<commit_message>
Apply presentation best practices: action titles and lead-with-conclusion script
Rewrite every slide title as a one-sentence conclusion with a small
section label above it, so the titles read as the full argument; open
each script page with that conclusion; shorten on-slide analysis text
to avoid duplicating narration. Add a study note on the principles
used (assertion-evidence, pyramid/SCQA, ghost-deck test, Mayer's
multimedia principles) with sources.

Co-Authored-By: Claude Opus 5.5 <noreply@anthropic.com>
Claude-Session: https://claude.ai/code/session_01GVqMkWurYUK1ig7fiBE8me
</commit_message>
<xml_diff>
--- a/Gracenote报告解读_课堂汇报.pptx
+++ b/Gracenote报告解读_课堂汇报.pptx
@@ -120,13 +120,13 @@
   <p:extLst>
     <p:ext uri="{521415D9-36F7-43E2-AB2F-B90AF26B5E84}">
       <p14:sectionLst xmlns:p14="http://schemas.microsoft.com/office/powerpoint/2010/main">
-        <p14:section name="开场" id="{6d2b9a57-c96a-ff0a-4dd6-c1b172ace300}">
+        <p14:section name="开场" id="{6d9f39e4-3985-8b7e-da85-a9c10d230e8f}">
           <p14:sldIdLst>
             <p14:sldId id="256"/>
             <p14:sldId id="257"/>
           </p14:sldIdLst>
         </p14:section>
-        <p14:section name="报告介绍" id="{de5f52f3-458a-d51f-cb1e-2a2f6de6e17c}">
+        <p14:section name="报告介绍" id="{b7582475-0380-d696-5d7c-b9b9ea37b213}">
           <p14:sldIdLst>
             <p14:sldId id="258"/>
             <p14:sldId id="259"/>
@@ -134,7 +134,7 @@
             <p14:sldId id="261"/>
           </p14:sldIdLst>
         </p14:section>
-        <p14:section name="方法评价" id="{18d7fba7-8f6c-a4f5-65a9-480f34b1b131}">
+        <p14:section name="方法评价" id="{62a34f20-8d61-e00a-eac1-c71f4a17625f}">
           <p14:sldIdLst>
             <p14:sldId id="262"/>
             <p14:sldId id="263"/>
@@ -143,12 +143,12 @@
             <p14:sldId id="266"/>
           </p14:sldIdLst>
         </p14:section>
-        <p14:section name="总结" id="{696348cc-a504-4ced-90e1-99cfee7af2eb}">
+        <p14:section name="总结" id="{325d7e52-5a4a-d9d7-0464-aaca59efa6c4}">
           <p14:sldIdLst>
             <p14:sldId id="267"/>
           </p14:sldIdLst>
         </p14:section>
-        <p14:section name="附录（备问）" id="{c592c07e-c550-a0de-8760-e7fac75f76fc}">
+        <p14:section name="附录（备问）" id="{e1cc1a14-9c81-94a3-3526-d664bd9b71bc}">
           <p14:sldIdLst>
             <p14:sldId id="268"/>
             <p14:sldId id="269"/>
@@ -1005,7 +1005,7 @@
           <a:p>
             <a:r>
               <a:rPr lang="en-US" dirty="0"/>
-              <a:t>【约 30 秒】维度三，调查时间。报告将皮尤 2025 年秋的 30% 与自身 2026 年初的 54% 对比，称使用“正在加速”。但两者分母不同：皮尤是全体青少年，同为 13 至 14 岁仅 24%。统一为使用者口径后，差距约 10 个百分点，不足以说明“加速”。</a:t>
+              <a:t>【约 25 秒】维度三，调查时间：两项调查分母不同，“加速”的结论不成立。报告将皮尤 2025 年秋的 30% 与自身 2026 年初的 54% 对比；但皮尤是全体青少年，同为 13 至 14 岁仅 24%。统一为使用者口径后，差距约 10 个百分点。</a:t>
             </a:r>
             <a:endParaRPr lang="en-US" dirty="0"/>
           </a:p>
@@ -1093,7 +1093,7 @@
           <a:p>
             <a:r>
               <a:rPr lang="en-US" dirty="0"/>
-              <a:t>【约 20 秒】维度四，研究方法。“检索困难导致退订”由四类数据支撑：退订意向、行业退订率、市场预测和 AI 测试。它们对象和性质各不相同，又无追踪或实验设计，只能提示可能相关，不能证明因果。</a:t>
+              <a:t>【约 20 秒】维度四，研究方法：四类异质数据不足以证明“检索困难导致退订”。这四类是退订意向、行业退订率、市场预测和 AI 测试，对象和性质各不相同，又无追踪或实验设计，只能提示可能相关。</a:t>
             </a:r>
             <a:endParaRPr lang="en-US" dirty="0"/>
           </a:p>
@@ -1181,7 +1181,7 @@
           <a:p>
             <a:r>
               <a:rPr lang="en-US" dirty="0"/>
-              <a:t>【约 25 秒】回到论证链：前两环方向成立，但只适用于 AI 用户；第三环口径混用、因果未证；第四环尚未检验。因此，报告可作为趋势参考，不宜作为精确估计或因果证据。最后提出一个问题：如何设计调查，才能检验“检索困难导致退订”？谢谢。</a:t>
+              <a:t>【约 30 秒】回到论证链：两环部分成立，两环证据不足。前两环只适用于 AI 用户；第三环口径混用、因果未证；第四环尚未检验。因此，报告可作为趋势参考，不宜作为精确估计或因果证据。最后提出一个问题：如何设计调查，才能检验“检索困难导致退订”？谢谢。</a:t>
             </a:r>
             <a:endParaRPr lang="en-US" dirty="0"/>
           </a:p>
@@ -1621,7 +1621,7 @@
           <a:p>
             <a:r>
               <a:rPr lang="en-US" dirty="0"/>
-              <a:t>【约 25 秒】报告主要依据两项线上问卷。调查一于 2026 年初进行，对象是 4003 名 13 至 79 岁的美国 AI 聊天机器人用户；调查二于 2025 年夏季进行，覆盖六国，每国 500 名流媒体用户。两项调查均未公开抽样框、加权方法和应答率。</a:t>
+              <a:t>【约 25 秒】报告的结论依赖两项线上问卷，且两者均未公开抽样框、加权方法和应答率。调查一于 2026 年初进行，对象是 4003 名 13 至 79 岁的美国 AI 聊天机器人用户；调查二于 2025 年夏季进行，覆盖六国，每国 500 名流媒体用户。</a:t>
             </a:r>
             <a:endParaRPr lang="en-US" dirty="0"/>
           </a:p>
@@ -1973,7 +1973,7 @@
           <a:p>
             <a:r>
               <a:rPr lang="en-US" dirty="0"/>
-              <a:t>【约 30 秒】维度一，调查对象。事实是，样本只包括 AI 聊天机器人用户，报告却表述为“美国人”。原因是线上样本以使用 AI 为筛选条件，抽样方式也未公开。因此，54% 和 75% 只能理解为 AI 用户中的比例，这与课上 Durex 网络调查的问题相同。</a:t>
+              <a:t>【约 25 秒】维度一，调查对象：样本仅为 AI 用户，结论却推及“美国人”。原因是线上样本以使用 AI 为筛选条件，抽样方式也未公开。因此，54% 和 75% 只能理解为 AI 用户中的比例，这与课上 Durex 网络调查的问题相同。</a:t>
             </a:r>
             <a:endParaRPr lang="en-US" dirty="0"/>
           </a:p>
@@ -2061,7 +2061,7 @@
           <a:p>
             <a:r>
               <a:rPr lang="en-US" dirty="0"/>
-              <a:t>【约 20 秒】维度二，研究总体。“平均 14 分钟”来自六国调查，是六国简单平均；美国受访者是 12 分钟，法国的 26 分钟拉高了均值。报告却把它放进描述美国收视的图表，会使读者高估美国用户的检索困难。</a:t>
+              <a:t>【约 20 秒】维度二，研究总体：“14 分钟”是六国均值，美国实为 12 分钟。它是六国简单平均，法国的 26 分钟拉高了均值；报告却把它放进描述美国收视的图表，会使读者高估美国用户的检索困难。</a:t>
             </a:r>
             <a:endParaRPr lang="en-US" dirty="0"/>
           </a:p>
@@ -2277,8 +2277,8 @@
         </p:nvSpPr>
         <p:spPr>
           <a:xfrm>
-            <a:off x="731520" y="502920"/>
-            <a:ext cx="10698480" cy="868680"/>
+            <a:off x="731520" y="594360"/>
+            <a:ext cx="10698480" cy="822960"/>
           </a:xfrm>
           <a:prstGeom prst="rect">
             <a:avLst/>
@@ -2291,7 +2291,7 @@
           <a:lstStyle>
             <a:lvl1pPr algn="l" indent="0" marL="0">
               <a:buNone/>
-              <a:defRPr lang="en-US" sz="3000" b="1" dirty="0">
+              <a:defRPr lang="en-US" sz="2800" b="1" dirty="0">
                 <a:solidFill>
                   <a:schemeClr val="bg1"/>
                 </a:solidFill>
@@ -2302,7 +2302,7 @@
             <a:pPr algn="l" indent="0" marL="0">
               <a:buNone/>
             </a:pPr>
-            <a:endParaRPr lang="en-US" sz="3000" dirty="0"/>
+            <a:endParaRPr lang="en-US" sz="2800" dirty="0"/>
           </a:p>
         </p:txBody>
       </p:sp>
@@ -2393,8 +2393,8 @@
         </p:nvSpPr>
         <p:spPr>
           <a:xfrm>
-            <a:off x="548640" y="365760"/>
-            <a:ext cx="7406640" cy="777240"/>
+            <a:off x="548640" y="502920"/>
+            <a:ext cx="7452360" cy="685800"/>
           </a:xfrm>
           <a:prstGeom prst="rect">
             <a:avLst/>
@@ -2407,7 +2407,7 @@
           <a:lstStyle>
             <a:lvl1pPr algn="l" indent="0" marL="0">
               <a:buNone/>
-              <a:defRPr lang="en-US" sz="2800" b="1" dirty="0">
+              <a:defRPr lang="en-US" sz="2600" b="1" dirty="0">
                 <a:solidFill>
                   <a:schemeClr val="tx2"/>
                 </a:solidFill>
@@ -2418,7 +2418,7 @@
             <a:pPr algn="l" indent="0" marL="0">
               <a:buNone/>
             </a:pPr>
-            <a:endParaRPr lang="en-US" sz="2800" dirty="0"/>
+            <a:endParaRPr lang="en-US" sz="2600" dirty="0"/>
           </a:p>
         </p:txBody>
       </p:sp>
@@ -3154,8 +3154,8 @@
         </p:nvSpPr>
         <p:spPr>
           <a:xfrm>
-            <a:off x="548640" y="365760"/>
-            <a:ext cx="7406640" cy="777240"/>
+            <a:off x="548640" y="502920"/>
+            <a:ext cx="7452360" cy="685800"/>
           </a:xfrm>
           <a:prstGeom prst="rect">
             <a:avLst/>
@@ -3171,20 +3171,56 @@
               <a:buNone/>
             </a:pPr>
             <a:r>
-              <a:rPr lang="en-US" sz="2800" b="1" dirty="0">
+              <a:rPr lang="en-US" sz="2600" b="1" dirty="0">
                 <a:solidFill>
                   <a:schemeClr val="tx2"/>
                 </a:solidFill>
               </a:rPr>
-              <a:t>维度三 · 调查时间：比较口径不一致</a:t>
-            </a:r>
-            <a:endParaRPr lang="en-US" sz="2800" dirty="0"/>
-          </a:p>
-        </p:txBody>
-      </p:sp>
-      <p:sp>
-        <p:nvSpPr>
-          <p:cNvPr id="3" name="进度1"/>
+              <a:t>两项调查分母不同，“加速”结论不成立</a:t>
+            </a:r>
+            <a:endParaRPr lang="en-US" sz="2600" dirty="0"/>
+          </a:p>
+        </p:txBody>
+      </p:sp>
+      <p:sp>
+        <p:nvSpPr>
+          <p:cNvPr id="3" name="章节标签"/>
+          <p:cNvSpPr txBox="1"/>
+          <p:nvPr/>
+        </p:nvSpPr>
+        <p:spPr>
+          <a:xfrm>
+            <a:off x="548640" y="256032"/>
+            <a:ext cx="7315200" cy="292608"/>
+          </a:xfrm>
+          <a:prstGeom prst="rect">
+            <a:avLst/>
+          </a:prstGeom>
+          <a:noFill/>
+          <a:ln/>
+        </p:spPr>
+        <p:txBody>
+          <a:bodyPr wrap="square" lIns="0" tIns="0" rIns="0" bIns="0" rtlCol="0" anchor="ctr"/>
+          <a:lstStyle/>
+          <a:p>
+            <a:pPr indent="0" marL="0">
+              <a:buNone/>
+            </a:pPr>
+            <a:r>
+              <a:rPr lang="en-US" sz="1200" b="1" dirty="0">
+                <a:solidFill>
+                  <a:schemeClr val="accent1"/>
+                </a:solidFill>
+              </a:rPr>
+              <a:t>四、方法评价 · 维度三  调查时间</a:t>
+            </a:r>
+            <a:endParaRPr lang="en-US" sz="1200" dirty="0"/>
+          </a:p>
+        </p:txBody>
+      </p:sp>
+      <p:sp>
+        <p:nvSpPr>
+          <p:cNvPr id="4" name="进度1"/>
           <p:cNvSpPr/>
           <p:nvPr/>
         </p:nvSpPr>
@@ -3211,7 +3247,7 @@
       </p:sp>
       <p:sp>
         <p:nvSpPr>
-          <p:cNvPr id="4" name="进度文字1"/>
+          <p:cNvPr id="5" name="进度文字1"/>
           <p:cNvSpPr txBox="1"/>
           <p:nvPr/>
         </p:nvSpPr>
@@ -3247,7 +3283,7 @@
       </p:sp>
       <p:sp>
         <p:nvSpPr>
-          <p:cNvPr id="5" name="进度2"/>
+          <p:cNvPr id="6" name="进度2"/>
           <p:cNvSpPr/>
           <p:nvPr/>
         </p:nvSpPr>
@@ -3274,7 +3310,7 @@
       </p:sp>
       <p:sp>
         <p:nvSpPr>
-          <p:cNvPr id="6" name="进度文字2"/>
+          <p:cNvPr id="7" name="进度文字2"/>
           <p:cNvSpPr txBox="1"/>
           <p:nvPr/>
         </p:nvSpPr>
@@ -3310,7 +3346,7 @@
       </p:sp>
       <p:sp>
         <p:nvSpPr>
-          <p:cNvPr id="7" name="进度3"/>
+          <p:cNvPr id="8" name="进度3"/>
           <p:cNvSpPr/>
           <p:nvPr/>
         </p:nvSpPr>
@@ -3337,7 +3373,7 @@
       </p:sp>
       <p:sp>
         <p:nvSpPr>
-          <p:cNvPr id="8" name="进度文字3"/>
+          <p:cNvPr id="9" name="进度文字3"/>
           <p:cNvSpPr txBox="1"/>
           <p:nvPr/>
         </p:nvSpPr>
@@ -3373,7 +3409,7 @@
       </p:sp>
       <p:sp>
         <p:nvSpPr>
-          <p:cNvPr id="9" name="进度4"/>
+          <p:cNvPr id="10" name="进度4"/>
           <p:cNvSpPr/>
           <p:nvPr/>
         </p:nvSpPr>
@@ -3400,7 +3436,7 @@
       </p:sp>
       <p:sp>
         <p:nvSpPr>
-          <p:cNvPr id="10" name="进度文字4"/>
+          <p:cNvPr id="11" name="进度文字4"/>
           <p:cNvSpPr txBox="1"/>
           <p:nvPr/>
         </p:nvSpPr>
@@ -3436,7 +3472,7 @@
       </p:sp>
       <p:sp>
         <p:nvSpPr>
-          <p:cNvPr id="11" name="进度5"/>
+          <p:cNvPr id="12" name="进度5"/>
           <p:cNvSpPr/>
           <p:nvPr/>
         </p:nvSpPr>
@@ -3463,7 +3499,7 @@
       </p:sp>
       <p:sp>
         <p:nvSpPr>
-          <p:cNvPr id="12" name="进度文字5"/>
+          <p:cNvPr id="13" name="进度文字5"/>
           <p:cNvSpPr txBox="1"/>
           <p:nvPr/>
         </p:nvSpPr>
@@ -3499,7 +3535,7 @@
       </p:sp>
       <p:sp>
         <p:nvSpPr>
-          <p:cNvPr id="13" name="对比卡1"/>
+          <p:cNvPr id="14" name="对比卡1"/>
           <p:cNvSpPr/>
           <p:nvPr/>
         </p:nvSpPr>
@@ -3526,7 +3562,7 @@
       </p:sp>
       <p:sp>
         <p:nvSpPr>
-          <p:cNvPr id="14" name="对比机构1"/>
+          <p:cNvPr id="15" name="对比机构1"/>
           <p:cNvSpPr txBox="1"/>
           <p:nvPr/>
         </p:nvSpPr>
@@ -3562,7 +3598,7 @@
       </p:sp>
       <p:sp>
         <p:nvSpPr>
-          <p:cNvPr id="15" name="对比数字1"/>
+          <p:cNvPr id="16" name="对比数字1"/>
           <p:cNvSpPr txBox="1"/>
           <p:nvPr/>
         </p:nvSpPr>
@@ -3612,7 +3648,7 @@
       </p:sp>
       <p:sp>
         <p:nvSpPr>
-          <p:cNvPr id="16" name="对比说明1"/>
+          <p:cNvPr id="17" name="对比说明1"/>
           <p:cNvSpPr txBox="1"/>
           <p:nvPr/>
         </p:nvSpPr>
@@ -3648,7 +3684,7 @@
       </p:sp>
       <p:sp>
         <p:nvSpPr>
-          <p:cNvPr id="17" name="对比卡2"/>
+          <p:cNvPr id="18" name="对比卡2"/>
           <p:cNvSpPr/>
           <p:nvPr/>
         </p:nvSpPr>
@@ -3675,7 +3711,7 @@
       </p:sp>
       <p:sp>
         <p:nvSpPr>
-          <p:cNvPr id="18" name="对比机构2"/>
+          <p:cNvPr id="19" name="对比机构2"/>
           <p:cNvSpPr txBox="1"/>
           <p:nvPr/>
         </p:nvSpPr>
@@ -3711,7 +3747,7 @@
       </p:sp>
       <p:sp>
         <p:nvSpPr>
-          <p:cNvPr id="19" name="对比数字2"/>
+          <p:cNvPr id="20" name="对比数字2"/>
           <p:cNvSpPr txBox="1"/>
           <p:nvPr/>
         </p:nvSpPr>
@@ -3761,7 +3797,7 @@
       </p:sp>
       <p:sp>
         <p:nvSpPr>
-          <p:cNvPr id="20" name="对比说明2"/>
+          <p:cNvPr id="21" name="对比说明2"/>
           <p:cNvSpPr txBox="1"/>
           <p:nvPr/>
         </p:nvSpPr>
@@ -3797,7 +3833,7 @@
       </p:sp>
       <p:sp>
         <p:nvSpPr>
-          <p:cNvPr id="21" name="事实卡"/>
+          <p:cNvPr id="22" name="事实卡"/>
           <p:cNvSpPr/>
           <p:nvPr/>
         </p:nvSpPr>
@@ -3824,7 +3860,7 @@
       </p:sp>
       <p:sp>
         <p:nvSpPr>
-          <p:cNvPr id="22" name="事实标签"/>
+          <p:cNvPr id="23" name="事实标签"/>
           <p:cNvSpPr/>
           <p:nvPr/>
         </p:nvSpPr>
@@ -3851,7 +3887,7 @@
       </p:sp>
       <p:sp>
         <p:nvSpPr>
-          <p:cNvPr id="23" name="事实标签文字"/>
+          <p:cNvPr id="24" name="事实标签文字"/>
           <p:cNvSpPr txBox="1"/>
           <p:nvPr/>
         </p:nvSpPr>
@@ -3887,7 +3923,7 @@
       </p:sp>
       <p:sp>
         <p:nvSpPr>
-          <p:cNvPr id="24" name="事实内容"/>
+          <p:cNvPr id="25" name="事实内容"/>
           <p:cNvSpPr txBox="1"/>
           <p:nvPr/>
         </p:nvSpPr>
@@ -3915,7 +3951,7 @@
                   <a:schemeClr val="tx1"/>
                 </a:solidFill>
               </a:rPr>
-              <a:t>报告将皮尤 2025 年秋季的 30% 与自身 2026 年初的 54% 对比，认为使用频率“正在加速”。</a:t>
+              <a:t>以皮尤 2025 年秋的 30% 对比本报告 2026 年初的 54%，称使用“正在加速”。</a:t>
             </a:r>
             <a:endParaRPr lang="en-US" sz="1400" dirty="0"/>
           </a:p>
@@ -3923,7 +3959,7 @@
       </p:sp>
       <p:sp>
         <p:nvSpPr>
-          <p:cNvPr id="25" name="下箭头"/>
+          <p:cNvPr id="26" name="下箭头"/>
           <p:cNvSpPr txBox="1"/>
           <p:nvPr/>
         </p:nvSpPr>
@@ -3959,7 +3995,7 @@
       </p:sp>
       <p:sp>
         <p:nvSpPr>
-          <p:cNvPr id="26" name="原因卡"/>
+          <p:cNvPr id="27" name="原因卡"/>
           <p:cNvSpPr/>
           <p:nvPr/>
         </p:nvSpPr>
@@ -3986,7 +4022,7 @@
       </p:sp>
       <p:sp>
         <p:nvSpPr>
-          <p:cNvPr id="27" name="原因标签"/>
+          <p:cNvPr id="28" name="原因标签"/>
           <p:cNvSpPr/>
           <p:nvPr/>
         </p:nvSpPr>
@@ -4013,7 +4049,7 @@
       </p:sp>
       <p:sp>
         <p:nvSpPr>
-          <p:cNvPr id="28" name="原因标签文字"/>
+          <p:cNvPr id="29" name="原因标签文字"/>
           <p:cNvSpPr txBox="1"/>
           <p:nvPr/>
         </p:nvSpPr>
@@ -4049,7 +4085,7 @@
       </p:sp>
       <p:sp>
         <p:nvSpPr>
-          <p:cNvPr id="29" name="原因内容"/>
+          <p:cNvPr id="30" name="原因内容"/>
           <p:cNvSpPr txBox="1"/>
           <p:nvPr/>
         </p:nvSpPr>
@@ -4077,7 +4113,7 @@
                   <a:schemeClr val="tx1"/>
                 </a:solidFill>
               </a:rPr>
-              <a:t>两项调查的分母不同（全体青少年 vs AI 用户），抽样方法与年龄范围也不同；同为 13–14 岁，皮尤仅为 24%。</a:t>
+              <a:t>分母不同：皮尤为全体青少年（13–14 岁仅 24%），本报告仅含 AI 用户。</a:t>
             </a:r>
             <a:endParaRPr lang="en-US" sz="1400" dirty="0"/>
           </a:p>
@@ -4085,7 +4121,7 @@
       </p:sp>
       <p:sp>
         <p:nvSpPr>
-          <p:cNvPr id="30" name="下箭头"/>
+          <p:cNvPr id="31" name="下箭头"/>
           <p:cNvSpPr txBox="1"/>
           <p:nvPr/>
         </p:nvSpPr>
@@ -4121,7 +4157,7 @@
       </p:sp>
       <p:sp>
         <p:nvSpPr>
-          <p:cNvPr id="31" name="影响卡"/>
+          <p:cNvPr id="32" name="影响卡"/>
           <p:cNvSpPr/>
           <p:nvPr/>
         </p:nvSpPr>
@@ -4148,7 +4184,7 @@
       </p:sp>
       <p:sp>
         <p:nvSpPr>
-          <p:cNvPr id="32" name="影响标签"/>
+          <p:cNvPr id="33" name="影响标签"/>
           <p:cNvSpPr/>
           <p:nvPr/>
         </p:nvSpPr>
@@ -4175,7 +4211,7 @@
       </p:sp>
       <p:sp>
         <p:nvSpPr>
-          <p:cNvPr id="33" name="影响标签文字"/>
+          <p:cNvPr id="34" name="影响标签文字"/>
           <p:cNvSpPr txBox="1"/>
           <p:nvPr/>
         </p:nvSpPr>
@@ -4211,7 +4247,7 @@
       </p:sp>
       <p:sp>
         <p:nvSpPr>
-          <p:cNvPr id="34" name="影响内容"/>
+          <p:cNvPr id="35" name="影响内容"/>
           <p:cNvSpPr txBox="1"/>
           <p:nvPr/>
         </p:nvSpPr>
@@ -4239,7 +4275,7 @@
                   <a:schemeClr val="tx1"/>
                 </a:solidFill>
               </a:rPr>
-              <a:t>统一为“使用者”口径后，皮尤为 44%，差距约 10 个百分点，不足以推断使用频率上升。</a:t>
+              <a:t>统一为使用者口径后皮尤为 44%，差距约 10 个百分点，不足以推断“加速”。</a:t>
             </a:r>
             <a:endParaRPr lang="en-US" sz="1400" dirty="0"/>
           </a:p>
@@ -4247,7 +4283,7 @@
       </p:sp>
       <p:sp>
         <p:nvSpPr>
-          <p:cNvPr id="35" name="来源说明"/>
+          <p:cNvPr id="36" name="来源说明"/>
           <p:cNvSpPr txBox="1"/>
           <p:nvPr/>
         </p:nvSpPr>
@@ -4361,8 +4397,8 @@
         </p:nvSpPr>
         <p:spPr>
           <a:xfrm>
-            <a:off x="548640" y="365760"/>
-            <a:ext cx="7406640" cy="777240"/>
+            <a:off x="548640" y="502920"/>
+            <a:ext cx="7452360" cy="685800"/>
           </a:xfrm>
           <a:prstGeom prst="rect">
             <a:avLst/>
@@ -4378,20 +4414,56 @@
               <a:buNone/>
             </a:pPr>
             <a:r>
-              <a:rPr lang="en-US" sz="2800" b="1" dirty="0">
+              <a:rPr lang="en-US" sz="2600" b="1" dirty="0">
                 <a:solidFill>
                   <a:schemeClr val="tx2"/>
                 </a:solidFill>
               </a:rPr>
-              <a:t>维度四 · 研究方法：因果推断依据不足</a:t>
-            </a:r>
-            <a:endParaRPr lang="en-US" sz="2800" dirty="0"/>
-          </a:p>
-        </p:txBody>
-      </p:sp>
-      <p:sp>
-        <p:nvSpPr>
-          <p:cNvPr id="3" name="进度1"/>
+              <a:t>四类异质数据不足以证明“检索困难导致退订”</a:t>
+            </a:r>
+            <a:endParaRPr lang="en-US" sz="2600" dirty="0"/>
+          </a:p>
+        </p:txBody>
+      </p:sp>
+      <p:sp>
+        <p:nvSpPr>
+          <p:cNvPr id="3" name="章节标签"/>
+          <p:cNvSpPr txBox="1"/>
+          <p:nvPr/>
+        </p:nvSpPr>
+        <p:spPr>
+          <a:xfrm>
+            <a:off x="548640" y="256032"/>
+            <a:ext cx="7315200" cy="292608"/>
+          </a:xfrm>
+          <a:prstGeom prst="rect">
+            <a:avLst/>
+          </a:prstGeom>
+          <a:noFill/>
+          <a:ln/>
+        </p:spPr>
+        <p:txBody>
+          <a:bodyPr wrap="square" lIns="0" tIns="0" rIns="0" bIns="0" rtlCol="0" anchor="ctr"/>
+          <a:lstStyle/>
+          <a:p>
+            <a:pPr indent="0" marL="0">
+              <a:buNone/>
+            </a:pPr>
+            <a:r>
+              <a:rPr lang="en-US" sz="1200" b="1" dirty="0">
+                <a:solidFill>
+                  <a:schemeClr val="accent1"/>
+                </a:solidFill>
+              </a:rPr>
+              <a:t>四、方法评价 · 维度四  研究方法</a:t>
+            </a:r>
+            <a:endParaRPr lang="en-US" sz="1200" dirty="0"/>
+          </a:p>
+        </p:txBody>
+      </p:sp>
+      <p:sp>
+        <p:nvSpPr>
+          <p:cNvPr id="4" name="进度1"/>
           <p:cNvSpPr/>
           <p:nvPr/>
         </p:nvSpPr>
@@ -4418,7 +4490,7 @@
       </p:sp>
       <p:sp>
         <p:nvSpPr>
-          <p:cNvPr id="4" name="进度文字1"/>
+          <p:cNvPr id="5" name="进度文字1"/>
           <p:cNvSpPr txBox="1"/>
           <p:nvPr/>
         </p:nvSpPr>
@@ -4454,7 +4526,7 @@
       </p:sp>
       <p:sp>
         <p:nvSpPr>
-          <p:cNvPr id="5" name="进度2"/>
+          <p:cNvPr id="6" name="进度2"/>
           <p:cNvSpPr/>
           <p:nvPr/>
         </p:nvSpPr>
@@ -4481,7 +4553,7 @@
       </p:sp>
       <p:sp>
         <p:nvSpPr>
-          <p:cNvPr id="6" name="进度文字2"/>
+          <p:cNvPr id="7" name="进度文字2"/>
           <p:cNvSpPr txBox="1"/>
           <p:nvPr/>
         </p:nvSpPr>
@@ -4517,7 +4589,7 @@
       </p:sp>
       <p:sp>
         <p:nvSpPr>
-          <p:cNvPr id="7" name="进度3"/>
+          <p:cNvPr id="8" name="进度3"/>
           <p:cNvSpPr/>
           <p:nvPr/>
         </p:nvSpPr>
@@ -4544,7 +4616,7 @@
       </p:sp>
       <p:sp>
         <p:nvSpPr>
-          <p:cNvPr id="8" name="进度文字3"/>
+          <p:cNvPr id="9" name="进度文字3"/>
           <p:cNvSpPr txBox="1"/>
           <p:nvPr/>
         </p:nvSpPr>
@@ -4580,7 +4652,7 @@
       </p:sp>
       <p:sp>
         <p:nvSpPr>
-          <p:cNvPr id="9" name="进度4"/>
+          <p:cNvPr id="10" name="进度4"/>
           <p:cNvSpPr/>
           <p:nvPr/>
         </p:nvSpPr>
@@ -4607,7 +4679,7 @@
       </p:sp>
       <p:sp>
         <p:nvSpPr>
-          <p:cNvPr id="10" name="进度文字4"/>
+          <p:cNvPr id="11" name="进度文字4"/>
           <p:cNvSpPr txBox="1"/>
           <p:nvPr/>
         </p:nvSpPr>
@@ -4643,7 +4715,7 @@
       </p:sp>
       <p:sp>
         <p:nvSpPr>
-          <p:cNvPr id="11" name="进度5"/>
+          <p:cNvPr id="12" name="进度5"/>
           <p:cNvSpPr/>
           <p:nvPr/>
         </p:nvSpPr>
@@ -4670,7 +4742,7 @@
       </p:sp>
       <p:sp>
         <p:nvSpPr>
-          <p:cNvPr id="12" name="进度文字5"/>
+          <p:cNvPr id="13" name="进度文字5"/>
           <p:cNvSpPr txBox="1"/>
           <p:nvPr/>
         </p:nvSpPr>
@@ -4706,7 +4778,7 @@
       </p:sp>
       <p:sp>
         <p:nvSpPr>
-          <p:cNvPr id="13" name="数据类型卡1"/>
+          <p:cNvPr id="14" name="数据类型卡1"/>
           <p:cNvSpPr/>
           <p:nvPr/>
         </p:nvSpPr>
@@ -4733,7 +4805,7 @@
       </p:sp>
       <p:sp>
         <p:nvSpPr>
-          <p:cNvPr id="14" name="数据类型1"/>
+          <p:cNvPr id="15" name="数据类型1"/>
           <p:cNvSpPr txBox="1"/>
           <p:nvPr/>
         </p:nvSpPr>
@@ -4769,7 +4841,7 @@
       </p:sp>
       <p:sp>
         <p:nvSpPr>
-          <p:cNvPr id="15" name="数据类型数字1"/>
+          <p:cNvPr id="16" name="数据类型数字1"/>
           <p:cNvSpPr txBox="1"/>
           <p:nvPr/>
         </p:nvSpPr>
@@ -4805,7 +4877,7 @@
       </p:sp>
       <p:sp>
         <p:nvSpPr>
-          <p:cNvPr id="16" name="数据类型说明1"/>
+          <p:cNvPr id="17" name="数据类型说明1"/>
           <p:cNvSpPr txBox="1"/>
           <p:nvPr/>
         </p:nvSpPr>
@@ -4841,7 +4913,7 @@
       </p:sp>
       <p:sp>
         <p:nvSpPr>
-          <p:cNvPr id="17" name="数据类型卡2"/>
+          <p:cNvPr id="18" name="数据类型卡2"/>
           <p:cNvSpPr/>
           <p:nvPr/>
         </p:nvSpPr>
@@ -4868,7 +4940,7 @@
       </p:sp>
       <p:sp>
         <p:nvSpPr>
-          <p:cNvPr id="18" name="数据类型2"/>
+          <p:cNvPr id="19" name="数据类型2"/>
           <p:cNvSpPr txBox="1"/>
           <p:nvPr/>
         </p:nvSpPr>
@@ -4904,7 +4976,7 @@
       </p:sp>
       <p:sp>
         <p:nvSpPr>
-          <p:cNvPr id="19" name="数据类型数字2"/>
+          <p:cNvPr id="20" name="数据类型数字2"/>
           <p:cNvSpPr txBox="1"/>
           <p:nvPr/>
         </p:nvSpPr>
@@ -4940,7 +5012,7 @@
       </p:sp>
       <p:sp>
         <p:nvSpPr>
-          <p:cNvPr id="20" name="数据类型说明2"/>
+          <p:cNvPr id="21" name="数据类型说明2"/>
           <p:cNvSpPr txBox="1"/>
           <p:nvPr/>
         </p:nvSpPr>
@@ -4976,7 +5048,7 @@
       </p:sp>
       <p:sp>
         <p:nvSpPr>
-          <p:cNvPr id="21" name="数据类型卡3"/>
+          <p:cNvPr id="22" name="数据类型卡3"/>
           <p:cNvSpPr/>
           <p:nvPr/>
         </p:nvSpPr>
@@ -5003,7 +5075,7 @@
       </p:sp>
       <p:sp>
         <p:nvSpPr>
-          <p:cNvPr id="22" name="数据类型3"/>
+          <p:cNvPr id="23" name="数据类型3"/>
           <p:cNvSpPr txBox="1"/>
           <p:nvPr/>
         </p:nvSpPr>
@@ -5039,7 +5111,7 @@
       </p:sp>
       <p:sp>
         <p:nvSpPr>
-          <p:cNvPr id="23" name="数据类型数字3"/>
+          <p:cNvPr id="24" name="数据类型数字3"/>
           <p:cNvSpPr txBox="1"/>
           <p:nvPr/>
         </p:nvSpPr>
@@ -5075,7 +5147,7 @@
       </p:sp>
       <p:sp>
         <p:nvSpPr>
-          <p:cNvPr id="24" name="数据类型说明3"/>
+          <p:cNvPr id="25" name="数据类型说明3"/>
           <p:cNvSpPr txBox="1"/>
           <p:nvPr/>
         </p:nvSpPr>
@@ -5111,7 +5183,7 @@
       </p:sp>
       <p:sp>
         <p:nvSpPr>
-          <p:cNvPr id="25" name="数据类型卡4"/>
+          <p:cNvPr id="26" name="数据类型卡4"/>
           <p:cNvSpPr/>
           <p:nvPr/>
         </p:nvSpPr>
@@ -5138,7 +5210,7 @@
       </p:sp>
       <p:sp>
         <p:nvSpPr>
-          <p:cNvPr id="26" name="数据类型4"/>
+          <p:cNvPr id="27" name="数据类型4"/>
           <p:cNvSpPr txBox="1"/>
           <p:nvPr/>
         </p:nvSpPr>
@@ -5174,7 +5246,7 @@
       </p:sp>
       <p:sp>
         <p:nvSpPr>
-          <p:cNvPr id="27" name="数据类型数字4"/>
+          <p:cNvPr id="28" name="数据类型数字4"/>
           <p:cNvSpPr txBox="1"/>
           <p:nvPr/>
         </p:nvSpPr>
@@ -5210,7 +5282,7 @@
       </p:sp>
       <p:sp>
         <p:nvSpPr>
-          <p:cNvPr id="28" name="数据类型说明4"/>
+          <p:cNvPr id="29" name="数据类型说明4"/>
           <p:cNvSpPr txBox="1"/>
           <p:nvPr/>
         </p:nvSpPr>
@@ -5246,7 +5318,7 @@
       </p:sp>
       <p:sp>
         <p:nvSpPr>
-          <p:cNvPr id="29" name="事实卡"/>
+          <p:cNvPr id="30" name="事实卡"/>
           <p:cNvSpPr/>
           <p:nvPr/>
         </p:nvSpPr>
@@ -5273,7 +5345,7 @@
       </p:sp>
       <p:sp>
         <p:nvSpPr>
-          <p:cNvPr id="30" name="事实标签"/>
+          <p:cNvPr id="31" name="事实标签"/>
           <p:cNvSpPr/>
           <p:nvPr/>
         </p:nvSpPr>
@@ -5300,7 +5372,7 @@
       </p:sp>
       <p:sp>
         <p:nvSpPr>
-          <p:cNvPr id="31" name="事实标签文字"/>
+          <p:cNvPr id="32" name="事实标签文字"/>
           <p:cNvSpPr txBox="1"/>
           <p:nvPr/>
         </p:nvSpPr>
@@ -5336,7 +5408,7 @@
       </p:sp>
       <p:sp>
         <p:nvSpPr>
-          <p:cNvPr id="32" name="事实内容"/>
+          <p:cNvPr id="33" name="事实内容"/>
           <p:cNvSpPr txBox="1"/>
           <p:nvPr/>
         </p:nvSpPr>
@@ -5364,7 +5436,7 @@
                   <a:schemeClr val="tx1"/>
                 </a:solidFill>
               </a:rPr>
-              <a:t>“检索困难导致退订”由四类数据支撑：问卷中的退订意向、行业退订率、市场预测与 AI 测试。</a:t>
+              <a:t>“检索困难导致退订”由意向、行为、预测、测试四类数据支撑。</a:t>
             </a:r>
             <a:endParaRPr lang="en-US" sz="1400" dirty="0"/>
           </a:p>
@@ -5372,7 +5444,7 @@
       </p:sp>
       <p:sp>
         <p:nvSpPr>
-          <p:cNvPr id="33" name="下箭头"/>
+          <p:cNvPr id="34" name="下箭头"/>
           <p:cNvSpPr txBox="1"/>
           <p:nvPr/>
         </p:nvSpPr>
@@ -5408,7 +5480,7 @@
       </p:sp>
       <p:sp>
         <p:nvSpPr>
-          <p:cNvPr id="34" name="原因卡"/>
+          <p:cNvPr id="35" name="原因卡"/>
           <p:cNvSpPr/>
           <p:nvPr/>
         </p:nvSpPr>
@@ -5435,7 +5507,7 @@
       </p:sp>
       <p:sp>
         <p:nvSpPr>
-          <p:cNvPr id="35" name="原因标签"/>
+          <p:cNvPr id="36" name="原因标签"/>
           <p:cNvSpPr/>
           <p:nvPr/>
         </p:nvSpPr>
@@ -5462,7 +5534,7 @@
       </p:sp>
       <p:sp>
         <p:nvSpPr>
-          <p:cNvPr id="36" name="原因标签文字"/>
+          <p:cNvPr id="37" name="原因标签文字"/>
           <p:cNvSpPr txBox="1"/>
           <p:nvPr/>
         </p:nvSpPr>
@@ -5498,7 +5570,7 @@
       </p:sp>
       <p:sp>
         <p:nvSpPr>
-          <p:cNvPr id="37" name="原因内容"/>
+          <p:cNvPr id="38" name="原因内容"/>
           <p:cNvSpPr txBox="1"/>
           <p:nvPr/>
         </p:nvSpPr>
@@ -5526,7 +5598,7 @@
                   <a:schemeClr val="tx1"/>
                 </a:solidFill>
               </a:rPr>
-              <a:t>四类数据的对象、国家与性质各不相同（意向≠行为，预测≠测量），且缺乏追踪设计或实验设计。</a:t>
+              <a:t>四类数据的对象、国家与性质不同，且缺乏追踪设计或实验设计。</a:t>
             </a:r>
             <a:endParaRPr lang="en-US" sz="1400" dirty="0"/>
           </a:p>
@@ -5534,7 +5606,7 @@
       </p:sp>
       <p:sp>
         <p:nvSpPr>
-          <p:cNvPr id="38" name="下箭头"/>
+          <p:cNvPr id="39" name="下箭头"/>
           <p:cNvSpPr txBox="1"/>
           <p:nvPr/>
         </p:nvSpPr>
@@ -5570,7 +5642,7 @@
       </p:sp>
       <p:sp>
         <p:nvSpPr>
-          <p:cNvPr id="39" name="影响卡"/>
+          <p:cNvPr id="40" name="影响卡"/>
           <p:cNvSpPr/>
           <p:nvPr/>
         </p:nvSpPr>
@@ -5597,7 +5669,7 @@
       </p:sp>
       <p:sp>
         <p:nvSpPr>
-          <p:cNvPr id="40" name="影响标签"/>
+          <p:cNvPr id="41" name="影响标签"/>
           <p:cNvSpPr/>
           <p:nvPr/>
         </p:nvSpPr>
@@ -5624,7 +5696,7 @@
       </p:sp>
       <p:sp>
         <p:nvSpPr>
-          <p:cNvPr id="41" name="影响标签文字"/>
+          <p:cNvPr id="42" name="影响标签文字"/>
           <p:cNvSpPr txBox="1"/>
           <p:nvPr/>
         </p:nvSpPr>
@@ -5660,7 +5732,7 @@
       </p:sp>
       <p:sp>
         <p:nvSpPr>
-          <p:cNvPr id="42" name="影响内容"/>
+          <p:cNvPr id="43" name="影响内容"/>
           <p:cNvSpPr txBox="1"/>
           <p:nvPr/>
         </p:nvSpPr>
@@ -5688,7 +5760,7 @@
                   <a:schemeClr val="tx1"/>
                 </a:solidFill>
               </a:rPr>
-              <a:t>只能提示二者可能相关，不能证明因果；报告方案（AI 接入行业数据）亦未经检验。</a:t>
+              <a:t>只能提示相关，不能证明因果；报告方案（AI 接入行业数据）亦未经检验。</a:t>
             </a:r>
             <a:endParaRPr lang="en-US" sz="1400" dirty="0"/>
           </a:p>
@@ -5696,7 +5768,7 @@
       </p:sp>
       <p:sp>
         <p:nvSpPr>
-          <p:cNvPr id="43" name="来源说明"/>
+          <p:cNvPr id="44" name="来源说明"/>
           <p:cNvSpPr txBox="1"/>
           <p:nvPr/>
         </p:nvSpPr>
@@ -5810,8 +5882,8 @@
         </p:nvSpPr>
         <p:spPr>
           <a:xfrm>
-            <a:off x="731520" y="502920"/>
-            <a:ext cx="10698480" cy="868680"/>
+            <a:off x="731520" y="594360"/>
+            <a:ext cx="10698480" cy="822960"/>
           </a:xfrm>
           <a:prstGeom prst="rect">
             <a:avLst/>
@@ -5827,20 +5899,56 @@
               <a:buNone/>
             </a:pPr>
             <a:r>
-              <a:rPr lang="en-US" sz="3000" b="1" dirty="0">
+              <a:rPr lang="en-US" sz="2800" b="1" dirty="0">
                 <a:solidFill>
                   <a:schemeClr val="bg1"/>
                 </a:solidFill>
               </a:rPr>
-              <a:t>五、总结与启示：逐环判断</a:t>
-            </a:r>
-            <a:endParaRPr lang="en-US" sz="3000" dirty="0"/>
-          </a:p>
-        </p:txBody>
-      </p:sp>
-      <p:sp>
-        <p:nvSpPr>
-          <p:cNvPr id="3" name="判断行1"/>
+              <a:t>两环部分成立、两环证据不足：结论应限于 AI 用户</a:t>
+            </a:r>
+            <a:endParaRPr lang="en-US" sz="2800" dirty="0"/>
+          </a:p>
+        </p:txBody>
+      </p:sp>
+      <p:sp>
+        <p:nvSpPr>
+          <p:cNvPr id="3" name="章节标签"/>
+          <p:cNvSpPr txBox="1"/>
+          <p:nvPr/>
+        </p:nvSpPr>
+        <p:spPr>
+          <a:xfrm>
+            <a:off x="731520" y="320040"/>
+            <a:ext cx="7315200" cy="292608"/>
+          </a:xfrm>
+          <a:prstGeom prst="rect">
+            <a:avLst/>
+          </a:prstGeom>
+          <a:noFill/>
+          <a:ln/>
+        </p:spPr>
+        <p:txBody>
+          <a:bodyPr wrap="square" lIns="0" tIns="0" rIns="0" bIns="0" rtlCol="0" anchor="ctr"/>
+          <a:lstStyle/>
+          <a:p>
+            <a:pPr indent="0" marL="0">
+              <a:buNone/>
+            </a:pPr>
+            <a:r>
+              <a:rPr lang="en-US" sz="1200" b="1" dirty="0">
+                <a:solidFill>
+                  <a:schemeClr val="accent4"/>
+                </a:solidFill>
+              </a:rPr>
+              <a:t>五、总结与启示</a:t>
+            </a:r>
+            <a:endParaRPr lang="en-US" sz="1200" dirty="0"/>
+          </a:p>
+        </p:txBody>
+      </p:sp>
+      <p:sp>
+        <p:nvSpPr>
+          <p:cNvPr id="4" name="判断行1"/>
           <p:cNvSpPr/>
           <p:nvPr/>
         </p:nvSpPr>
@@ -5867,7 +5975,7 @@
       </p:sp>
       <p:sp>
         <p:nvSpPr>
-          <p:cNvPr id="4" name="判断环节1"/>
+          <p:cNvPr id="5" name="判断环节1"/>
           <p:cNvSpPr txBox="1"/>
           <p:nvPr/>
         </p:nvSpPr>
@@ -5903,7 +6011,7 @@
       </p:sp>
       <p:sp>
         <p:nvSpPr>
-          <p:cNvPr id="5" name="判断说明1"/>
+          <p:cNvPr id="6" name="判断说明1"/>
           <p:cNvSpPr txBox="1"/>
           <p:nvPr/>
         </p:nvSpPr>
@@ -5939,7 +6047,7 @@
       </p:sp>
       <p:sp>
         <p:nvSpPr>
-          <p:cNvPr id="6" name="判断标签1"/>
+          <p:cNvPr id="7" name="判断标签1"/>
           <p:cNvSpPr/>
           <p:nvPr/>
         </p:nvSpPr>
@@ -5966,7 +6074,7 @@
       </p:sp>
       <p:sp>
         <p:nvSpPr>
-          <p:cNvPr id="7" name="判断标签文字1"/>
+          <p:cNvPr id="8" name="判断标签文字1"/>
           <p:cNvSpPr txBox="1"/>
           <p:nvPr/>
         </p:nvSpPr>
@@ -6002,7 +6110,7 @@
       </p:sp>
       <p:sp>
         <p:nvSpPr>
-          <p:cNvPr id="8" name="判断行2"/>
+          <p:cNvPr id="9" name="判断行2"/>
           <p:cNvSpPr/>
           <p:nvPr/>
         </p:nvSpPr>
@@ -6029,7 +6137,7 @@
       </p:sp>
       <p:sp>
         <p:nvSpPr>
-          <p:cNvPr id="9" name="判断环节2"/>
+          <p:cNvPr id="10" name="判断环节2"/>
           <p:cNvSpPr txBox="1"/>
           <p:nvPr/>
         </p:nvSpPr>
@@ -6065,7 +6173,7 @@
       </p:sp>
       <p:sp>
         <p:nvSpPr>
-          <p:cNvPr id="10" name="判断说明2"/>
+          <p:cNvPr id="11" name="判断说明2"/>
           <p:cNvSpPr txBox="1"/>
           <p:nvPr/>
         </p:nvSpPr>
@@ -6101,7 +6209,7 @@
       </p:sp>
       <p:sp>
         <p:nvSpPr>
-          <p:cNvPr id="11" name="判断标签2"/>
+          <p:cNvPr id="12" name="判断标签2"/>
           <p:cNvSpPr/>
           <p:nvPr/>
         </p:nvSpPr>
@@ -6128,7 +6236,7 @@
       </p:sp>
       <p:sp>
         <p:nvSpPr>
-          <p:cNvPr id="12" name="判断标签文字2"/>
+          <p:cNvPr id="13" name="判断标签文字2"/>
           <p:cNvSpPr txBox="1"/>
           <p:nvPr/>
         </p:nvSpPr>
@@ -6164,7 +6272,7 @@
       </p:sp>
       <p:sp>
         <p:nvSpPr>
-          <p:cNvPr id="13" name="判断行3"/>
+          <p:cNvPr id="14" name="判断行3"/>
           <p:cNvSpPr/>
           <p:nvPr/>
         </p:nvSpPr>
@@ -6191,7 +6299,7 @@
       </p:sp>
       <p:sp>
         <p:nvSpPr>
-          <p:cNvPr id="14" name="判断环节3"/>
+          <p:cNvPr id="15" name="判断环节3"/>
           <p:cNvSpPr txBox="1"/>
           <p:nvPr/>
         </p:nvSpPr>
@@ -6227,7 +6335,7 @@
       </p:sp>
       <p:sp>
         <p:nvSpPr>
-          <p:cNvPr id="15" name="判断说明3"/>
+          <p:cNvPr id="16" name="判断说明3"/>
           <p:cNvSpPr txBox="1"/>
           <p:nvPr/>
         </p:nvSpPr>
@@ -6263,7 +6371,7 @@
       </p:sp>
       <p:sp>
         <p:nvSpPr>
-          <p:cNvPr id="16" name="判断标签3"/>
+          <p:cNvPr id="17" name="判断标签3"/>
           <p:cNvSpPr/>
           <p:nvPr/>
         </p:nvSpPr>
@@ -6290,7 +6398,7 @@
       </p:sp>
       <p:sp>
         <p:nvSpPr>
-          <p:cNvPr id="17" name="判断标签文字3"/>
+          <p:cNvPr id="18" name="判断标签文字3"/>
           <p:cNvSpPr txBox="1"/>
           <p:nvPr/>
         </p:nvSpPr>
@@ -6326,7 +6434,7 @@
       </p:sp>
       <p:sp>
         <p:nvSpPr>
-          <p:cNvPr id="18" name="判断行4"/>
+          <p:cNvPr id="19" name="判断行4"/>
           <p:cNvSpPr/>
           <p:nvPr/>
         </p:nvSpPr>
@@ -6353,7 +6461,7 @@
       </p:sp>
       <p:sp>
         <p:nvSpPr>
-          <p:cNvPr id="19" name="判断环节4"/>
+          <p:cNvPr id="20" name="判断环节4"/>
           <p:cNvSpPr txBox="1"/>
           <p:nvPr/>
         </p:nvSpPr>
@@ -6389,7 +6497,7 @@
       </p:sp>
       <p:sp>
         <p:nvSpPr>
-          <p:cNvPr id="20" name="判断说明4"/>
+          <p:cNvPr id="21" name="判断说明4"/>
           <p:cNvSpPr txBox="1"/>
           <p:nvPr/>
         </p:nvSpPr>
@@ -6425,7 +6533,7 @@
       </p:sp>
       <p:sp>
         <p:nvSpPr>
-          <p:cNvPr id="21" name="判断标签4"/>
+          <p:cNvPr id="22" name="判断标签4"/>
           <p:cNvSpPr/>
           <p:nvPr/>
         </p:nvSpPr>
@@ -6452,7 +6560,7 @@
       </p:sp>
       <p:sp>
         <p:nvSpPr>
-          <p:cNvPr id="22" name="判断标签文字4"/>
+          <p:cNvPr id="23" name="判断标签文字4"/>
           <p:cNvSpPr txBox="1"/>
           <p:nvPr/>
         </p:nvSpPr>
@@ -6488,7 +6596,7 @@
       </p:sp>
       <p:sp>
         <p:nvSpPr>
-          <p:cNvPr id="23" name="研究价值卡"/>
+          <p:cNvPr id="24" name="研究价值卡"/>
           <p:cNvSpPr/>
           <p:nvPr/>
         </p:nvSpPr>
@@ -6515,7 +6623,7 @@
       </p:sp>
       <p:sp>
         <p:nvSpPr>
-          <p:cNvPr id="24" name="研究价值"/>
+          <p:cNvPr id="25" name="研究价值"/>
           <p:cNvSpPr txBox="1"/>
           <p:nvPr/>
         </p:nvSpPr>
@@ -6571,7 +6679,7 @@
       </p:sp>
       <p:sp>
         <p:nvSpPr>
-          <p:cNvPr id="25" name="讨论卡"/>
+          <p:cNvPr id="26" name="讨论卡"/>
           <p:cNvSpPr/>
           <p:nvPr/>
         </p:nvSpPr>
@@ -6598,7 +6706,7 @@
       </p:sp>
       <p:sp>
         <p:nvSpPr>
-          <p:cNvPr id="26" name="讨论问题"/>
+          <p:cNvPr id="27" name="讨论问题"/>
           <p:cNvSpPr txBox="1"/>
           <p:nvPr/>
         </p:nvSpPr>
@@ -6671,7 +6779,7 @@
       </p:sp>
       <p:sp>
         <p:nvSpPr>
-          <p:cNvPr id="27" name="利益关系说明"/>
+          <p:cNvPr id="28" name="利益关系说明"/>
           <p:cNvSpPr txBox="1"/>
           <p:nvPr/>
         </p:nvSpPr>
@@ -6785,8 +6893,8 @@
         </p:nvSpPr>
         <p:spPr>
           <a:xfrm>
-            <a:off x="548640" y="365760"/>
-            <a:ext cx="7406640" cy="777240"/>
+            <a:off x="548640" y="502920"/>
+            <a:ext cx="7452360" cy="685800"/>
           </a:xfrm>
           <a:prstGeom prst="rect">
             <a:avLst/>
@@ -6802,20 +6910,56 @@
               <a:buNone/>
             </a:pPr>
             <a:r>
-              <a:rPr lang="en-US" sz="2800" b="1" dirty="0">
+              <a:rPr lang="en-US" sz="2600" b="1" dirty="0">
                 <a:solidFill>
                   <a:schemeClr val="tx2"/>
                 </a:solidFill>
               </a:rPr>
-              <a:t>附录一：11 个数据来源的方法公开程度</a:t>
-            </a:r>
-            <a:endParaRPr lang="en-US" sz="2800" dirty="0"/>
-          </a:p>
-        </p:txBody>
-      </p:sp>
-      <p:sp>
-        <p:nvSpPr>
-          <p:cNvPr id="3" name="来源卡1"/>
+              <a:t>11 个数据来源中，核心两项问卷最不透明</a:t>
+            </a:r>
+            <a:endParaRPr lang="en-US" sz="2600" dirty="0"/>
+          </a:p>
+        </p:txBody>
+      </p:sp>
+      <p:sp>
+        <p:nvSpPr>
+          <p:cNvPr id="3" name="章节标签"/>
+          <p:cNvSpPr txBox="1"/>
+          <p:nvPr/>
+        </p:nvSpPr>
+        <p:spPr>
+          <a:xfrm>
+            <a:off x="548640" y="256032"/>
+            <a:ext cx="7315200" cy="292608"/>
+          </a:xfrm>
+          <a:prstGeom prst="rect">
+            <a:avLst/>
+          </a:prstGeom>
+          <a:noFill/>
+          <a:ln/>
+        </p:spPr>
+        <p:txBody>
+          <a:bodyPr wrap="square" lIns="0" tIns="0" rIns="0" bIns="0" rtlCol="0" anchor="ctr"/>
+          <a:lstStyle/>
+          <a:p>
+            <a:pPr indent="0" marL="0">
+              <a:buNone/>
+            </a:pPr>
+            <a:r>
+              <a:rPr lang="en-US" sz="1200" b="1" dirty="0">
+                <a:solidFill>
+                  <a:schemeClr val="accent1"/>
+                </a:solidFill>
+              </a:rPr>
+              <a:t>附录（备问）</a:t>
+            </a:r>
+            <a:endParaRPr lang="en-US" sz="1200" dirty="0"/>
+          </a:p>
+        </p:txBody>
+      </p:sp>
+      <p:sp>
+        <p:nvSpPr>
+          <p:cNvPr id="4" name="来源卡1"/>
           <p:cNvSpPr/>
           <p:nvPr/>
         </p:nvSpPr>
@@ -6842,7 +6986,7 @@
       </p:sp>
       <p:sp>
         <p:nvSpPr>
-          <p:cNvPr id="4" name="状态点1"/>
+          <p:cNvPr id="5" name="状态点1"/>
           <p:cNvSpPr/>
           <p:nvPr/>
         </p:nvSpPr>
@@ -6867,7 +7011,7 @@
       </p:sp>
       <p:sp>
         <p:nvSpPr>
-          <p:cNvPr id="5" name="来源类型1"/>
+          <p:cNvPr id="6" name="来源类型1"/>
           <p:cNvSpPr txBox="1"/>
           <p:nvPr/>
         </p:nvSpPr>
@@ -6914,7 +7058,7 @@
       </p:sp>
       <p:sp>
         <p:nvSpPr>
-          <p:cNvPr id="6" name="来源说明1"/>
+          <p:cNvPr id="7" name="来源说明1"/>
           <p:cNvSpPr txBox="1"/>
           <p:nvPr/>
         </p:nvSpPr>
@@ -6970,7 +7114,7 @@
       </p:sp>
       <p:sp>
         <p:nvSpPr>
-          <p:cNvPr id="7" name="来源卡2"/>
+          <p:cNvPr id="8" name="来源卡2"/>
           <p:cNvSpPr/>
           <p:nvPr/>
         </p:nvSpPr>
@@ -6997,7 +7141,7 @@
       </p:sp>
       <p:sp>
         <p:nvSpPr>
-          <p:cNvPr id="8" name="状态点2"/>
+          <p:cNvPr id="9" name="状态点2"/>
           <p:cNvSpPr/>
           <p:nvPr/>
         </p:nvSpPr>
@@ -7022,7 +7166,7 @@
       </p:sp>
       <p:sp>
         <p:nvSpPr>
-          <p:cNvPr id="9" name="来源类型2"/>
+          <p:cNvPr id="10" name="来源类型2"/>
           <p:cNvSpPr txBox="1"/>
           <p:nvPr/>
         </p:nvSpPr>
@@ -7069,7 +7213,7 @@
       </p:sp>
       <p:sp>
         <p:nvSpPr>
-          <p:cNvPr id="10" name="来源说明2"/>
+          <p:cNvPr id="11" name="来源说明2"/>
           <p:cNvSpPr txBox="1"/>
           <p:nvPr/>
         </p:nvSpPr>
@@ -7125,7 +7269,7 @@
       </p:sp>
       <p:sp>
         <p:nvSpPr>
-          <p:cNvPr id="11" name="来源卡3"/>
+          <p:cNvPr id="12" name="来源卡3"/>
           <p:cNvSpPr/>
           <p:nvPr/>
         </p:nvSpPr>
@@ -7152,7 +7296,7 @@
       </p:sp>
       <p:sp>
         <p:nvSpPr>
-          <p:cNvPr id="12" name="状态点3"/>
+          <p:cNvPr id="13" name="状态点3"/>
           <p:cNvSpPr/>
           <p:nvPr/>
         </p:nvSpPr>
@@ -7177,7 +7321,7 @@
       </p:sp>
       <p:sp>
         <p:nvSpPr>
-          <p:cNvPr id="13" name="来源类型3"/>
+          <p:cNvPr id="14" name="来源类型3"/>
           <p:cNvSpPr txBox="1"/>
           <p:nvPr/>
         </p:nvSpPr>
@@ -7224,7 +7368,7 @@
       </p:sp>
       <p:sp>
         <p:nvSpPr>
-          <p:cNvPr id="14" name="来源说明3"/>
+          <p:cNvPr id="15" name="来源说明3"/>
           <p:cNvSpPr txBox="1"/>
           <p:nvPr/>
         </p:nvSpPr>
@@ -7280,7 +7424,7 @@
       </p:sp>
       <p:sp>
         <p:nvSpPr>
-          <p:cNvPr id="15" name="来源卡4"/>
+          <p:cNvPr id="16" name="来源卡4"/>
           <p:cNvSpPr/>
           <p:nvPr/>
         </p:nvSpPr>
@@ -7307,7 +7451,7 @@
       </p:sp>
       <p:sp>
         <p:nvSpPr>
-          <p:cNvPr id="16" name="状态点4"/>
+          <p:cNvPr id="17" name="状态点4"/>
           <p:cNvSpPr/>
           <p:nvPr/>
         </p:nvSpPr>
@@ -7332,7 +7476,7 @@
       </p:sp>
       <p:sp>
         <p:nvSpPr>
-          <p:cNvPr id="17" name="来源类型4"/>
+          <p:cNvPr id="18" name="来源类型4"/>
           <p:cNvSpPr txBox="1"/>
           <p:nvPr/>
         </p:nvSpPr>
@@ -7379,7 +7523,7 @@
       </p:sp>
       <p:sp>
         <p:nvSpPr>
-          <p:cNvPr id="18" name="来源说明4"/>
+          <p:cNvPr id="19" name="来源说明4"/>
           <p:cNvSpPr txBox="1"/>
           <p:nvPr/>
         </p:nvSpPr>
@@ -7435,7 +7579,7 @@
       </p:sp>
       <p:sp>
         <p:nvSpPr>
-          <p:cNvPr id="19" name="来源卡5"/>
+          <p:cNvPr id="20" name="来源卡5"/>
           <p:cNvSpPr/>
           <p:nvPr/>
         </p:nvSpPr>
@@ -7462,7 +7606,7 @@
       </p:sp>
       <p:sp>
         <p:nvSpPr>
-          <p:cNvPr id="20" name="状态点5"/>
+          <p:cNvPr id="21" name="状态点5"/>
           <p:cNvSpPr/>
           <p:nvPr/>
         </p:nvSpPr>
@@ -7487,7 +7631,7 @@
       </p:sp>
       <p:sp>
         <p:nvSpPr>
-          <p:cNvPr id="21" name="来源类型5"/>
+          <p:cNvPr id="22" name="来源类型5"/>
           <p:cNvSpPr txBox="1"/>
           <p:nvPr/>
         </p:nvSpPr>
@@ -7534,7 +7678,7 @@
       </p:sp>
       <p:sp>
         <p:nvSpPr>
-          <p:cNvPr id="22" name="来源说明5"/>
+          <p:cNvPr id="23" name="来源说明5"/>
           <p:cNvSpPr txBox="1"/>
           <p:nvPr/>
         </p:nvSpPr>
@@ -7590,7 +7734,7 @@
       </p:sp>
       <p:sp>
         <p:nvSpPr>
-          <p:cNvPr id="23" name="来源卡6"/>
+          <p:cNvPr id="24" name="来源卡6"/>
           <p:cNvSpPr/>
           <p:nvPr/>
         </p:nvSpPr>
@@ -7617,7 +7761,7 @@
       </p:sp>
       <p:sp>
         <p:nvSpPr>
-          <p:cNvPr id="24" name="状态点6"/>
+          <p:cNvPr id="25" name="状态点6"/>
           <p:cNvSpPr/>
           <p:nvPr/>
         </p:nvSpPr>
@@ -7642,7 +7786,7 @@
       </p:sp>
       <p:sp>
         <p:nvSpPr>
-          <p:cNvPr id="25" name="来源类型6"/>
+          <p:cNvPr id="26" name="来源类型6"/>
           <p:cNvSpPr txBox="1"/>
           <p:nvPr/>
         </p:nvSpPr>
@@ -7689,7 +7833,7 @@
       </p:sp>
       <p:sp>
         <p:nvSpPr>
-          <p:cNvPr id="26" name="来源说明6"/>
+          <p:cNvPr id="27" name="来源说明6"/>
           <p:cNvSpPr txBox="1"/>
           <p:nvPr/>
         </p:nvSpPr>
@@ -7745,7 +7889,7 @@
       </p:sp>
       <p:sp>
         <p:nvSpPr>
-          <p:cNvPr id="27" name="来源卡7"/>
+          <p:cNvPr id="28" name="来源卡7"/>
           <p:cNvSpPr/>
           <p:nvPr/>
         </p:nvSpPr>
@@ -7772,7 +7916,7 @@
       </p:sp>
       <p:sp>
         <p:nvSpPr>
-          <p:cNvPr id="28" name="状态点7"/>
+          <p:cNvPr id="29" name="状态点7"/>
           <p:cNvSpPr/>
           <p:nvPr/>
         </p:nvSpPr>
@@ -7797,7 +7941,7 @@
       </p:sp>
       <p:sp>
         <p:nvSpPr>
-          <p:cNvPr id="29" name="来源类型7"/>
+          <p:cNvPr id="30" name="来源类型7"/>
           <p:cNvSpPr txBox="1"/>
           <p:nvPr/>
         </p:nvSpPr>
@@ -7844,7 +7988,7 @@
       </p:sp>
       <p:sp>
         <p:nvSpPr>
-          <p:cNvPr id="30" name="来源说明7"/>
+          <p:cNvPr id="31" name="来源说明7"/>
           <p:cNvSpPr txBox="1"/>
           <p:nvPr/>
         </p:nvSpPr>
@@ -7900,7 +8044,7 @@
       </p:sp>
       <p:sp>
         <p:nvSpPr>
-          <p:cNvPr id="31" name="来源卡8"/>
+          <p:cNvPr id="32" name="来源卡8"/>
           <p:cNvSpPr/>
           <p:nvPr/>
         </p:nvSpPr>
@@ -7927,7 +8071,7 @@
       </p:sp>
       <p:sp>
         <p:nvSpPr>
-          <p:cNvPr id="32" name="状态点8"/>
+          <p:cNvPr id="33" name="状态点8"/>
           <p:cNvSpPr/>
           <p:nvPr/>
         </p:nvSpPr>
@@ -7952,7 +8096,7 @@
       </p:sp>
       <p:sp>
         <p:nvSpPr>
-          <p:cNvPr id="33" name="来源类型8"/>
+          <p:cNvPr id="34" name="来源类型8"/>
           <p:cNvSpPr txBox="1"/>
           <p:nvPr/>
         </p:nvSpPr>
@@ -7999,7 +8143,7 @@
       </p:sp>
       <p:sp>
         <p:nvSpPr>
-          <p:cNvPr id="34" name="来源说明8"/>
+          <p:cNvPr id="35" name="来源说明8"/>
           <p:cNvSpPr txBox="1"/>
           <p:nvPr/>
         </p:nvSpPr>
@@ -8055,7 +8199,7 @@
       </p:sp>
       <p:sp>
         <p:nvSpPr>
-          <p:cNvPr id="35" name="来源卡9"/>
+          <p:cNvPr id="36" name="来源卡9"/>
           <p:cNvSpPr/>
           <p:nvPr/>
         </p:nvSpPr>
@@ -8082,7 +8226,7 @@
       </p:sp>
       <p:sp>
         <p:nvSpPr>
-          <p:cNvPr id="36" name="状态点9"/>
+          <p:cNvPr id="37" name="状态点9"/>
           <p:cNvSpPr/>
           <p:nvPr/>
         </p:nvSpPr>
@@ -8107,7 +8251,7 @@
       </p:sp>
       <p:sp>
         <p:nvSpPr>
-          <p:cNvPr id="37" name="来源类型9"/>
+          <p:cNvPr id="38" name="来源类型9"/>
           <p:cNvSpPr txBox="1"/>
           <p:nvPr/>
         </p:nvSpPr>
@@ -8154,7 +8298,7 @@
       </p:sp>
       <p:sp>
         <p:nvSpPr>
-          <p:cNvPr id="38" name="来源说明9"/>
+          <p:cNvPr id="39" name="来源说明9"/>
           <p:cNvSpPr txBox="1"/>
           <p:nvPr/>
         </p:nvSpPr>
@@ -8210,7 +8354,7 @@
       </p:sp>
       <p:sp>
         <p:nvSpPr>
-          <p:cNvPr id="39" name="来源卡10"/>
+          <p:cNvPr id="40" name="来源卡10"/>
           <p:cNvSpPr/>
           <p:nvPr/>
         </p:nvSpPr>
@@ -8237,7 +8381,7 @@
       </p:sp>
       <p:sp>
         <p:nvSpPr>
-          <p:cNvPr id="40" name="状态点10"/>
+          <p:cNvPr id="41" name="状态点10"/>
           <p:cNvSpPr/>
           <p:nvPr/>
         </p:nvSpPr>
@@ -8262,7 +8406,7 @@
       </p:sp>
       <p:sp>
         <p:nvSpPr>
-          <p:cNvPr id="41" name="来源类型10"/>
+          <p:cNvPr id="42" name="来源类型10"/>
           <p:cNvSpPr txBox="1"/>
           <p:nvPr/>
         </p:nvSpPr>
@@ -8309,7 +8453,7 @@
       </p:sp>
       <p:sp>
         <p:nvSpPr>
-          <p:cNvPr id="42" name="来源说明10"/>
+          <p:cNvPr id="43" name="来源说明10"/>
           <p:cNvSpPr txBox="1"/>
           <p:nvPr/>
         </p:nvSpPr>
@@ -8365,7 +8509,7 @@
       </p:sp>
       <p:sp>
         <p:nvSpPr>
-          <p:cNvPr id="43" name="来源卡11"/>
+          <p:cNvPr id="44" name="来源卡11"/>
           <p:cNvSpPr/>
           <p:nvPr/>
         </p:nvSpPr>
@@ -8392,7 +8536,7 @@
       </p:sp>
       <p:sp>
         <p:nvSpPr>
-          <p:cNvPr id="44" name="状态点11"/>
+          <p:cNvPr id="45" name="状态点11"/>
           <p:cNvSpPr/>
           <p:nvPr/>
         </p:nvSpPr>
@@ -8417,7 +8561,7 @@
       </p:sp>
       <p:sp>
         <p:nvSpPr>
-          <p:cNvPr id="45" name="来源类型11"/>
+          <p:cNvPr id="46" name="来源类型11"/>
           <p:cNvSpPr txBox="1"/>
           <p:nvPr/>
         </p:nvSpPr>
@@ -8464,7 +8608,7 @@
       </p:sp>
       <p:sp>
         <p:nvSpPr>
-          <p:cNvPr id="46" name="来源说明11"/>
+          <p:cNvPr id="47" name="来源说明11"/>
           <p:cNvSpPr txBox="1"/>
           <p:nvPr/>
         </p:nvSpPr>
@@ -8520,7 +8664,7 @@
       </p:sp>
       <p:sp>
         <p:nvSpPr>
-          <p:cNvPr id="47" name="来源小结卡"/>
+          <p:cNvPr id="48" name="来源小结卡"/>
           <p:cNvSpPr/>
           <p:nvPr/>
         </p:nvSpPr>
@@ -8547,7 +8691,7 @@
       </p:sp>
       <p:sp>
         <p:nvSpPr>
-          <p:cNvPr id="48" name="来源小结"/>
+          <p:cNvPr id="49" name="来源小结"/>
           <p:cNvSpPr txBox="1"/>
           <p:nvPr/>
         </p:nvSpPr>
@@ -8583,7 +8727,7 @@
       </p:sp>
       <p:sp>
         <p:nvSpPr>
-          <p:cNvPr id="49" name="来源说明"/>
+          <p:cNvPr id="50" name="来源说明"/>
           <p:cNvSpPr txBox="1"/>
           <p:nvPr/>
         </p:nvSpPr>
@@ -8697,8 +8841,8 @@
         </p:nvSpPr>
         <p:spPr>
           <a:xfrm>
-            <a:off x="548640" y="365760"/>
-            <a:ext cx="7406640" cy="777240"/>
+            <a:off x="548640" y="502920"/>
+            <a:ext cx="7452360" cy="685800"/>
           </a:xfrm>
           <a:prstGeom prst="rect">
             <a:avLst/>
@@ -8714,14 +8858,50 @@
               <a:buNone/>
             </a:pPr>
             <a:r>
-              <a:rPr lang="en-US" sz="2800" b="1" dirty="0">
+              <a:rPr lang="en-US" sz="2600" b="1" dirty="0">
                 <a:solidFill>
                   <a:schemeClr val="tx2"/>
                 </a:solidFill>
               </a:rPr>
-              <a:t>附录二：引用与数据口径核对</a:t>
-            </a:r>
-            <a:endParaRPr lang="en-US" sz="2800" dirty="0"/>
+              <a:t>多处引用与原始来源的口径不一致</a:t>
+            </a:r>
+            <a:endParaRPr lang="en-US" sz="2600" dirty="0"/>
+          </a:p>
+        </p:txBody>
+      </p:sp>
+      <p:sp>
+        <p:nvSpPr>
+          <p:cNvPr id="3" name="章节标签"/>
+          <p:cNvSpPr txBox="1"/>
+          <p:nvPr/>
+        </p:nvSpPr>
+        <p:spPr>
+          <a:xfrm>
+            <a:off x="548640" y="256032"/>
+            <a:ext cx="7315200" cy="292608"/>
+          </a:xfrm>
+          <a:prstGeom prst="rect">
+            <a:avLst/>
+          </a:prstGeom>
+          <a:noFill/>
+          <a:ln/>
+        </p:spPr>
+        <p:txBody>
+          <a:bodyPr wrap="square" lIns="0" tIns="0" rIns="0" bIns="0" rtlCol="0" anchor="ctr"/>
+          <a:lstStyle/>
+          <a:p>
+            <a:pPr indent="0" marL="0">
+              <a:buNone/>
+            </a:pPr>
+            <a:r>
+              <a:rPr lang="en-US" sz="1200" b="1" dirty="0">
+                <a:solidFill>
+                  <a:schemeClr val="accent1"/>
+                </a:solidFill>
+              </a:rPr>
+              <a:t>附录（备问）</a:t>
+            </a:r>
+            <a:endParaRPr lang="en-US" sz="1200" dirty="0"/>
           </a:p>
         </p:txBody>
       </p:sp>
@@ -9749,7 +9929,7 @@
       </p:graphicFrame>
       <p:sp>
         <p:nvSpPr>
-          <p:cNvPr id="4" name="来源说明"/>
+          <p:cNvPr id="5" name="来源说明"/>
           <p:cNvSpPr txBox="1"/>
           <p:nvPr/>
         </p:nvSpPr>
@@ -9863,8 +10043,8 @@
         </p:nvSpPr>
         <p:spPr>
           <a:xfrm>
-            <a:off x="548640" y="365760"/>
-            <a:ext cx="7406640" cy="777240"/>
+            <a:off x="548640" y="502920"/>
+            <a:ext cx="7452360" cy="685800"/>
           </a:xfrm>
           <a:prstGeom prst="rect">
             <a:avLst/>
@@ -9880,20 +10060,56 @@
               <a:buNone/>
             </a:pPr>
             <a:r>
-              <a:rPr lang="en-US" sz="2800" b="1" dirty="0">
+              <a:rPr lang="en-US" sz="2600" b="1" dirty="0">
                 <a:solidFill>
                   <a:schemeClr val="tx2"/>
                 </a:solidFill>
               </a:rPr>
+              <a:t>趋势可参考，但论证链关键环节证据不足</a:t>
+            </a:r>
+            <a:endParaRPr lang="en-US" sz="2600" dirty="0"/>
+          </a:p>
+        </p:txBody>
+      </p:sp>
+      <p:sp>
+        <p:nvSpPr>
+          <p:cNvPr id="3" name="章节标签"/>
+          <p:cNvSpPr txBox="1"/>
+          <p:nvPr/>
+        </p:nvSpPr>
+        <p:spPr>
+          <a:xfrm>
+            <a:off x="548640" y="256032"/>
+            <a:ext cx="7315200" cy="292608"/>
+          </a:xfrm>
+          <a:prstGeom prst="rect">
+            <a:avLst/>
+          </a:prstGeom>
+          <a:noFill/>
+          <a:ln/>
+        </p:spPr>
+        <p:txBody>
+          <a:bodyPr wrap="square" lIns="0" tIns="0" rIns="0" bIns="0" rtlCol="0" anchor="ctr"/>
+          <a:lstStyle/>
+          <a:p>
+            <a:pPr indent="0" marL="0">
+              <a:buNone/>
+            </a:pPr>
+            <a:r>
+              <a:rPr lang="en-US" sz="1200" b="1" dirty="0">
+                <a:solidFill>
+                  <a:schemeClr val="accent1"/>
+                </a:solidFill>
+              </a:rPr>
               <a:t>汇报框架与核心观点</a:t>
             </a:r>
-            <a:endParaRPr lang="en-US" sz="2800" dirty="0"/>
-          </a:p>
-        </p:txBody>
-      </p:sp>
-      <p:sp>
-        <p:nvSpPr>
-          <p:cNvPr id="3" name="框架行1"/>
+            <a:endParaRPr lang="en-US" sz="1200" dirty="0"/>
+          </a:p>
+        </p:txBody>
+      </p:sp>
+      <p:sp>
+        <p:nvSpPr>
+          <p:cNvPr id="4" name="框架行1"/>
           <p:cNvSpPr/>
           <p:nvPr/>
         </p:nvSpPr>
@@ -9920,7 +10136,7 @@
       </p:sp>
       <p:sp>
         <p:nvSpPr>
-          <p:cNvPr id="4" name="序号底1"/>
+          <p:cNvPr id="5" name="序号底1"/>
           <p:cNvSpPr/>
           <p:nvPr/>
         </p:nvSpPr>
@@ -9945,7 +10161,7 @@
       </p:sp>
       <p:sp>
         <p:nvSpPr>
-          <p:cNvPr id="5" name="序号1"/>
+          <p:cNvPr id="6" name="序号1"/>
           <p:cNvSpPr txBox="1"/>
           <p:nvPr/>
         </p:nvSpPr>
@@ -9981,7 +10197,7 @@
       </p:sp>
       <p:sp>
         <p:nvSpPr>
-          <p:cNvPr id="6" name="框架名1"/>
+          <p:cNvPr id="7" name="框架名1"/>
           <p:cNvSpPr txBox="1"/>
           <p:nvPr/>
         </p:nvSpPr>
@@ -10017,7 +10233,7 @@
       </p:sp>
       <p:sp>
         <p:nvSpPr>
-          <p:cNvPr id="7" name="框架说明1"/>
+          <p:cNvPr id="8" name="框架说明1"/>
           <p:cNvSpPr txBox="1"/>
           <p:nvPr/>
         </p:nvSpPr>
@@ -10053,7 +10269,7 @@
       </p:sp>
       <p:sp>
         <p:nvSpPr>
-          <p:cNvPr id="8" name="框架行2"/>
+          <p:cNvPr id="9" name="框架行2"/>
           <p:cNvSpPr/>
           <p:nvPr/>
         </p:nvSpPr>
@@ -10080,7 +10296,7 @@
       </p:sp>
       <p:sp>
         <p:nvSpPr>
-          <p:cNvPr id="9" name="序号底2"/>
+          <p:cNvPr id="10" name="序号底2"/>
           <p:cNvSpPr/>
           <p:nvPr/>
         </p:nvSpPr>
@@ -10105,7 +10321,7 @@
       </p:sp>
       <p:sp>
         <p:nvSpPr>
-          <p:cNvPr id="10" name="序号2"/>
+          <p:cNvPr id="11" name="序号2"/>
           <p:cNvSpPr txBox="1"/>
           <p:nvPr/>
         </p:nvSpPr>
@@ -10141,7 +10357,7 @@
       </p:sp>
       <p:sp>
         <p:nvSpPr>
-          <p:cNvPr id="11" name="框架名2"/>
+          <p:cNvPr id="12" name="框架名2"/>
           <p:cNvSpPr txBox="1"/>
           <p:nvPr/>
         </p:nvSpPr>
@@ -10177,7 +10393,7 @@
       </p:sp>
       <p:sp>
         <p:nvSpPr>
-          <p:cNvPr id="12" name="框架说明2"/>
+          <p:cNvPr id="13" name="框架说明2"/>
           <p:cNvSpPr txBox="1"/>
           <p:nvPr/>
         </p:nvSpPr>
@@ -10213,7 +10429,7 @@
       </p:sp>
       <p:sp>
         <p:nvSpPr>
-          <p:cNvPr id="13" name="框架行3"/>
+          <p:cNvPr id="14" name="框架行3"/>
           <p:cNvSpPr/>
           <p:nvPr/>
         </p:nvSpPr>
@@ -10240,7 +10456,7 @@
       </p:sp>
       <p:sp>
         <p:nvSpPr>
-          <p:cNvPr id="14" name="序号底3"/>
+          <p:cNvPr id="15" name="序号底3"/>
           <p:cNvSpPr/>
           <p:nvPr/>
         </p:nvSpPr>
@@ -10265,7 +10481,7 @@
       </p:sp>
       <p:sp>
         <p:nvSpPr>
-          <p:cNvPr id="15" name="序号3"/>
+          <p:cNvPr id="16" name="序号3"/>
           <p:cNvSpPr txBox="1"/>
           <p:nvPr/>
         </p:nvSpPr>
@@ -10301,7 +10517,7 @@
       </p:sp>
       <p:sp>
         <p:nvSpPr>
-          <p:cNvPr id="16" name="框架名3"/>
+          <p:cNvPr id="17" name="框架名3"/>
           <p:cNvSpPr txBox="1"/>
           <p:nvPr/>
         </p:nvSpPr>
@@ -10337,7 +10553,7 @@
       </p:sp>
       <p:sp>
         <p:nvSpPr>
-          <p:cNvPr id="17" name="框架说明3"/>
+          <p:cNvPr id="18" name="框架说明3"/>
           <p:cNvSpPr txBox="1"/>
           <p:nvPr/>
         </p:nvSpPr>
@@ -10373,7 +10589,7 @@
       </p:sp>
       <p:sp>
         <p:nvSpPr>
-          <p:cNvPr id="18" name="框架行4"/>
+          <p:cNvPr id="19" name="框架行4"/>
           <p:cNvSpPr/>
           <p:nvPr/>
         </p:nvSpPr>
@@ -10400,7 +10616,7 @@
       </p:sp>
       <p:sp>
         <p:nvSpPr>
-          <p:cNvPr id="19" name="序号底4"/>
+          <p:cNvPr id="20" name="序号底4"/>
           <p:cNvSpPr/>
           <p:nvPr/>
         </p:nvSpPr>
@@ -10425,7 +10641,7 @@
       </p:sp>
       <p:sp>
         <p:nvSpPr>
-          <p:cNvPr id="20" name="序号4"/>
+          <p:cNvPr id="21" name="序号4"/>
           <p:cNvSpPr txBox="1"/>
           <p:nvPr/>
         </p:nvSpPr>
@@ -10461,7 +10677,7 @@
       </p:sp>
       <p:sp>
         <p:nvSpPr>
-          <p:cNvPr id="21" name="框架名4"/>
+          <p:cNvPr id="22" name="框架名4"/>
           <p:cNvSpPr txBox="1"/>
           <p:nvPr/>
         </p:nvSpPr>
@@ -10497,7 +10713,7 @@
       </p:sp>
       <p:sp>
         <p:nvSpPr>
-          <p:cNvPr id="22" name="框架说明4"/>
+          <p:cNvPr id="23" name="框架说明4"/>
           <p:cNvSpPr txBox="1"/>
           <p:nvPr/>
         </p:nvSpPr>
@@ -10533,7 +10749,7 @@
       </p:sp>
       <p:sp>
         <p:nvSpPr>
-          <p:cNvPr id="23" name="框架行5"/>
+          <p:cNvPr id="24" name="框架行5"/>
           <p:cNvSpPr/>
           <p:nvPr/>
         </p:nvSpPr>
@@ -10560,7 +10776,7 @@
       </p:sp>
       <p:sp>
         <p:nvSpPr>
-          <p:cNvPr id="24" name="序号底5"/>
+          <p:cNvPr id="25" name="序号底5"/>
           <p:cNvSpPr/>
           <p:nvPr/>
         </p:nvSpPr>
@@ -10585,7 +10801,7 @@
       </p:sp>
       <p:sp>
         <p:nvSpPr>
-          <p:cNvPr id="25" name="序号5"/>
+          <p:cNvPr id="26" name="序号5"/>
           <p:cNvSpPr txBox="1"/>
           <p:nvPr/>
         </p:nvSpPr>
@@ -10621,7 +10837,7 @@
       </p:sp>
       <p:sp>
         <p:nvSpPr>
-          <p:cNvPr id="26" name="框架名5"/>
+          <p:cNvPr id="27" name="框架名5"/>
           <p:cNvSpPr txBox="1"/>
           <p:nvPr/>
         </p:nvSpPr>
@@ -10657,7 +10873,7 @@
       </p:sp>
       <p:sp>
         <p:nvSpPr>
-          <p:cNvPr id="27" name="框架说明5"/>
+          <p:cNvPr id="28" name="框架说明5"/>
           <p:cNvSpPr txBox="1"/>
           <p:nvPr/>
         </p:nvSpPr>
@@ -10693,7 +10909,7 @@
       </p:sp>
       <p:sp>
         <p:nvSpPr>
-          <p:cNvPr id="28" name="核心观点卡"/>
+          <p:cNvPr id="29" name="核心观点卡"/>
           <p:cNvSpPr/>
           <p:nvPr/>
         </p:nvSpPr>
@@ -10720,7 +10936,7 @@
       </p:sp>
       <p:sp>
         <p:nvSpPr>
-          <p:cNvPr id="29" name="核心观点"/>
+          <p:cNvPr id="30" name="核心观点"/>
           <p:cNvSpPr txBox="1"/>
           <p:nvPr/>
         </p:nvSpPr>
@@ -10871,8 +11087,8 @@
         </p:nvSpPr>
         <p:spPr>
           <a:xfrm>
-            <a:off x="548640" y="365760"/>
-            <a:ext cx="7406640" cy="777240"/>
+            <a:off x="548640" y="502920"/>
+            <a:ext cx="7452360" cy="685800"/>
           </a:xfrm>
           <a:prstGeom prst="rect">
             <a:avLst/>
@@ -10888,20 +11104,56 @@
               <a:buNone/>
             </a:pPr>
             <a:r>
-              <a:rPr lang="en-US" sz="2800" b="1" dirty="0">
+              <a:rPr lang="en-US" sz="2600" b="1" dirty="0">
                 <a:solidFill>
                   <a:schemeClr val="tx2"/>
                 </a:solidFill>
               </a:rPr>
+              <a:t>内容分散使检索变难，AI 能否成为新入口？</a:t>
+            </a:r>
+            <a:endParaRPr lang="en-US" sz="2600" dirty="0"/>
+          </a:p>
+        </p:txBody>
+      </p:sp>
+      <p:sp>
+        <p:nvSpPr>
+          <p:cNvPr id="3" name="章节标签"/>
+          <p:cNvSpPr txBox="1"/>
+          <p:nvPr/>
+        </p:nvSpPr>
+        <p:spPr>
+          <a:xfrm>
+            <a:off x="548640" y="256032"/>
+            <a:ext cx="7315200" cy="292608"/>
+          </a:xfrm>
+          <a:prstGeom prst="rect">
+            <a:avLst/>
+          </a:prstGeom>
+          <a:noFill/>
+          <a:ln/>
+        </p:spPr>
+        <p:txBody>
+          <a:bodyPr wrap="square" lIns="0" tIns="0" rIns="0" bIns="0" rtlCol="0" anchor="ctr"/>
+          <a:lstStyle/>
+          <a:p>
+            <a:pPr indent="0" marL="0">
+              <a:buNone/>
+            </a:pPr>
+            <a:r>
+              <a:rPr lang="en-US" sz="1200" b="1" dirty="0">
+                <a:solidFill>
+                  <a:schemeClr val="accent1"/>
+                </a:solidFill>
+              </a:rPr>
               <a:t>一、研究背景与研究问题</a:t>
             </a:r>
-            <a:endParaRPr lang="en-US" sz="2800" dirty="0"/>
-          </a:p>
-        </p:txBody>
-      </p:sp>
-      <p:sp>
-        <p:nvSpPr>
-          <p:cNvPr id="3" name="进度1"/>
+            <a:endParaRPr lang="en-US" sz="1200" dirty="0"/>
+          </a:p>
+        </p:txBody>
+      </p:sp>
+      <p:sp>
+        <p:nvSpPr>
+          <p:cNvPr id="4" name="进度1"/>
           <p:cNvSpPr/>
           <p:nvPr/>
         </p:nvSpPr>
@@ -10928,7 +11180,7 @@
       </p:sp>
       <p:sp>
         <p:nvSpPr>
-          <p:cNvPr id="4" name="进度文字1"/>
+          <p:cNvPr id="5" name="进度文字1"/>
           <p:cNvSpPr txBox="1"/>
           <p:nvPr/>
         </p:nvSpPr>
@@ -10964,7 +11216,7 @@
       </p:sp>
       <p:sp>
         <p:nvSpPr>
-          <p:cNvPr id="5" name="进度2"/>
+          <p:cNvPr id="6" name="进度2"/>
           <p:cNvSpPr/>
           <p:nvPr/>
         </p:nvSpPr>
@@ -10991,7 +11243,7 @@
       </p:sp>
       <p:sp>
         <p:nvSpPr>
-          <p:cNvPr id="6" name="进度文字2"/>
+          <p:cNvPr id="7" name="进度文字2"/>
           <p:cNvSpPr txBox="1"/>
           <p:nvPr/>
         </p:nvSpPr>
@@ -11027,7 +11279,7 @@
       </p:sp>
       <p:sp>
         <p:nvSpPr>
-          <p:cNvPr id="7" name="进度3"/>
+          <p:cNvPr id="8" name="进度3"/>
           <p:cNvSpPr/>
           <p:nvPr/>
         </p:nvSpPr>
@@ -11054,7 +11306,7 @@
       </p:sp>
       <p:sp>
         <p:nvSpPr>
-          <p:cNvPr id="8" name="进度文字3"/>
+          <p:cNvPr id="9" name="进度文字3"/>
           <p:cNvSpPr txBox="1"/>
           <p:nvPr/>
         </p:nvSpPr>
@@ -11090,7 +11342,7 @@
       </p:sp>
       <p:sp>
         <p:nvSpPr>
-          <p:cNvPr id="9" name="进度4"/>
+          <p:cNvPr id="10" name="进度4"/>
           <p:cNvSpPr/>
           <p:nvPr/>
         </p:nvSpPr>
@@ -11117,7 +11369,7 @@
       </p:sp>
       <p:sp>
         <p:nvSpPr>
-          <p:cNvPr id="10" name="进度文字4"/>
+          <p:cNvPr id="11" name="进度文字4"/>
           <p:cNvSpPr txBox="1"/>
           <p:nvPr/>
         </p:nvSpPr>
@@ -11153,7 +11405,7 @@
       </p:sp>
       <p:sp>
         <p:nvSpPr>
-          <p:cNvPr id="11" name="进度5"/>
+          <p:cNvPr id="12" name="进度5"/>
           <p:cNvSpPr/>
           <p:nvPr/>
         </p:nvSpPr>
@@ -11180,7 +11432,7 @@
       </p:sp>
       <p:sp>
         <p:nvSpPr>
-          <p:cNvPr id="12" name="进度文字5"/>
+          <p:cNvPr id="13" name="进度文字5"/>
           <p:cNvSpPr txBox="1"/>
           <p:nvPr/>
         </p:nvSpPr>
@@ -11216,7 +11468,7 @@
       </p:sp>
       <p:sp>
         <p:nvSpPr>
-          <p:cNvPr id="13" name="研究背景"/>
+          <p:cNvPr id="14" name="研究背景"/>
           <p:cNvSpPr txBox="1"/>
           <p:nvPr/>
         </p:nvSpPr>
@@ -11263,7 +11515,7 @@
       </p:sp>
       <p:sp>
         <p:nvSpPr>
-          <p:cNvPr id="14" name="问题卡1"/>
+          <p:cNvPr id="15" name="问题卡1"/>
           <p:cNvSpPr/>
           <p:nvPr/>
         </p:nvSpPr>
@@ -11290,7 +11542,7 @@
       </p:sp>
       <p:sp>
         <p:nvSpPr>
-          <p:cNvPr id="15" name="图标底"/>
+          <p:cNvPr id="16" name="图标底"/>
           <p:cNvSpPr/>
           <p:nvPr/>
         </p:nvSpPr>
@@ -11315,7 +11567,7 @@
       </p:sp>
       <p:pic>
         <p:nvPicPr>
-          <p:cNvPr id="16" name="图标" descr="preencoded.png">    </p:cNvPr>
+          <p:cNvPr id="17" name="图标" descr="preencoded.png">    </p:cNvPr>
           <p:cNvPicPr>
             <a:picLocks noChangeAspect="1"/>
           </p:cNvPicPr>
@@ -11339,7 +11591,7 @@
       </p:pic>
       <p:sp>
         <p:nvSpPr>
-          <p:cNvPr id="17" name="问题标题1"/>
+          <p:cNvPr id="18" name="问题标题1"/>
           <p:cNvSpPr txBox="1"/>
           <p:nvPr/>
         </p:nvSpPr>
@@ -11375,7 +11627,7 @@
       </p:sp>
       <p:sp>
         <p:nvSpPr>
-          <p:cNvPr id="18" name="问题内容1"/>
+          <p:cNvPr id="19" name="问题内容1"/>
           <p:cNvSpPr txBox="1"/>
           <p:nvPr/>
         </p:nvSpPr>
@@ -11411,7 +11663,7 @@
       </p:sp>
       <p:sp>
         <p:nvSpPr>
-          <p:cNvPr id="19" name="问题卡2"/>
+          <p:cNvPr id="20" name="问题卡2"/>
           <p:cNvSpPr/>
           <p:nvPr/>
         </p:nvSpPr>
@@ -11438,7 +11690,7 @@
       </p:sp>
       <p:sp>
         <p:nvSpPr>
-          <p:cNvPr id="20" name="图标底"/>
+          <p:cNvPr id="21" name="图标底"/>
           <p:cNvSpPr/>
           <p:nvPr/>
         </p:nvSpPr>
@@ -11463,7 +11715,7 @@
       </p:sp>
       <p:pic>
         <p:nvPicPr>
-          <p:cNvPr id="21" name="图标" descr="preencoded.png">    </p:cNvPr>
+          <p:cNvPr id="22" name="图标" descr="preencoded.png">    </p:cNvPr>
           <p:cNvPicPr>
             <a:picLocks noChangeAspect="1"/>
           </p:cNvPicPr>
@@ -11487,7 +11739,7 @@
       </p:pic>
       <p:sp>
         <p:nvSpPr>
-          <p:cNvPr id="22" name="问题标题2"/>
+          <p:cNvPr id="23" name="问题标题2"/>
           <p:cNvSpPr txBox="1"/>
           <p:nvPr/>
         </p:nvSpPr>
@@ -11523,7 +11775,7 @@
       </p:sp>
       <p:sp>
         <p:nvSpPr>
-          <p:cNvPr id="23" name="问题内容2"/>
+          <p:cNvPr id="24" name="问题内容2"/>
           <p:cNvSpPr txBox="1"/>
           <p:nvPr/>
         </p:nvSpPr>
@@ -11559,7 +11811,7 @@
       </p:sp>
       <p:sp>
         <p:nvSpPr>
-          <p:cNvPr id="24" name="问题卡3"/>
+          <p:cNvPr id="25" name="问题卡3"/>
           <p:cNvSpPr/>
           <p:nvPr/>
         </p:nvSpPr>
@@ -11586,7 +11838,7 @@
       </p:sp>
       <p:sp>
         <p:nvSpPr>
-          <p:cNvPr id="25" name="图标底"/>
+          <p:cNvPr id="26" name="图标底"/>
           <p:cNvSpPr/>
           <p:nvPr/>
         </p:nvSpPr>
@@ -11611,7 +11863,7 @@
       </p:sp>
       <p:pic>
         <p:nvPicPr>
-          <p:cNvPr id="26" name="图标" descr="preencoded.png">    </p:cNvPr>
+          <p:cNvPr id="27" name="图标" descr="preencoded.png">    </p:cNvPr>
           <p:cNvPicPr>
             <a:picLocks noChangeAspect="1"/>
           </p:cNvPicPr>
@@ -11635,7 +11887,7 @@
       </p:pic>
       <p:sp>
         <p:nvSpPr>
-          <p:cNvPr id="27" name="问题标题3"/>
+          <p:cNvPr id="28" name="问题标题3"/>
           <p:cNvSpPr txBox="1"/>
           <p:nvPr/>
         </p:nvSpPr>
@@ -11671,7 +11923,7 @@
       </p:sp>
       <p:sp>
         <p:nvSpPr>
-          <p:cNvPr id="28" name="问题内容3"/>
+          <p:cNvPr id="29" name="问题内容3"/>
           <p:cNvSpPr txBox="1"/>
           <p:nvPr/>
         </p:nvSpPr>
@@ -11707,7 +11959,7 @@
       </p:sp>
       <p:sp>
         <p:nvSpPr>
-          <p:cNvPr id="29" name="机构与主张"/>
+          <p:cNvPr id="30" name="机构与主张"/>
           <p:cNvSpPr/>
           <p:nvPr/>
         </p:nvSpPr>
@@ -11734,7 +11986,7 @@
       </p:sp>
       <p:sp>
         <p:nvSpPr>
-          <p:cNvPr id="30" name="图标底"/>
+          <p:cNvPr id="31" name="图标底"/>
           <p:cNvSpPr/>
           <p:nvPr/>
         </p:nvSpPr>
@@ -11759,7 +12011,7 @@
       </p:sp>
       <p:pic>
         <p:nvPicPr>
-          <p:cNvPr id="31" name="图标" descr="preencoded.png">    </p:cNvPr>
+          <p:cNvPr id="32" name="图标" descr="preencoded.png">    </p:cNvPr>
           <p:cNvPicPr>
             <a:picLocks noChangeAspect="1"/>
           </p:cNvPicPr>
@@ -11783,7 +12035,7 @@
       </p:pic>
       <p:sp>
         <p:nvSpPr>
-          <p:cNvPr id="32" name="研究机构"/>
+          <p:cNvPr id="33" name="研究机构"/>
           <p:cNvSpPr txBox="1"/>
           <p:nvPr/>
         </p:nvSpPr>
@@ -11839,7 +12091,7 @@
       </p:sp>
       <p:sp>
         <p:nvSpPr>
-          <p:cNvPr id="33" name="图标底"/>
+          <p:cNvPr id="34" name="图标底"/>
           <p:cNvSpPr/>
           <p:nvPr/>
         </p:nvSpPr>
@@ -11864,7 +12116,7 @@
       </p:sp>
       <p:pic>
         <p:nvPicPr>
-          <p:cNvPr id="34" name="图标" descr="preencoded.png">    </p:cNvPr>
+          <p:cNvPr id="35" name="图标" descr="preencoded.png">    </p:cNvPr>
           <p:cNvPicPr>
             <a:picLocks noChangeAspect="1"/>
           </p:cNvPicPr>
@@ -11888,7 +12140,7 @@
       </p:pic>
       <p:sp>
         <p:nvSpPr>
-          <p:cNvPr id="35" name="报告主张"/>
+          <p:cNvPr id="36" name="报告主张"/>
           <p:cNvSpPr txBox="1"/>
           <p:nvPr/>
         </p:nvSpPr>
@@ -12022,8 +12274,8 @@
         </p:nvSpPr>
         <p:spPr>
           <a:xfrm>
-            <a:off x="548640" y="365760"/>
-            <a:ext cx="7406640" cy="777240"/>
+            <a:off x="548640" y="502920"/>
+            <a:ext cx="7452360" cy="685800"/>
           </a:xfrm>
           <a:prstGeom prst="rect">
             <a:avLst/>
@@ -12039,20 +12291,56 @@
               <a:buNone/>
             </a:pPr>
             <a:r>
-              <a:rPr lang="en-US" sz="2800" b="1" dirty="0">
+              <a:rPr lang="en-US" sz="2600" b="1" dirty="0">
                 <a:solidFill>
                   <a:schemeClr val="tx2"/>
                 </a:solidFill>
               </a:rPr>
-              <a:t>二、研究设计：两项核心问卷调查</a:t>
-            </a:r>
-            <a:endParaRPr lang="en-US" sz="2800" dirty="0"/>
-          </a:p>
-        </p:txBody>
-      </p:sp>
-      <p:sp>
-        <p:nvSpPr>
-          <p:cNvPr id="3" name="进度1"/>
+              <a:t>结论依赖两项线上问卷，抽样方式均未公开</a:t>
+            </a:r>
+            <a:endParaRPr lang="en-US" sz="2600" dirty="0"/>
+          </a:p>
+        </p:txBody>
+      </p:sp>
+      <p:sp>
+        <p:nvSpPr>
+          <p:cNvPr id="3" name="章节标签"/>
+          <p:cNvSpPr txBox="1"/>
+          <p:nvPr/>
+        </p:nvSpPr>
+        <p:spPr>
+          <a:xfrm>
+            <a:off x="548640" y="256032"/>
+            <a:ext cx="7315200" cy="292608"/>
+          </a:xfrm>
+          <a:prstGeom prst="rect">
+            <a:avLst/>
+          </a:prstGeom>
+          <a:noFill/>
+          <a:ln/>
+        </p:spPr>
+        <p:txBody>
+          <a:bodyPr wrap="square" lIns="0" tIns="0" rIns="0" bIns="0" rtlCol="0" anchor="ctr"/>
+          <a:lstStyle/>
+          <a:p>
+            <a:pPr indent="0" marL="0">
+              <a:buNone/>
+            </a:pPr>
+            <a:r>
+              <a:rPr lang="en-US" sz="1200" b="1" dirty="0">
+                <a:solidFill>
+                  <a:schemeClr val="accent1"/>
+                </a:solidFill>
+              </a:rPr>
+              <a:t>二、研究设计</a:t>
+            </a:r>
+            <a:endParaRPr lang="en-US" sz="1200" dirty="0"/>
+          </a:p>
+        </p:txBody>
+      </p:sp>
+      <p:sp>
+        <p:nvSpPr>
+          <p:cNvPr id="4" name="进度1"/>
           <p:cNvSpPr/>
           <p:nvPr/>
         </p:nvSpPr>
@@ -12079,7 +12367,7 @@
       </p:sp>
       <p:sp>
         <p:nvSpPr>
-          <p:cNvPr id="4" name="进度文字1"/>
+          <p:cNvPr id="5" name="进度文字1"/>
           <p:cNvSpPr txBox="1"/>
           <p:nvPr/>
         </p:nvSpPr>
@@ -12115,7 +12403,7 @@
       </p:sp>
       <p:sp>
         <p:nvSpPr>
-          <p:cNvPr id="5" name="进度2"/>
+          <p:cNvPr id="6" name="进度2"/>
           <p:cNvSpPr/>
           <p:nvPr/>
         </p:nvSpPr>
@@ -12142,7 +12430,7 @@
       </p:sp>
       <p:sp>
         <p:nvSpPr>
-          <p:cNvPr id="6" name="进度文字2"/>
+          <p:cNvPr id="7" name="进度文字2"/>
           <p:cNvSpPr txBox="1"/>
           <p:nvPr/>
         </p:nvSpPr>
@@ -12178,7 +12466,7 @@
       </p:sp>
       <p:sp>
         <p:nvSpPr>
-          <p:cNvPr id="7" name="进度3"/>
+          <p:cNvPr id="8" name="进度3"/>
           <p:cNvSpPr/>
           <p:nvPr/>
         </p:nvSpPr>
@@ -12205,7 +12493,7 @@
       </p:sp>
       <p:sp>
         <p:nvSpPr>
-          <p:cNvPr id="8" name="进度文字3"/>
+          <p:cNvPr id="9" name="进度文字3"/>
           <p:cNvSpPr txBox="1"/>
           <p:nvPr/>
         </p:nvSpPr>
@@ -12241,7 +12529,7 @@
       </p:sp>
       <p:sp>
         <p:nvSpPr>
-          <p:cNvPr id="9" name="进度4"/>
+          <p:cNvPr id="10" name="进度4"/>
           <p:cNvSpPr/>
           <p:nvPr/>
         </p:nvSpPr>
@@ -12268,7 +12556,7 @@
       </p:sp>
       <p:sp>
         <p:nvSpPr>
-          <p:cNvPr id="10" name="进度文字4"/>
+          <p:cNvPr id="11" name="进度文字4"/>
           <p:cNvSpPr txBox="1"/>
           <p:nvPr/>
         </p:nvSpPr>
@@ -12304,7 +12592,7 @@
       </p:sp>
       <p:sp>
         <p:nvSpPr>
-          <p:cNvPr id="11" name="进度5"/>
+          <p:cNvPr id="12" name="进度5"/>
           <p:cNvSpPr/>
           <p:nvPr/>
         </p:nvSpPr>
@@ -12331,7 +12619,7 @@
       </p:sp>
       <p:sp>
         <p:nvSpPr>
-          <p:cNvPr id="12" name="进度文字5"/>
+          <p:cNvPr id="13" name="进度文字5"/>
           <p:cNvSpPr txBox="1"/>
           <p:nvPr/>
         </p:nvSpPr>
@@ -12367,7 +12655,7 @@
       </p:sp>
       <p:sp>
         <p:nvSpPr>
-          <p:cNvPr id="13" name="问卷卡1"/>
+          <p:cNvPr id="14" name="问卷卡1"/>
           <p:cNvSpPr/>
           <p:nvPr/>
         </p:nvSpPr>
@@ -12394,7 +12682,7 @@
       </p:sp>
       <p:sp>
         <p:nvSpPr>
-          <p:cNvPr id="14" name="问卷名1"/>
+          <p:cNvPr id="15" name="问卷名1"/>
           <p:cNvSpPr txBox="1"/>
           <p:nvPr/>
         </p:nvSpPr>
@@ -12444,7 +12732,7 @@
       </p:sp>
       <p:sp>
         <p:nvSpPr>
-          <p:cNvPr id="15" name="设计项1-1"/>
+          <p:cNvPr id="16" name="设计项1-1"/>
           <p:cNvSpPr txBox="1"/>
           <p:nvPr/>
         </p:nvSpPr>
@@ -12480,7 +12768,7 @@
       </p:sp>
       <p:sp>
         <p:nvSpPr>
-          <p:cNvPr id="16" name="设计值1-1"/>
+          <p:cNvPr id="17" name="设计值1-1"/>
           <p:cNvSpPr txBox="1"/>
           <p:nvPr/>
         </p:nvSpPr>
@@ -12516,7 +12804,7 @@
       </p:sp>
       <p:sp>
         <p:nvSpPr>
-          <p:cNvPr id="17" name="设计项1-2"/>
+          <p:cNvPr id="18" name="设计项1-2"/>
           <p:cNvSpPr txBox="1"/>
           <p:nvPr/>
         </p:nvSpPr>
@@ -12552,7 +12840,7 @@
       </p:sp>
       <p:sp>
         <p:nvSpPr>
-          <p:cNvPr id="18" name="设计值1-2"/>
+          <p:cNvPr id="19" name="设计值1-2"/>
           <p:cNvSpPr txBox="1"/>
           <p:nvPr/>
         </p:nvSpPr>
@@ -12588,7 +12876,7 @@
       </p:sp>
       <p:sp>
         <p:nvSpPr>
-          <p:cNvPr id="19" name="设计项1-3"/>
+          <p:cNvPr id="20" name="设计项1-3"/>
           <p:cNvSpPr txBox="1"/>
           <p:nvPr/>
         </p:nvSpPr>
@@ -12624,7 +12912,7 @@
       </p:sp>
       <p:sp>
         <p:nvSpPr>
-          <p:cNvPr id="20" name="设计值1-3"/>
+          <p:cNvPr id="21" name="设计值1-3"/>
           <p:cNvSpPr txBox="1"/>
           <p:nvPr/>
         </p:nvSpPr>
@@ -12660,7 +12948,7 @@
       </p:sp>
       <p:sp>
         <p:nvSpPr>
-          <p:cNvPr id="21" name="设计项1-4"/>
+          <p:cNvPr id="22" name="设计项1-4"/>
           <p:cNvSpPr txBox="1"/>
           <p:nvPr/>
         </p:nvSpPr>
@@ -12696,7 +12984,7 @@
       </p:sp>
       <p:sp>
         <p:nvSpPr>
-          <p:cNvPr id="22" name="设计值1-4"/>
+          <p:cNvPr id="23" name="设计值1-4"/>
           <p:cNvSpPr txBox="1"/>
           <p:nvPr/>
         </p:nvSpPr>
@@ -12732,7 +13020,7 @@
       </p:sp>
       <p:sp>
         <p:nvSpPr>
-          <p:cNvPr id="23" name="未公开底"/>
+          <p:cNvPr id="24" name="未公开底"/>
           <p:cNvSpPr/>
           <p:nvPr/>
         </p:nvSpPr>
@@ -12759,7 +13047,7 @@
       </p:sp>
       <p:sp>
         <p:nvSpPr>
-          <p:cNvPr id="24" name="设计项1-5"/>
+          <p:cNvPr id="25" name="设计项1-5"/>
           <p:cNvSpPr txBox="1"/>
           <p:nvPr/>
         </p:nvSpPr>
@@ -12795,7 +13083,7 @@
       </p:sp>
       <p:sp>
         <p:nvSpPr>
-          <p:cNvPr id="25" name="设计值1-5"/>
+          <p:cNvPr id="26" name="设计值1-5"/>
           <p:cNvSpPr txBox="1"/>
           <p:nvPr/>
         </p:nvSpPr>
@@ -12831,7 +13119,7 @@
       </p:sp>
       <p:sp>
         <p:nvSpPr>
-          <p:cNvPr id="26" name="问卷卡2"/>
+          <p:cNvPr id="27" name="问卷卡2"/>
           <p:cNvSpPr/>
           <p:nvPr/>
         </p:nvSpPr>
@@ -12858,7 +13146,7 @@
       </p:sp>
       <p:sp>
         <p:nvSpPr>
-          <p:cNvPr id="27" name="问卷名2"/>
+          <p:cNvPr id="28" name="问卷名2"/>
           <p:cNvSpPr txBox="1"/>
           <p:nvPr/>
         </p:nvSpPr>
@@ -12908,7 +13196,7 @@
       </p:sp>
       <p:sp>
         <p:nvSpPr>
-          <p:cNvPr id="28" name="设计项2-1"/>
+          <p:cNvPr id="29" name="设计项2-1"/>
           <p:cNvSpPr txBox="1"/>
           <p:nvPr/>
         </p:nvSpPr>
@@ -12944,7 +13232,7 @@
       </p:sp>
       <p:sp>
         <p:nvSpPr>
-          <p:cNvPr id="29" name="设计值2-1"/>
+          <p:cNvPr id="30" name="设计值2-1"/>
           <p:cNvSpPr txBox="1"/>
           <p:nvPr/>
         </p:nvSpPr>
@@ -12980,7 +13268,7 @@
       </p:sp>
       <p:sp>
         <p:nvSpPr>
-          <p:cNvPr id="30" name="设计项2-2"/>
+          <p:cNvPr id="31" name="设计项2-2"/>
           <p:cNvSpPr txBox="1"/>
           <p:nvPr/>
         </p:nvSpPr>
@@ -13016,7 +13304,7 @@
       </p:sp>
       <p:sp>
         <p:nvSpPr>
-          <p:cNvPr id="31" name="设计值2-2"/>
+          <p:cNvPr id="32" name="设计值2-2"/>
           <p:cNvSpPr txBox="1"/>
           <p:nvPr/>
         </p:nvSpPr>
@@ -13052,7 +13340,7 @@
       </p:sp>
       <p:sp>
         <p:nvSpPr>
-          <p:cNvPr id="32" name="设计项2-3"/>
+          <p:cNvPr id="33" name="设计项2-3"/>
           <p:cNvSpPr txBox="1"/>
           <p:nvPr/>
         </p:nvSpPr>
@@ -13088,7 +13376,7 @@
       </p:sp>
       <p:sp>
         <p:nvSpPr>
-          <p:cNvPr id="33" name="设计值2-3"/>
+          <p:cNvPr id="34" name="设计值2-3"/>
           <p:cNvSpPr txBox="1"/>
           <p:nvPr/>
         </p:nvSpPr>
@@ -13124,7 +13412,7 @@
       </p:sp>
       <p:sp>
         <p:nvSpPr>
-          <p:cNvPr id="34" name="设计项2-4"/>
+          <p:cNvPr id="35" name="设计项2-4"/>
           <p:cNvSpPr txBox="1"/>
           <p:nvPr/>
         </p:nvSpPr>
@@ -13160,7 +13448,7 @@
       </p:sp>
       <p:sp>
         <p:nvSpPr>
-          <p:cNvPr id="35" name="设计值2-4"/>
+          <p:cNvPr id="36" name="设计值2-4"/>
           <p:cNvSpPr txBox="1"/>
           <p:nvPr/>
         </p:nvSpPr>
@@ -13196,7 +13484,7 @@
       </p:sp>
       <p:sp>
         <p:nvSpPr>
-          <p:cNvPr id="36" name="未公开底"/>
+          <p:cNvPr id="37" name="未公开底"/>
           <p:cNvSpPr/>
           <p:nvPr/>
         </p:nvSpPr>
@@ -13223,7 +13511,7 @@
       </p:sp>
       <p:sp>
         <p:nvSpPr>
-          <p:cNvPr id="37" name="设计项2-5"/>
+          <p:cNvPr id="38" name="设计项2-5"/>
           <p:cNvSpPr txBox="1"/>
           <p:nvPr/>
         </p:nvSpPr>
@@ -13259,7 +13547,7 @@
       </p:sp>
       <p:sp>
         <p:nvSpPr>
-          <p:cNvPr id="38" name="设计值2-5"/>
+          <p:cNvPr id="39" name="设计值2-5"/>
           <p:cNvSpPr txBox="1"/>
           <p:nvPr/>
         </p:nvSpPr>
@@ -13295,7 +13583,7 @@
       </p:sp>
       <p:sp>
         <p:nvSpPr>
-          <p:cNvPr id="39" name="其他来源"/>
+          <p:cNvPr id="40" name="其他来源"/>
           <p:cNvSpPr txBox="1"/>
           <p:nvPr/>
         </p:nvSpPr>
@@ -13331,7 +13619,7 @@
       </p:sp>
       <p:sp>
         <p:nvSpPr>
-          <p:cNvPr id="40" name="来源说明"/>
+          <p:cNvPr id="41" name="来源说明"/>
           <p:cNvSpPr txBox="1"/>
           <p:nvPr/>
         </p:nvSpPr>
@@ -13445,8 +13733,8 @@
         </p:nvSpPr>
         <p:spPr>
           <a:xfrm>
-            <a:off x="548640" y="365760"/>
-            <a:ext cx="7406640" cy="777240"/>
+            <a:off x="548640" y="502920"/>
+            <a:ext cx="7452360" cy="685800"/>
           </a:xfrm>
           <a:prstGeom prst="rect">
             <a:avLst/>
@@ -13462,20 +13750,56 @@
               <a:buNone/>
             </a:pPr>
             <a:r>
-              <a:rPr lang="en-US" sz="2800" b="1" dirty="0">
+              <a:rPr lang="en-US" sz="2600" b="1" dirty="0">
                 <a:solidFill>
                   <a:schemeClr val="tx2"/>
                 </a:solidFill>
               </a:rPr>
-              <a:t>三、报告内容（一）：AI 使用增加，信任不足</a:t>
-            </a:r>
-            <a:endParaRPr lang="en-US" sz="2800" dirty="0"/>
-          </a:p>
-        </p:txBody>
-      </p:sp>
-      <p:sp>
-        <p:nvSpPr>
-          <p:cNvPr id="3" name="进度1"/>
+              <a:t>报告发现：年轻用户依赖 AI，但信任不足</a:t>
+            </a:r>
+            <a:endParaRPr lang="en-US" sz="2600" dirty="0"/>
+          </a:p>
+        </p:txBody>
+      </p:sp>
+      <p:sp>
+        <p:nvSpPr>
+          <p:cNvPr id="3" name="章节标签"/>
+          <p:cNvSpPr txBox="1"/>
+          <p:nvPr/>
+        </p:nvSpPr>
+        <p:spPr>
+          <a:xfrm>
+            <a:off x="548640" y="256032"/>
+            <a:ext cx="7315200" cy="292608"/>
+          </a:xfrm>
+          <a:prstGeom prst="rect">
+            <a:avLst/>
+          </a:prstGeom>
+          <a:noFill/>
+          <a:ln/>
+        </p:spPr>
+        <p:txBody>
+          <a:bodyPr wrap="square" lIns="0" tIns="0" rIns="0" bIns="0" rtlCol="0" anchor="ctr"/>
+          <a:lstStyle/>
+          <a:p>
+            <a:pPr indent="0" marL="0">
+              <a:buNone/>
+            </a:pPr>
+            <a:r>
+              <a:rPr lang="en-US" sz="1200" b="1" dirty="0">
+                <a:solidFill>
+                  <a:schemeClr val="accent1"/>
+                </a:solidFill>
+              </a:rPr>
+              <a:t>三、报告内容（一）</a:t>
+            </a:r>
+            <a:endParaRPr lang="en-US" sz="1200" dirty="0"/>
+          </a:p>
+        </p:txBody>
+      </p:sp>
+      <p:sp>
+        <p:nvSpPr>
+          <p:cNvPr id="4" name="进度1"/>
           <p:cNvSpPr/>
           <p:nvPr/>
         </p:nvSpPr>
@@ -13502,7 +13826,7 @@
       </p:sp>
       <p:sp>
         <p:nvSpPr>
-          <p:cNvPr id="4" name="进度文字1"/>
+          <p:cNvPr id="5" name="进度文字1"/>
           <p:cNvSpPr txBox="1"/>
           <p:nvPr/>
         </p:nvSpPr>
@@ -13538,7 +13862,7 @@
       </p:sp>
       <p:sp>
         <p:nvSpPr>
-          <p:cNvPr id="5" name="进度2"/>
+          <p:cNvPr id="6" name="进度2"/>
           <p:cNvSpPr/>
           <p:nvPr/>
         </p:nvSpPr>
@@ -13565,7 +13889,7 @@
       </p:sp>
       <p:sp>
         <p:nvSpPr>
-          <p:cNvPr id="6" name="进度文字2"/>
+          <p:cNvPr id="7" name="进度文字2"/>
           <p:cNvSpPr txBox="1"/>
           <p:nvPr/>
         </p:nvSpPr>
@@ -13601,7 +13925,7 @@
       </p:sp>
       <p:sp>
         <p:nvSpPr>
-          <p:cNvPr id="7" name="进度3"/>
+          <p:cNvPr id="8" name="进度3"/>
           <p:cNvSpPr/>
           <p:nvPr/>
         </p:nvSpPr>
@@ -13628,7 +13952,7 @@
       </p:sp>
       <p:sp>
         <p:nvSpPr>
-          <p:cNvPr id="8" name="进度文字3"/>
+          <p:cNvPr id="9" name="进度文字3"/>
           <p:cNvSpPr txBox="1"/>
           <p:nvPr/>
         </p:nvSpPr>
@@ -13664,7 +13988,7 @@
       </p:sp>
       <p:sp>
         <p:nvSpPr>
-          <p:cNvPr id="9" name="进度4"/>
+          <p:cNvPr id="10" name="进度4"/>
           <p:cNvSpPr/>
           <p:nvPr/>
         </p:nvSpPr>
@@ -13691,7 +14015,7 @@
       </p:sp>
       <p:sp>
         <p:nvSpPr>
-          <p:cNvPr id="10" name="进度文字4"/>
+          <p:cNvPr id="11" name="进度文字4"/>
           <p:cNvSpPr txBox="1"/>
           <p:nvPr/>
         </p:nvSpPr>
@@ -13727,7 +14051,7 @@
       </p:sp>
       <p:sp>
         <p:nvSpPr>
-          <p:cNvPr id="11" name="进度5"/>
+          <p:cNvPr id="12" name="进度5"/>
           <p:cNvSpPr/>
           <p:nvPr/>
         </p:nvSpPr>
@@ -13754,7 +14078,7 @@
       </p:sp>
       <p:sp>
         <p:nvSpPr>
-          <p:cNvPr id="12" name="进度文字5"/>
+          <p:cNvPr id="13" name="进度文字5"/>
           <p:cNvSpPr txBox="1"/>
           <p:nvPr/>
         </p:nvSpPr>
@@ -13790,7 +14114,7 @@
       </p:sp>
       <p:sp>
         <p:nvSpPr>
-          <p:cNvPr id="13" name="数据卡1"/>
+          <p:cNvPr id="14" name="数据卡1"/>
           <p:cNvSpPr/>
           <p:nvPr/>
         </p:nvSpPr>
@@ -13817,7 +14141,7 @@
       </p:sp>
       <p:sp>
         <p:nvSpPr>
-          <p:cNvPr id="14" name="数据1"/>
+          <p:cNvPr id="15" name="数据1"/>
           <p:cNvSpPr txBox="1"/>
           <p:nvPr/>
         </p:nvSpPr>
@@ -13856,7 +14180,7 @@
       </p:sp>
       <p:sp>
         <p:nvSpPr>
-          <p:cNvPr id="15" name="数据说明1"/>
+          <p:cNvPr id="16" name="数据说明1"/>
           <p:cNvSpPr txBox="1"/>
           <p:nvPr/>
         </p:nvSpPr>
@@ -13892,7 +14216,7 @@
       </p:sp>
       <p:sp>
         <p:nvSpPr>
-          <p:cNvPr id="16" name="数据卡2"/>
+          <p:cNvPr id="17" name="数据卡2"/>
           <p:cNvSpPr/>
           <p:nvPr/>
         </p:nvSpPr>
@@ -13919,7 +14243,7 @@
       </p:sp>
       <p:sp>
         <p:nvSpPr>
-          <p:cNvPr id="17" name="数据2"/>
+          <p:cNvPr id="18" name="数据2"/>
           <p:cNvSpPr txBox="1"/>
           <p:nvPr/>
         </p:nvSpPr>
@@ -13958,7 +14282,7 @@
       </p:sp>
       <p:sp>
         <p:nvSpPr>
-          <p:cNvPr id="18" name="数据说明2"/>
+          <p:cNvPr id="19" name="数据说明2"/>
           <p:cNvSpPr txBox="1"/>
           <p:nvPr/>
         </p:nvSpPr>
@@ -13994,7 +14318,7 @@
       </p:sp>
       <p:sp>
         <p:nvSpPr>
-          <p:cNvPr id="19" name="数据卡3"/>
+          <p:cNvPr id="20" name="数据卡3"/>
           <p:cNvSpPr/>
           <p:nvPr/>
         </p:nvSpPr>
@@ -14021,7 +14345,7 @@
       </p:sp>
       <p:sp>
         <p:nvSpPr>
-          <p:cNvPr id="20" name="数据3"/>
+          <p:cNvPr id="21" name="数据3"/>
           <p:cNvSpPr txBox="1"/>
           <p:nvPr/>
         </p:nvSpPr>
@@ -14060,7 +14384,7 @@
       </p:sp>
       <p:sp>
         <p:nvSpPr>
-          <p:cNvPr id="21" name="数据说明3"/>
+          <p:cNvPr id="22" name="数据说明3"/>
           <p:cNvSpPr txBox="1"/>
           <p:nvPr/>
         </p:nvSpPr>
@@ -14096,7 +14420,7 @@
       </p:sp>
       <p:sp>
         <p:nvSpPr>
-          <p:cNvPr id="22" name="数据卡4"/>
+          <p:cNvPr id="23" name="数据卡4"/>
           <p:cNvSpPr/>
           <p:nvPr/>
         </p:nvSpPr>
@@ -14123,7 +14447,7 @@
       </p:sp>
       <p:sp>
         <p:nvSpPr>
-          <p:cNvPr id="23" name="数据4"/>
+          <p:cNvPr id="24" name="数据4"/>
           <p:cNvSpPr txBox="1"/>
           <p:nvPr/>
         </p:nvSpPr>
@@ -14162,7 +14486,7 @@
       </p:sp>
       <p:sp>
         <p:nvSpPr>
-          <p:cNvPr id="24" name="数据说明4"/>
+          <p:cNvPr id="25" name="数据说明4"/>
           <p:cNvSpPr txBox="1"/>
           <p:nvPr/>
         </p:nvSpPr>
@@ -14198,7 +14522,7 @@
       </p:sp>
       <p:sp>
         <p:nvSpPr>
-          <p:cNvPr id="25" name="报告解释卡"/>
+          <p:cNvPr id="26" name="报告解释卡"/>
           <p:cNvSpPr/>
           <p:nvPr/>
         </p:nvSpPr>
@@ -14225,7 +14549,7 @@
       </p:sp>
       <p:sp>
         <p:nvSpPr>
-          <p:cNvPr id="26" name="解释标题"/>
+          <p:cNvPr id="27" name="解释标题"/>
           <p:cNvSpPr txBox="1"/>
           <p:nvPr/>
         </p:nvSpPr>
@@ -14261,7 +14585,7 @@
       </p:sp>
       <p:sp>
         <p:nvSpPr>
-          <p:cNvPr id="27" name="解释1"/>
+          <p:cNvPr id="28" name="解释1"/>
           <p:cNvSpPr txBox="1"/>
           <p:nvPr/>
         </p:nvSpPr>
@@ -14317,7 +14641,7 @@
       </p:sp>
       <p:sp>
         <p:nvSpPr>
-          <p:cNvPr id="28" name="解释2"/>
+          <p:cNvPr id="29" name="解释2"/>
           <p:cNvSpPr txBox="1"/>
           <p:nvPr/>
         </p:nvSpPr>
@@ -14373,7 +14697,7 @@
       </p:sp>
       <p:sp>
         <p:nvSpPr>
-          <p:cNvPr id="29" name="解释3"/>
+          <p:cNvPr id="30" name="解释3"/>
           <p:cNvSpPr txBox="1"/>
           <p:nvPr/>
         </p:nvSpPr>
@@ -14429,7 +14753,7 @@
       </p:sp>
       <p:sp>
         <p:nvSpPr>
-          <p:cNvPr id="30" name="来源说明"/>
+          <p:cNvPr id="31" name="来源说明"/>
           <p:cNvSpPr txBox="1"/>
           <p:nvPr/>
         </p:nvSpPr>
@@ -14543,8 +14867,8 @@
         </p:nvSpPr>
         <p:spPr>
           <a:xfrm>
-            <a:off x="548640" y="365760"/>
-            <a:ext cx="7406640" cy="777240"/>
+            <a:off x="548640" y="502920"/>
+            <a:ext cx="7452360" cy="685800"/>
           </a:xfrm>
           <a:prstGeom prst="rect">
             <a:avLst/>
@@ -14560,20 +14884,56 @@
               <a:buNone/>
             </a:pPr>
             <a:r>
-              <a:rPr lang="en-US" sz="2800" b="1" dirty="0">
+              <a:rPr lang="en-US" sz="2600" b="1" dirty="0">
                 <a:solidFill>
                   <a:schemeClr val="tx2"/>
                 </a:solidFill>
               </a:rPr>
-              <a:t>三、报告内容（二）：内容分散，检索困难</a:t>
-            </a:r>
-            <a:endParaRPr lang="en-US" sz="2800" dirty="0"/>
-          </a:p>
-        </p:txBody>
-      </p:sp>
-      <p:sp>
-        <p:nvSpPr>
-          <p:cNvPr id="3" name="进度1"/>
+              <a:t>报告认为：内容分散致退订，AI 须接入可信数据</a:t>
+            </a:r>
+            <a:endParaRPr lang="en-US" sz="2600" dirty="0"/>
+          </a:p>
+        </p:txBody>
+      </p:sp>
+      <p:sp>
+        <p:nvSpPr>
+          <p:cNvPr id="3" name="章节标签"/>
+          <p:cNvSpPr txBox="1"/>
+          <p:nvPr/>
+        </p:nvSpPr>
+        <p:spPr>
+          <a:xfrm>
+            <a:off x="548640" y="256032"/>
+            <a:ext cx="7315200" cy="292608"/>
+          </a:xfrm>
+          <a:prstGeom prst="rect">
+            <a:avLst/>
+          </a:prstGeom>
+          <a:noFill/>
+          <a:ln/>
+        </p:spPr>
+        <p:txBody>
+          <a:bodyPr wrap="square" lIns="0" tIns="0" rIns="0" bIns="0" rtlCol="0" anchor="ctr"/>
+          <a:lstStyle/>
+          <a:p>
+            <a:pPr indent="0" marL="0">
+              <a:buNone/>
+            </a:pPr>
+            <a:r>
+              <a:rPr lang="en-US" sz="1200" b="1" dirty="0">
+                <a:solidFill>
+                  <a:schemeClr val="accent1"/>
+                </a:solidFill>
+              </a:rPr>
+              <a:t>三、报告内容（二）</a:t>
+            </a:r>
+            <a:endParaRPr lang="en-US" sz="1200" dirty="0"/>
+          </a:p>
+        </p:txBody>
+      </p:sp>
+      <p:sp>
+        <p:nvSpPr>
+          <p:cNvPr id="4" name="进度1"/>
           <p:cNvSpPr/>
           <p:nvPr/>
         </p:nvSpPr>
@@ -14600,7 +14960,7 @@
       </p:sp>
       <p:sp>
         <p:nvSpPr>
-          <p:cNvPr id="4" name="进度文字1"/>
+          <p:cNvPr id="5" name="进度文字1"/>
           <p:cNvSpPr txBox="1"/>
           <p:nvPr/>
         </p:nvSpPr>
@@ -14636,7 +14996,7 @@
       </p:sp>
       <p:sp>
         <p:nvSpPr>
-          <p:cNvPr id="5" name="进度2"/>
+          <p:cNvPr id="6" name="进度2"/>
           <p:cNvSpPr/>
           <p:nvPr/>
         </p:nvSpPr>
@@ -14663,7 +15023,7 @@
       </p:sp>
       <p:sp>
         <p:nvSpPr>
-          <p:cNvPr id="6" name="进度文字2"/>
+          <p:cNvPr id="7" name="进度文字2"/>
           <p:cNvSpPr txBox="1"/>
           <p:nvPr/>
         </p:nvSpPr>
@@ -14699,7 +15059,7 @@
       </p:sp>
       <p:sp>
         <p:nvSpPr>
-          <p:cNvPr id="7" name="进度3"/>
+          <p:cNvPr id="8" name="进度3"/>
           <p:cNvSpPr/>
           <p:nvPr/>
         </p:nvSpPr>
@@ -14726,7 +15086,7 @@
       </p:sp>
       <p:sp>
         <p:nvSpPr>
-          <p:cNvPr id="8" name="进度文字3"/>
+          <p:cNvPr id="9" name="进度文字3"/>
           <p:cNvSpPr txBox="1"/>
           <p:nvPr/>
         </p:nvSpPr>
@@ -14762,7 +15122,7 @@
       </p:sp>
       <p:sp>
         <p:nvSpPr>
-          <p:cNvPr id="9" name="进度4"/>
+          <p:cNvPr id="10" name="进度4"/>
           <p:cNvSpPr/>
           <p:nvPr/>
         </p:nvSpPr>
@@ -14789,7 +15149,7 @@
       </p:sp>
       <p:sp>
         <p:nvSpPr>
-          <p:cNvPr id="10" name="进度文字4"/>
+          <p:cNvPr id="11" name="进度文字4"/>
           <p:cNvSpPr txBox="1"/>
           <p:nvPr/>
         </p:nvSpPr>
@@ -14825,7 +15185,7 @@
       </p:sp>
       <p:sp>
         <p:nvSpPr>
-          <p:cNvPr id="11" name="进度5"/>
+          <p:cNvPr id="12" name="进度5"/>
           <p:cNvSpPr/>
           <p:nvPr/>
         </p:nvSpPr>
@@ -14852,7 +15212,7 @@
       </p:sp>
       <p:sp>
         <p:nvSpPr>
-          <p:cNvPr id="12" name="进度文字5"/>
+          <p:cNvPr id="13" name="进度文字5"/>
           <p:cNvSpPr txBox="1"/>
           <p:nvPr/>
         </p:nvSpPr>
@@ -14888,7 +15248,7 @@
       </p:sp>
       <p:sp>
         <p:nvSpPr>
-          <p:cNvPr id="13" name="数据卡1"/>
+          <p:cNvPr id="14" name="数据卡1"/>
           <p:cNvSpPr/>
           <p:nvPr/>
         </p:nvSpPr>
@@ -14915,7 +15275,7 @@
       </p:sp>
       <p:sp>
         <p:nvSpPr>
-          <p:cNvPr id="14" name="数据1"/>
+          <p:cNvPr id="15" name="数据1"/>
           <p:cNvSpPr txBox="1"/>
           <p:nvPr/>
         </p:nvSpPr>
@@ -14954,7 +15314,7 @@
       </p:sp>
       <p:sp>
         <p:nvSpPr>
-          <p:cNvPr id="15" name="数据说明1"/>
+          <p:cNvPr id="16" name="数据说明1"/>
           <p:cNvSpPr txBox="1"/>
           <p:nvPr/>
         </p:nvSpPr>
@@ -14990,7 +15350,7 @@
       </p:sp>
       <p:sp>
         <p:nvSpPr>
-          <p:cNvPr id="16" name="数据卡2"/>
+          <p:cNvPr id="17" name="数据卡2"/>
           <p:cNvSpPr/>
           <p:nvPr/>
         </p:nvSpPr>
@@ -15017,7 +15377,7 @@
       </p:sp>
       <p:sp>
         <p:nvSpPr>
-          <p:cNvPr id="17" name="数据2"/>
+          <p:cNvPr id="18" name="数据2"/>
           <p:cNvSpPr txBox="1"/>
           <p:nvPr/>
         </p:nvSpPr>
@@ -15056,7 +15416,7 @@
       </p:sp>
       <p:sp>
         <p:nvSpPr>
-          <p:cNvPr id="18" name="数据说明2"/>
+          <p:cNvPr id="19" name="数据说明2"/>
           <p:cNvSpPr txBox="1"/>
           <p:nvPr/>
         </p:nvSpPr>
@@ -15092,7 +15452,7 @@
       </p:sp>
       <p:sp>
         <p:nvSpPr>
-          <p:cNvPr id="19" name="数据卡3"/>
+          <p:cNvPr id="20" name="数据卡3"/>
           <p:cNvSpPr/>
           <p:nvPr/>
         </p:nvSpPr>
@@ -15119,7 +15479,7 @@
       </p:sp>
       <p:sp>
         <p:nvSpPr>
-          <p:cNvPr id="20" name="数据3"/>
+          <p:cNvPr id="21" name="数据3"/>
           <p:cNvSpPr txBox="1"/>
           <p:nvPr/>
         </p:nvSpPr>
@@ -15158,7 +15518,7 @@
       </p:sp>
       <p:sp>
         <p:nvSpPr>
-          <p:cNvPr id="21" name="数据说明3"/>
+          <p:cNvPr id="22" name="数据说明3"/>
           <p:cNvSpPr txBox="1"/>
           <p:nvPr/>
         </p:nvSpPr>
@@ -15194,7 +15554,7 @@
       </p:sp>
       <p:sp>
         <p:nvSpPr>
-          <p:cNvPr id="22" name="数据卡4"/>
+          <p:cNvPr id="23" name="数据卡4"/>
           <p:cNvSpPr/>
           <p:nvPr/>
         </p:nvSpPr>
@@ -15221,7 +15581,7 @@
       </p:sp>
       <p:sp>
         <p:nvSpPr>
-          <p:cNvPr id="23" name="数据4"/>
+          <p:cNvPr id="24" name="数据4"/>
           <p:cNvSpPr txBox="1"/>
           <p:nvPr/>
         </p:nvSpPr>
@@ -15260,7 +15620,7 @@
       </p:sp>
       <p:sp>
         <p:nvSpPr>
-          <p:cNvPr id="24" name="数据说明4"/>
+          <p:cNvPr id="25" name="数据说明4"/>
           <p:cNvSpPr txBox="1"/>
           <p:nvPr/>
         </p:nvSpPr>
@@ -15296,7 +15656,7 @@
       </p:sp>
       <p:sp>
         <p:nvSpPr>
-          <p:cNvPr id="25" name="报告论证卡"/>
+          <p:cNvPr id="26" name="报告论证卡"/>
           <p:cNvSpPr/>
           <p:nvPr/>
         </p:nvSpPr>
@@ -15323,7 +15683,7 @@
       </p:sp>
       <p:sp>
         <p:nvSpPr>
-          <p:cNvPr id="26" name="论证标题"/>
+          <p:cNvPr id="27" name="论证标题"/>
           <p:cNvSpPr txBox="1"/>
           <p:nvPr/>
         </p:nvSpPr>
@@ -15359,7 +15719,7 @@
       </p:sp>
       <p:sp>
         <p:nvSpPr>
-          <p:cNvPr id="27" name="论证环1"/>
+          <p:cNvPr id="28" name="论证环1"/>
           <p:cNvSpPr/>
           <p:nvPr/>
         </p:nvSpPr>
@@ -15386,7 +15746,7 @@
       </p:sp>
       <p:sp>
         <p:nvSpPr>
-          <p:cNvPr id="28" name="论证环文字1"/>
+          <p:cNvPr id="29" name="论证环文字1"/>
           <p:cNvSpPr txBox="1"/>
           <p:nvPr/>
         </p:nvSpPr>
@@ -15422,7 +15782,7 @@
       </p:sp>
       <p:sp>
         <p:nvSpPr>
-          <p:cNvPr id="29" name="论证说明1"/>
+          <p:cNvPr id="30" name="论证说明1"/>
           <p:cNvSpPr txBox="1"/>
           <p:nvPr/>
         </p:nvSpPr>
@@ -15458,7 +15818,7 @@
       </p:sp>
       <p:sp>
         <p:nvSpPr>
-          <p:cNvPr id="30" name="论证箭头1"/>
+          <p:cNvPr id="31" name="论证箭头1"/>
           <p:cNvSpPr txBox="1"/>
           <p:nvPr/>
         </p:nvSpPr>
@@ -15494,7 +15854,7 @@
       </p:sp>
       <p:sp>
         <p:nvSpPr>
-          <p:cNvPr id="31" name="论证环2"/>
+          <p:cNvPr id="32" name="论证环2"/>
           <p:cNvSpPr/>
           <p:nvPr/>
         </p:nvSpPr>
@@ -15521,7 +15881,7 @@
       </p:sp>
       <p:sp>
         <p:nvSpPr>
-          <p:cNvPr id="32" name="论证环文字2"/>
+          <p:cNvPr id="33" name="论证环文字2"/>
           <p:cNvSpPr txBox="1"/>
           <p:nvPr/>
         </p:nvSpPr>
@@ -15557,7 +15917,7 @@
       </p:sp>
       <p:sp>
         <p:nvSpPr>
-          <p:cNvPr id="33" name="论证说明2"/>
+          <p:cNvPr id="34" name="论证说明2"/>
           <p:cNvSpPr txBox="1"/>
           <p:nvPr/>
         </p:nvSpPr>
@@ -15593,7 +15953,7 @@
       </p:sp>
       <p:sp>
         <p:nvSpPr>
-          <p:cNvPr id="34" name="论证箭头2"/>
+          <p:cNvPr id="35" name="论证箭头2"/>
           <p:cNvSpPr txBox="1"/>
           <p:nvPr/>
         </p:nvSpPr>
@@ -15629,7 +15989,7 @@
       </p:sp>
       <p:sp>
         <p:nvSpPr>
-          <p:cNvPr id="35" name="论证环3"/>
+          <p:cNvPr id="36" name="论证环3"/>
           <p:cNvSpPr/>
           <p:nvPr/>
         </p:nvSpPr>
@@ -15656,7 +16016,7 @@
       </p:sp>
       <p:sp>
         <p:nvSpPr>
-          <p:cNvPr id="36" name="论证环文字3"/>
+          <p:cNvPr id="37" name="论证环文字3"/>
           <p:cNvSpPr txBox="1"/>
           <p:nvPr/>
         </p:nvSpPr>
@@ -15692,7 +16052,7 @@
       </p:sp>
       <p:sp>
         <p:nvSpPr>
-          <p:cNvPr id="37" name="论证说明3"/>
+          <p:cNvPr id="38" name="论证说明3"/>
           <p:cNvSpPr txBox="1"/>
           <p:nvPr/>
         </p:nvSpPr>
@@ -15728,7 +16088,7 @@
       </p:sp>
       <p:sp>
         <p:nvSpPr>
-          <p:cNvPr id="38" name="论证箭头3"/>
+          <p:cNvPr id="39" name="论证箭头3"/>
           <p:cNvSpPr txBox="1"/>
           <p:nvPr/>
         </p:nvSpPr>
@@ -15764,7 +16124,7 @@
       </p:sp>
       <p:sp>
         <p:nvSpPr>
-          <p:cNvPr id="39" name="论证环4"/>
+          <p:cNvPr id="40" name="论证环4"/>
           <p:cNvSpPr/>
           <p:nvPr/>
         </p:nvSpPr>
@@ -15791,7 +16151,7 @@
       </p:sp>
       <p:sp>
         <p:nvSpPr>
-          <p:cNvPr id="40" name="论证环文字4"/>
+          <p:cNvPr id="41" name="论证环文字4"/>
           <p:cNvSpPr txBox="1"/>
           <p:nvPr/>
         </p:nvSpPr>
@@ -15827,7 +16187,7 @@
       </p:sp>
       <p:sp>
         <p:nvSpPr>
-          <p:cNvPr id="41" name="论证说明4"/>
+          <p:cNvPr id="42" name="论证说明4"/>
           <p:cNvSpPr txBox="1"/>
           <p:nvPr/>
         </p:nvSpPr>
@@ -15863,7 +16223,7 @@
       </p:sp>
       <p:sp>
         <p:nvSpPr>
-          <p:cNvPr id="42" name="来源说明"/>
+          <p:cNvPr id="43" name="来源说明"/>
           <p:cNvSpPr txBox="1"/>
           <p:nvPr/>
         </p:nvSpPr>
@@ -15977,8 +16337,8 @@
         </p:nvSpPr>
         <p:spPr>
           <a:xfrm>
-            <a:off x="548640" y="365760"/>
-            <a:ext cx="7406640" cy="777240"/>
+            <a:off x="548640" y="502920"/>
+            <a:ext cx="7452360" cy="685800"/>
           </a:xfrm>
           <a:prstGeom prst="rect">
             <a:avLst/>
@@ -15994,20 +16354,56 @@
               <a:buNone/>
             </a:pPr>
             <a:r>
-              <a:rPr lang="en-US" sz="2800" b="1" dirty="0">
+              <a:rPr lang="en-US" sz="2600" b="1" dirty="0">
                 <a:solidFill>
                   <a:schemeClr val="tx2"/>
                 </a:solidFill>
               </a:rPr>
-              <a:t>四、方法评价：沿论证链逐环检验</a:t>
-            </a:r>
-            <a:endParaRPr lang="en-US" sz="2800" dirty="0"/>
-          </a:p>
-        </p:txBody>
-      </p:sp>
-      <p:sp>
-        <p:nvSpPr>
-          <p:cNvPr id="3" name="进度1"/>
+              <a:t>报告的四环论证，可按课上四个维度逐环检验</a:t>
+            </a:r>
+            <a:endParaRPr lang="en-US" sz="2600" dirty="0"/>
+          </a:p>
+        </p:txBody>
+      </p:sp>
+      <p:sp>
+        <p:nvSpPr>
+          <p:cNvPr id="3" name="章节标签"/>
+          <p:cNvSpPr txBox="1"/>
+          <p:nvPr/>
+        </p:nvSpPr>
+        <p:spPr>
+          <a:xfrm>
+            <a:off x="548640" y="256032"/>
+            <a:ext cx="7315200" cy="292608"/>
+          </a:xfrm>
+          <a:prstGeom prst="rect">
+            <a:avLst/>
+          </a:prstGeom>
+          <a:noFill/>
+          <a:ln/>
+        </p:spPr>
+        <p:txBody>
+          <a:bodyPr wrap="square" lIns="0" tIns="0" rIns="0" bIns="0" rtlCol="0" anchor="ctr"/>
+          <a:lstStyle/>
+          <a:p>
+            <a:pPr indent="0" marL="0">
+              <a:buNone/>
+            </a:pPr>
+            <a:r>
+              <a:rPr lang="en-US" sz="1200" b="1" dirty="0">
+                <a:solidFill>
+                  <a:schemeClr val="accent1"/>
+                </a:solidFill>
+              </a:rPr>
+              <a:t>四、方法评价 · 总览</a:t>
+            </a:r>
+            <a:endParaRPr lang="en-US" sz="1200" dirty="0"/>
+          </a:p>
+        </p:txBody>
+      </p:sp>
+      <p:sp>
+        <p:nvSpPr>
+          <p:cNvPr id="4" name="进度1"/>
           <p:cNvSpPr/>
           <p:nvPr/>
         </p:nvSpPr>
@@ -16034,7 +16430,7 @@
       </p:sp>
       <p:sp>
         <p:nvSpPr>
-          <p:cNvPr id="4" name="进度文字1"/>
+          <p:cNvPr id="5" name="进度文字1"/>
           <p:cNvSpPr txBox="1"/>
           <p:nvPr/>
         </p:nvSpPr>
@@ -16070,7 +16466,7 @@
       </p:sp>
       <p:sp>
         <p:nvSpPr>
-          <p:cNvPr id="5" name="进度2"/>
+          <p:cNvPr id="6" name="进度2"/>
           <p:cNvSpPr/>
           <p:nvPr/>
         </p:nvSpPr>
@@ -16097,7 +16493,7 @@
       </p:sp>
       <p:sp>
         <p:nvSpPr>
-          <p:cNvPr id="6" name="进度文字2"/>
+          <p:cNvPr id="7" name="进度文字2"/>
           <p:cNvSpPr txBox="1"/>
           <p:nvPr/>
         </p:nvSpPr>
@@ -16133,7 +16529,7 @@
       </p:sp>
       <p:sp>
         <p:nvSpPr>
-          <p:cNvPr id="7" name="进度3"/>
+          <p:cNvPr id="8" name="进度3"/>
           <p:cNvSpPr/>
           <p:nvPr/>
         </p:nvSpPr>
@@ -16160,7 +16556,7 @@
       </p:sp>
       <p:sp>
         <p:nvSpPr>
-          <p:cNvPr id="8" name="进度文字3"/>
+          <p:cNvPr id="9" name="进度文字3"/>
           <p:cNvSpPr txBox="1"/>
           <p:nvPr/>
         </p:nvSpPr>
@@ -16196,7 +16592,7 @@
       </p:sp>
       <p:sp>
         <p:nvSpPr>
-          <p:cNvPr id="9" name="进度4"/>
+          <p:cNvPr id="10" name="进度4"/>
           <p:cNvSpPr/>
           <p:nvPr/>
         </p:nvSpPr>
@@ -16223,7 +16619,7 @@
       </p:sp>
       <p:sp>
         <p:nvSpPr>
-          <p:cNvPr id="10" name="进度文字4"/>
+          <p:cNvPr id="11" name="进度文字4"/>
           <p:cNvSpPr txBox="1"/>
           <p:nvPr/>
         </p:nvSpPr>
@@ -16259,7 +16655,7 @@
       </p:sp>
       <p:sp>
         <p:nvSpPr>
-          <p:cNvPr id="11" name="进度5"/>
+          <p:cNvPr id="12" name="进度5"/>
           <p:cNvSpPr/>
           <p:nvPr/>
         </p:nvSpPr>
@@ -16286,7 +16682,7 @@
       </p:sp>
       <p:sp>
         <p:nvSpPr>
-          <p:cNvPr id="12" name="进度文字5"/>
+          <p:cNvPr id="13" name="进度文字5"/>
           <p:cNvSpPr txBox="1"/>
           <p:nvPr/>
         </p:nvSpPr>
@@ -16322,7 +16718,7 @@
       </p:sp>
       <p:sp>
         <p:nvSpPr>
-          <p:cNvPr id="13" name="评价引言"/>
+          <p:cNvPr id="14" name="评价引言"/>
           <p:cNvSpPr txBox="1"/>
           <p:nvPr/>
         </p:nvSpPr>
@@ -16350,7 +16746,7 @@
                   <a:schemeClr val="tx2"/>
                 </a:solidFill>
               </a:rPr>
-              <a:t>参照课上春晚满意度调查案例（央视 81.6% 与新浪网 11.5%）：调查对象、研究总体、调查时间与研究方法不同，结论必然不同。</a:t>
+              <a:t>依据：课上春晚满意度调查案例（央视 81.6% 与新浪网 11.5%）——调查对象、研究总体、调查时间与研究方法不同，结论必然不同。</a:t>
             </a:r>
             <a:endParaRPr lang="en-US" sz="1400" dirty="0"/>
           </a:p>
@@ -16358,7 +16754,7 @@
       </p:sp>
       <p:sp>
         <p:nvSpPr>
-          <p:cNvPr id="14" name="行标签1"/>
+          <p:cNvPr id="15" name="行标签1"/>
           <p:cNvSpPr txBox="1"/>
           <p:nvPr/>
         </p:nvSpPr>
@@ -16394,7 +16790,7 @@
       </p:sp>
       <p:sp>
         <p:nvSpPr>
-          <p:cNvPr id="15" name="行标签2"/>
+          <p:cNvPr id="16" name="行标签2"/>
           <p:cNvSpPr txBox="1"/>
           <p:nvPr/>
         </p:nvSpPr>
@@ -16430,7 +16826,7 @@
       </p:sp>
       <p:sp>
         <p:nvSpPr>
-          <p:cNvPr id="16" name="行标签3"/>
+          <p:cNvPr id="17" name="行标签3"/>
           <p:cNvSpPr txBox="1"/>
           <p:nvPr/>
         </p:nvSpPr>
@@ -16466,7 +16862,7 @@
       </p:sp>
       <p:sp>
         <p:nvSpPr>
-          <p:cNvPr id="17" name="环节1"/>
+          <p:cNvPr id="18" name="环节1"/>
           <p:cNvSpPr/>
           <p:nvPr/>
         </p:nvSpPr>
@@ -16493,7 +16889,7 @@
       </p:sp>
       <p:sp>
         <p:nvSpPr>
-          <p:cNvPr id="18" name="环节文字1"/>
+          <p:cNvPr id="19" name="环节文字1"/>
           <p:cNvSpPr txBox="1"/>
           <p:nvPr/>
         </p:nvSpPr>
@@ -16529,7 +16925,7 @@
       </p:sp>
       <p:sp>
         <p:nvSpPr>
-          <p:cNvPr id="19" name="环节箭头1"/>
+          <p:cNvPr id="20" name="环节箭头1"/>
           <p:cNvSpPr txBox="1"/>
           <p:nvPr/>
         </p:nvSpPr>
@@ -16565,7 +16961,7 @@
       </p:sp>
       <p:sp>
         <p:nvSpPr>
-          <p:cNvPr id="20" name="证据1"/>
+          <p:cNvPr id="21" name="证据1"/>
           <p:cNvSpPr/>
           <p:nvPr/>
         </p:nvSpPr>
@@ -16592,7 +16988,7 @@
       </p:sp>
       <p:sp>
         <p:nvSpPr>
-          <p:cNvPr id="21" name="证据文字1"/>
+          <p:cNvPr id="22" name="证据文字1"/>
           <p:cNvSpPr txBox="1"/>
           <p:nvPr/>
         </p:nvSpPr>
@@ -16628,7 +17024,7 @@
       </p:sp>
       <p:sp>
         <p:nvSpPr>
-          <p:cNvPr id="22" name="检验1"/>
+          <p:cNvPr id="23" name="检验1"/>
           <p:cNvSpPr/>
           <p:nvPr/>
         </p:nvSpPr>
@@ -16655,7 +17051,7 @@
       </p:sp>
       <p:sp>
         <p:nvSpPr>
-          <p:cNvPr id="23" name="检验文字1"/>
+          <p:cNvPr id="24" name="检验文字1"/>
           <p:cNvSpPr txBox="1"/>
           <p:nvPr/>
         </p:nvSpPr>
@@ -16705,7 +17101,7 @@
       </p:sp>
       <p:sp>
         <p:nvSpPr>
-          <p:cNvPr id="24" name="环节2"/>
+          <p:cNvPr id="25" name="环节2"/>
           <p:cNvSpPr/>
           <p:nvPr/>
         </p:nvSpPr>
@@ -16732,7 +17128,7 @@
       </p:sp>
       <p:sp>
         <p:nvSpPr>
-          <p:cNvPr id="25" name="环节文字2"/>
+          <p:cNvPr id="26" name="环节文字2"/>
           <p:cNvSpPr txBox="1"/>
           <p:nvPr/>
         </p:nvSpPr>
@@ -16768,7 +17164,7 @@
       </p:sp>
       <p:sp>
         <p:nvSpPr>
-          <p:cNvPr id="26" name="环节箭头2"/>
+          <p:cNvPr id="27" name="环节箭头2"/>
           <p:cNvSpPr txBox="1"/>
           <p:nvPr/>
         </p:nvSpPr>
@@ -16804,7 +17200,7 @@
       </p:sp>
       <p:sp>
         <p:nvSpPr>
-          <p:cNvPr id="27" name="证据2"/>
+          <p:cNvPr id="28" name="证据2"/>
           <p:cNvSpPr/>
           <p:nvPr/>
         </p:nvSpPr>
@@ -16831,7 +17227,7 @@
       </p:sp>
       <p:sp>
         <p:nvSpPr>
-          <p:cNvPr id="28" name="证据文字2"/>
+          <p:cNvPr id="29" name="证据文字2"/>
           <p:cNvSpPr txBox="1"/>
           <p:nvPr/>
         </p:nvSpPr>
@@ -16867,7 +17263,7 @@
       </p:sp>
       <p:sp>
         <p:nvSpPr>
-          <p:cNvPr id="29" name="检验2"/>
+          <p:cNvPr id="30" name="检验2"/>
           <p:cNvSpPr/>
           <p:nvPr/>
         </p:nvSpPr>
@@ -16894,7 +17290,7 @@
       </p:sp>
       <p:sp>
         <p:nvSpPr>
-          <p:cNvPr id="30" name="检验文字2"/>
+          <p:cNvPr id="31" name="检验文字2"/>
           <p:cNvSpPr txBox="1"/>
           <p:nvPr/>
         </p:nvSpPr>
@@ -16930,7 +17326,7 @@
       </p:sp>
       <p:sp>
         <p:nvSpPr>
-          <p:cNvPr id="31" name="环节3"/>
+          <p:cNvPr id="32" name="环节3"/>
           <p:cNvSpPr/>
           <p:nvPr/>
         </p:nvSpPr>
@@ -16957,7 +17353,7 @@
       </p:sp>
       <p:sp>
         <p:nvSpPr>
-          <p:cNvPr id="32" name="环节文字3"/>
+          <p:cNvPr id="33" name="环节文字3"/>
           <p:cNvSpPr txBox="1"/>
           <p:nvPr/>
         </p:nvSpPr>
@@ -16993,7 +17389,7 @@
       </p:sp>
       <p:sp>
         <p:nvSpPr>
-          <p:cNvPr id="33" name="环节箭头3"/>
+          <p:cNvPr id="34" name="环节箭头3"/>
           <p:cNvSpPr txBox="1"/>
           <p:nvPr/>
         </p:nvSpPr>
@@ -17029,7 +17425,7 @@
       </p:sp>
       <p:sp>
         <p:nvSpPr>
-          <p:cNvPr id="34" name="证据3"/>
+          <p:cNvPr id="35" name="证据3"/>
           <p:cNvSpPr/>
           <p:nvPr/>
         </p:nvSpPr>
@@ -17056,7 +17452,7 @@
       </p:sp>
       <p:sp>
         <p:nvSpPr>
-          <p:cNvPr id="35" name="证据文字3"/>
+          <p:cNvPr id="36" name="证据文字3"/>
           <p:cNvSpPr txBox="1"/>
           <p:nvPr/>
         </p:nvSpPr>
@@ -17092,7 +17488,7 @@
       </p:sp>
       <p:sp>
         <p:nvSpPr>
-          <p:cNvPr id="36" name="检验3"/>
+          <p:cNvPr id="37" name="检验3"/>
           <p:cNvSpPr/>
           <p:nvPr/>
         </p:nvSpPr>
@@ -17119,7 +17515,7 @@
       </p:sp>
       <p:sp>
         <p:nvSpPr>
-          <p:cNvPr id="37" name="检验文字3"/>
+          <p:cNvPr id="38" name="检验文字3"/>
           <p:cNvSpPr txBox="1"/>
           <p:nvPr/>
         </p:nvSpPr>
@@ -17169,7 +17565,7 @@
       </p:sp>
       <p:sp>
         <p:nvSpPr>
-          <p:cNvPr id="38" name="环节4"/>
+          <p:cNvPr id="39" name="环节4"/>
           <p:cNvSpPr/>
           <p:nvPr/>
         </p:nvSpPr>
@@ -17196,7 +17592,7 @@
       </p:sp>
       <p:sp>
         <p:nvSpPr>
-          <p:cNvPr id="39" name="环节文字4"/>
+          <p:cNvPr id="40" name="环节文字4"/>
           <p:cNvSpPr txBox="1"/>
           <p:nvPr/>
         </p:nvSpPr>
@@ -17232,7 +17628,7 @@
       </p:sp>
       <p:sp>
         <p:nvSpPr>
-          <p:cNvPr id="40" name="证据4"/>
+          <p:cNvPr id="41" name="证据4"/>
           <p:cNvSpPr/>
           <p:nvPr/>
         </p:nvSpPr>
@@ -17259,7 +17655,7 @@
       </p:sp>
       <p:sp>
         <p:nvSpPr>
-          <p:cNvPr id="41" name="证据文字4"/>
+          <p:cNvPr id="42" name="证据文字4"/>
           <p:cNvSpPr txBox="1"/>
           <p:nvPr/>
         </p:nvSpPr>
@@ -17295,7 +17691,7 @@
       </p:sp>
       <p:sp>
         <p:nvSpPr>
-          <p:cNvPr id="42" name="检验4"/>
+          <p:cNvPr id="43" name="检验4"/>
           <p:cNvSpPr/>
           <p:nvPr/>
         </p:nvSpPr>
@@ -17322,7 +17718,7 @@
       </p:sp>
       <p:sp>
         <p:nvSpPr>
-          <p:cNvPr id="43" name="检验文字4"/>
+          <p:cNvPr id="44" name="检验文字4"/>
           <p:cNvSpPr txBox="1"/>
           <p:nvPr/>
         </p:nvSpPr>
@@ -17372,7 +17768,7 @@
       </p:sp>
       <p:sp>
         <p:nvSpPr>
-          <p:cNvPr id="44" name="来源说明"/>
+          <p:cNvPr id="45" name="来源说明"/>
           <p:cNvSpPr txBox="1"/>
           <p:nvPr/>
         </p:nvSpPr>
@@ -17486,8 +17882,8 @@
         </p:nvSpPr>
         <p:spPr>
           <a:xfrm>
-            <a:off x="548640" y="365760"/>
-            <a:ext cx="7406640" cy="777240"/>
+            <a:off x="548640" y="502920"/>
+            <a:ext cx="7452360" cy="685800"/>
           </a:xfrm>
           <a:prstGeom prst="rect">
             <a:avLst/>
@@ -17503,20 +17899,56 @@
               <a:buNone/>
             </a:pPr>
             <a:r>
-              <a:rPr lang="en-US" sz="2800" b="1" dirty="0">
+              <a:rPr lang="en-US" sz="2600" b="1" dirty="0">
                 <a:solidFill>
                   <a:schemeClr val="tx2"/>
                 </a:solidFill>
               </a:rPr>
-              <a:t>维度一 · 调查对象：样本代表性存疑</a:t>
-            </a:r>
-            <a:endParaRPr lang="en-US" sz="2800" dirty="0"/>
-          </a:p>
-        </p:txBody>
-      </p:sp>
-      <p:sp>
-        <p:nvSpPr>
-          <p:cNvPr id="3" name="进度1"/>
+              <a:t>样本仅为 AI 用户，结论却推及“美国人”</a:t>
+            </a:r>
+            <a:endParaRPr lang="en-US" sz="2600" dirty="0"/>
+          </a:p>
+        </p:txBody>
+      </p:sp>
+      <p:sp>
+        <p:nvSpPr>
+          <p:cNvPr id="3" name="章节标签"/>
+          <p:cNvSpPr txBox="1"/>
+          <p:nvPr/>
+        </p:nvSpPr>
+        <p:spPr>
+          <a:xfrm>
+            <a:off x="548640" y="256032"/>
+            <a:ext cx="7315200" cy="292608"/>
+          </a:xfrm>
+          <a:prstGeom prst="rect">
+            <a:avLst/>
+          </a:prstGeom>
+          <a:noFill/>
+          <a:ln/>
+        </p:spPr>
+        <p:txBody>
+          <a:bodyPr wrap="square" lIns="0" tIns="0" rIns="0" bIns="0" rtlCol="0" anchor="ctr"/>
+          <a:lstStyle/>
+          <a:p>
+            <a:pPr indent="0" marL="0">
+              <a:buNone/>
+            </a:pPr>
+            <a:r>
+              <a:rPr lang="en-US" sz="1200" b="1" dirty="0">
+                <a:solidFill>
+                  <a:schemeClr val="accent1"/>
+                </a:solidFill>
+              </a:rPr>
+              <a:t>四、方法评价 · 维度一  调查对象</a:t>
+            </a:r>
+            <a:endParaRPr lang="en-US" sz="1200" dirty="0"/>
+          </a:p>
+        </p:txBody>
+      </p:sp>
+      <p:sp>
+        <p:nvSpPr>
+          <p:cNvPr id="4" name="进度1"/>
           <p:cNvSpPr/>
           <p:nvPr/>
         </p:nvSpPr>
@@ -17543,7 +17975,7 @@
       </p:sp>
       <p:sp>
         <p:nvSpPr>
-          <p:cNvPr id="4" name="进度文字1"/>
+          <p:cNvPr id="5" name="进度文字1"/>
           <p:cNvSpPr txBox="1"/>
           <p:nvPr/>
         </p:nvSpPr>
@@ -17579,7 +18011,7 @@
       </p:sp>
       <p:sp>
         <p:nvSpPr>
-          <p:cNvPr id="5" name="进度2"/>
+          <p:cNvPr id="6" name="进度2"/>
           <p:cNvSpPr/>
           <p:nvPr/>
         </p:nvSpPr>
@@ -17606,7 +18038,7 @@
       </p:sp>
       <p:sp>
         <p:nvSpPr>
-          <p:cNvPr id="6" name="进度文字2"/>
+          <p:cNvPr id="7" name="进度文字2"/>
           <p:cNvSpPr txBox="1"/>
           <p:nvPr/>
         </p:nvSpPr>
@@ -17642,7 +18074,7 @@
       </p:sp>
       <p:sp>
         <p:nvSpPr>
-          <p:cNvPr id="7" name="进度3"/>
+          <p:cNvPr id="8" name="进度3"/>
           <p:cNvSpPr/>
           <p:nvPr/>
         </p:nvSpPr>
@@ -17669,7 +18101,7 @@
       </p:sp>
       <p:sp>
         <p:nvSpPr>
-          <p:cNvPr id="8" name="进度文字3"/>
+          <p:cNvPr id="9" name="进度文字3"/>
           <p:cNvSpPr txBox="1"/>
           <p:nvPr/>
         </p:nvSpPr>
@@ -17705,7 +18137,7 @@
       </p:sp>
       <p:sp>
         <p:nvSpPr>
-          <p:cNvPr id="9" name="进度4"/>
+          <p:cNvPr id="10" name="进度4"/>
           <p:cNvSpPr/>
           <p:nvPr/>
         </p:nvSpPr>
@@ -17732,7 +18164,7 @@
       </p:sp>
       <p:sp>
         <p:nvSpPr>
-          <p:cNvPr id="10" name="进度文字4"/>
+          <p:cNvPr id="11" name="进度文字4"/>
           <p:cNvSpPr txBox="1"/>
           <p:nvPr/>
         </p:nvSpPr>
@@ -17768,7 +18200,7 @@
       </p:sp>
       <p:sp>
         <p:nvSpPr>
-          <p:cNvPr id="11" name="进度5"/>
+          <p:cNvPr id="12" name="进度5"/>
           <p:cNvSpPr/>
           <p:nvPr/>
         </p:nvSpPr>
@@ -17795,7 +18227,7 @@
       </p:sp>
       <p:sp>
         <p:nvSpPr>
-          <p:cNvPr id="12" name="进度文字5"/>
+          <p:cNvPr id="13" name="进度文字5"/>
           <p:cNvSpPr txBox="1"/>
           <p:nvPr/>
         </p:nvSpPr>
@@ -17831,7 +18263,7 @@
       </p:sp>
       <p:sp>
         <p:nvSpPr>
-          <p:cNvPr id="13" name="总体圈1"/>
+          <p:cNvPr id="14" name="总体圈1"/>
           <p:cNvSpPr/>
           <p:nvPr/>
         </p:nvSpPr>
@@ -17856,7 +18288,7 @@
       </p:sp>
       <p:sp>
         <p:nvSpPr>
-          <p:cNvPr id="14" name="总体标签1"/>
+          <p:cNvPr id="15" name="总体标签1"/>
           <p:cNvSpPr txBox="1"/>
           <p:nvPr/>
         </p:nvSpPr>
@@ -17892,7 +18324,7 @@
       </p:sp>
       <p:sp>
         <p:nvSpPr>
-          <p:cNvPr id="15" name="总体圈2"/>
+          <p:cNvPr id="16" name="总体圈2"/>
           <p:cNvSpPr/>
           <p:nvPr/>
         </p:nvSpPr>
@@ -17917,7 +18349,7 @@
       </p:sp>
       <p:sp>
         <p:nvSpPr>
-          <p:cNvPr id="16" name="总体标签2"/>
+          <p:cNvPr id="17" name="总体标签2"/>
           <p:cNvSpPr txBox="1"/>
           <p:nvPr/>
         </p:nvSpPr>
@@ -17953,7 +18385,7 @@
       </p:sp>
       <p:sp>
         <p:nvSpPr>
-          <p:cNvPr id="17" name="总体圈3"/>
+          <p:cNvPr id="18" name="总体圈3"/>
           <p:cNvSpPr/>
           <p:nvPr/>
         </p:nvSpPr>
@@ -17978,7 +18410,7 @@
       </p:sp>
       <p:sp>
         <p:nvSpPr>
-          <p:cNvPr id="18" name="总体标签3"/>
+          <p:cNvPr id="19" name="总体标签3"/>
           <p:cNvSpPr txBox="1"/>
           <p:nvPr/>
         </p:nvSpPr>
@@ -18014,7 +18446,7 @@
       </p:sp>
       <p:sp>
         <p:nvSpPr>
-          <p:cNvPr id="19" name="总体圈4"/>
+          <p:cNvPr id="20" name="总体圈4"/>
           <p:cNvSpPr/>
           <p:nvPr/>
         </p:nvSpPr>
@@ -18039,7 +18471,7 @@
       </p:sp>
       <p:sp>
         <p:nvSpPr>
-          <p:cNvPr id="20" name="样本标签"/>
+          <p:cNvPr id="21" name="样本标签"/>
           <p:cNvSpPr txBox="1"/>
           <p:nvPr/>
         </p:nvSpPr>
@@ -18092,7 +18524,7 @@
       </p:sp>
       <p:sp>
         <p:nvSpPr>
-          <p:cNvPr id="21" name="事实卡"/>
+          <p:cNvPr id="22" name="事实卡"/>
           <p:cNvSpPr/>
           <p:nvPr/>
         </p:nvSpPr>
@@ -18119,7 +18551,7 @@
       </p:sp>
       <p:sp>
         <p:nvSpPr>
-          <p:cNvPr id="22" name="事实标签"/>
+          <p:cNvPr id="23" name="事实标签"/>
           <p:cNvSpPr/>
           <p:nvPr/>
         </p:nvSpPr>
@@ -18146,7 +18578,7 @@
       </p:sp>
       <p:sp>
         <p:nvSpPr>
-          <p:cNvPr id="23" name="事实标签文字"/>
+          <p:cNvPr id="24" name="事实标签文字"/>
           <p:cNvSpPr txBox="1"/>
           <p:nvPr/>
         </p:nvSpPr>
@@ -18182,7 +18614,7 @@
       </p:sp>
       <p:sp>
         <p:nvSpPr>
-          <p:cNvPr id="24" name="事实内容"/>
+          <p:cNvPr id="25" name="事实内容"/>
           <p:cNvSpPr txBox="1"/>
           <p:nvPr/>
         </p:nvSpPr>
@@ -18210,7 +18642,7 @@
                   <a:schemeClr val="tx1"/>
                 </a:solidFill>
               </a:rPr>
-              <a:t>样本仅为 AI 聊天机器人用户，报告却多处将结论表述为“美国人”；所称“Alpha 世代”仅含 13–14 岁受访者。</a:t>
+              <a:t>样本仅为 AI 聊天机器人用户，结论却表述为“美国人”；“Alpha 世代”仅含 13–14 岁。</a:t>
             </a:r>
             <a:endParaRPr lang="en-US" sz="1400" dirty="0"/>
           </a:p>
@@ -18218,7 +18650,7 @@
       </p:sp>
       <p:sp>
         <p:nvSpPr>
-          <p:cNvPr id="25" name="下箭头"/>
+          <p:cNvPr id="26" name="下箭头"/>
           <p:cNvSpPr txBox="1"/>
           <p:nvPr/>
         </p:nvSpPr>
@@ -18254,7 +18686,7 @@
       </p:sp>
       <p:sp>
         <p:nvSpPr>
-          <p:cNvPr id="26" name="原因卡"/>
+          <p:cNvPr id="27" name="原因卡"/>
           <p:cNvSpPr/>
           <p:nvPr/>
         </p:nvSpPr>
@@ -18281,7 +18713,7 @@
       </p:sp>
       <p:sp>
         <p:nvSpPr>
-          <p:cNvPr id="27" name="原因标签"/>
+          <p:cNvPr id="28" name="原因标签"/>
           <p:cNvSpPr/>
           <p:nvPr/>
         </p:nvSpPr>
@@ -18308,7 +18740,7 @@
       </p:sp>
       <p:sp>
         <p:nvSpPr>
-          <p:cNvPr id="28" name="原因标签文字"/>
+          <p:cNvPr id="29" name="原因标签文字"/>
           <p:cNvSpPr txBox="1"/>
           <p:nvPr/>
         </p:nvSpPr>
@@ -18344,7 +18776,7 @@
       </p:sp>
       <p:sp>
         <p:nvSpPr>
-          <p:cNvPr id="29" name="原因内容"/>
+          <p:cNvPr id="30" name="原因内容"/>
           <p:cNvSpPr txBox="1"/>
           <p:nvPr/>
         </p:nvSpPr>
@@ -18372,7 +18804,7 @@
                   <a:schemeClr val="tx1"/>
                 </a:solidFill>
               </a:rPr>
-              <a:t>线上样本以“使用 AI”为筛选条件，抽样框、加权方法与应答率均未公开，调查总体小于报告推论的总体。</a:t>
+              <a:t>以“使用 AI”为筛选条件的线上样本；抽样框、加权、应答率均未公开。</a:t>
             </a:r>
             <a:endParaRPr lang="en-US" sz="1400" dirty="0"/>
           </a:p>
@@ -18380,7 +18812,7 @@
       </p:sp>
       <p:sp>
         <p:nvSpPr>
-          <p:cNvPr id="30" name="下箭头"/>
+          <p:cNvPr id="31" name="下箭头"/>
           <p:cNvSpPr txBox="1"/>
           <p:nvPr/>
         </p:nvSpPr>
@@ -18416,7 +18848,7 @@
       </p:sp>
       <p:sp>
         <p:nvSpPr>
-          <p:cNvPr id="31" name="影响卡"/>
+          <p:cNvPr id="32" name="影响卡"/>
           <p:cNvSpPr/>
           <p:nvPr/>
         </p:nvSpPr>
@@ -18443,7 +18875,7 @@
       </p:sp>
       <p:sp>
         <p:nvSpPr>
-          <p:cNvPr id="32" name="影响标签"/>
+          <p:cNvPr id="33" name="影响标签"/>
           <p:cNvSpPr/>
           <p:nvPr/>
         </p:nvSpPr>
@@ -18470,7 +18902,7 @@
       </p:sp>
       <p:sp>
         <p:nvSpPr>
-          <p:cNvPr id="33" name="影响标签文字"/>
+          <p:cNvPr id="34" name="影响标签文字"/>
           <p:cNvSpPr txBox="1"/>
           <p:nvPr/>
         </p:nvSpPr>
@@ -18506,7 +18938,7 @@
       </p:sp>
       <p:sp>
         <p:nvSpPr>
-          <p:cNvPr id="34" name="影响内容"/>
+          <p:cNvPr id="35" name="影响内容"/>
           <p:cNvSpPr txBox="1"/>
           <p:nvPr/>
         </p:nvSpPr>
@@ -18534,7 +18966,7 @@
                   <a:schemeClr val="tx1"/>
                 </a:solidFill>
               </a:rPr>
-              <a:t>54%、75% 等数据只能解释为“美国 AI 用户中”的比例；与课上 Durex 网络调查同属覆盖偏差问题。</a:t>
+              <a:t>54%、75% 只代表美国 AI 用户；与课上 Durex 网络调查同属覆盖偏差。</a:t>
             </a:r>
             <a:endParaRPr lang="en-US" sz="1400" dirty="0"/>
           </a:p>
@@ -18542,7 +18974,7 @@
       </p:sp>
       <p:sp>
         <p:nvSpPr>
-          <p:cNvPr id="35" name="来源说明"/>
+          <p:cNvPr id="36" name="来源说明"/>
           <p:cNvSpPr txBox="1"/>
           <p:nvPr/>
         </p:nvSpPr>
@@ -18656,8 +19088,8 @@
         </p:nvSpPr>
         <p:spPr>
           <a:xfrm>
-            <a:off x="548640" y="365760"/>
-            <a:ext cx="7406640" cy="777240"/>
+            <a:off x="548640" y="502920"/>
+            <a:ext cx="7452360" cy="685800"/>
           </a:xfrm>
           <a:prstGeom prst="rect">
             <a:avLst/>
@@ -18673,20 +19105,56 @@
               <a:buNone/>
             </a:pPr>
             <a:r>
-              <a:rPr lang="en-US" sz="2800" b="1" dirty="0">
+              <a:rPr lang="en-US" sz="2600" b="1" dirty="0">
                 <a:solidFill>
                   <a:schemeClr val="tx2"/>
                 </a:solidFill>
               </a:rPr>
-              <a:t>维度二 · 研究总体：六国均值用于美国</a:t>
-            </a:r>
-            <a:endParaRPr lang="en-US" sz="2800" dirty="0"/>
-          </a:p>
-        </p:txBody>
-      </p:sp>
-      <p:sp>
-        <p:nvSpPr>
-          <p:cNvPr id="3" name="进度1"/>
+              <a:t>“14 分钟”是六国均值，美国实为 12 分钟</a:t>
+            </a:r>
+            <a:endParaRPr lang="en-US" sz="2600" dirty="0"/>
+          </a:p>
+        </p:txBody>
+      </p:sp>
+      <p:sp>
+        <p:nvSpPr>
+          <p:cNvPr id="3" name="章节标签"/>
+          <p:cNvSpPr txBox="1"/>
+          <p:nvPr/>
+        </p:nvSpPr>
+        <p:spPr>
+          <a:xfrm>
+            <a:off x="548640" y="256032"/>
+            <a:ext cx="7315200" cy="292608"/>
+          </a:xfrm>
+          <a:prstGeom prst="rect">
+            <a:avLst/>
+          </a:prstGeom>
+          <a:noFill/>
+          <a:ln/>
+        </p:spPr>
+        <p:txBody>
+          <a:bodyPr wrap="square" lIns="0" tIns="0" rIns="0" bIns="0" rtlCol="0" anchor="ctr"/>
+          <a:lstStyle/>
+          <a:p>
+            <a:pPr indent="0" marL="0">
+              <a:buNone/>
+            </a:pPr>
+            <a:r>
+              <a:rPr lang="en-US" sz="1200" b="1" dirty="0">
+                <a:solidFill>
+                  <a:schemeClr val="accent1"/>
+                </a:solidFill>
+              </a:rPr>
+              <a:t>四、方法评价 · 维度二  研究总体</a:t>
+            </a:r>
+            <a:endParaRPr lang="en-US" sz="1200" dirty="0"/>
+          </a:p>
+        </p:txBody>
+      </p:sp>
+      <p:sp>
+        <p:nvSpPr>
+          <p:cNvPr id="4" name="进度1"/>
           <p:cNvSpPr/>
           <p:nvPr/>
         </p:nvSpPr>
@@ -18713,7 +19181,7 @@
       </p:sp>
       <p:sp>
         <p:nvSpPr>
-          <p:cNvPr id="4" name="进度文字1"/>
+          <p:cNvPr id="5" name="进度文字1"/>
           <p:cNvSpPr txBox="1"/>
           <p:nvPr/>
         </p:nvSpPr>
@@ -18749,7 +19217,7 @@
       </p:sp>
       <p:sp>
         <p:nvSpPr>
-          <p:cNvPr id="5" name="进度2"/>
+          <p:cNvPr id="6" name="进度2"/>
           <p:cNvSpPr/>
           <p:nvPr/>
         </p:nvSpPr>
@@ -18776,7 +19244,7 @@
       </p:sp>
       <p:sp>
         <p:nvSpPr>
-          <p:cNvPr id="6" name="进度文字2"/>
+          <p:cNvPr id="7" name="进度文字2"/>
           <p:cNvSpPr txBox="1"/>
           <p:nvPr/>
         </p:nvSpPr>
@@ -18812,7 +19280,7 @@
       </p:sp>
       <p:sp>
         <p:nvSpPr>
-          <p:cNvPr id="7" name="进度3"/>
+          <p:cNvPr id="8" name="进度3"/>
           <p:cNvSpPr/>
           <p:nvPr/>
         </p:nvSpPr>
@@ -18839,7 +19307,7 @@
       </p:sp>
       <p:sp>
         <p:nvSpPr>
-          <p:cNvPr id="8" name="进度文字3"/>
+          <p:cNvPr id="9" name="进度文字3"/>
           <p:cNvSpPr txBox="1"/>
           <p:nvPr/>
         </p:nvSpPr>
@@ -18875,7 +19343,7 @@
       </p:sp>
       <p:sp>
         <p:nvSpPr>
-          <p:cNvPr id="9" name="进度4"/>
+          <p:cNvPr id="10" name="进度4"/>
           <p:cNvSpPr/>
           <p:nvPr/>
         </p:nvSpPr>
@@ -18902,7 +19370,7 @@
       </p:sp>
       <p:sp>
         <p:nvSpPr>
-          <p:cNvPr id="10" name="进度文字4"/>
+          <p:cNvPr id="11" name="进度文字4"/>
           <p:cNvSpPr txBox="1"/>
           <p:nvPr/>
         </p:nvSpPr>
@@ -18938,7 +19406,7 @@
       </p:sp>
       <p:sp>
         <p:nvSpPr>
-          <p:cNvPr id="11" name="进度5"/>
+          <p:cNvPr id="12" name="进度5"/>
           <p:cNvSpPr/>
           <p:nvPr/>
         </p:nvSpPr>
@@ -18965,7 +19433,7 @@
       </p:sp>
       <p:sp>
         <p:nvSpPr>
-          <p:cNvPr id="12" name="进度文字5"/>
+          <p:cNvPr id="13" name="进度文字5"/>
           <p:cNvSpPr txBox="1"/>
           <p:nvPr/>
         </p:nvSpPr>
@@ -19001,7 +19469,7 @@
       </p:sp>
       <p:graphicFrame>
         <p:nvGraphicFramePr>
-          <p:cNvPr id="13" name="分国家寻找时长图" descr=""/>
+          <p:cNvPr id="14" name="分国家寻找时长图" descr=""/>
           <p:cNvGraphicFramePr/>
           <p:nvPr/>
         </p:nvGraphicFramePr>
@@ -19017,7 +19485,7 @@
       </p:graphicFrame>
       <p:sp>
         <p:nvSpPr>
-          <p:cNvPr id="14" name="事实卡"/>
+          <p:cNvPr id="15" name="事实卡"/>
           <p:cNvSpPr/>
           <p:nvPr/>
         </p:nvSpPr>
@@ -19044,7 +19512,7 @@
       </p:sp>
       <p:sp>
         <p:nvSpPr>
-          <p:cNvPr id="15" name="事实标签"/>
+          <p:cNvPr id="16" name="事实标签"/>
           <p:cNvSpPr/>
           <p:nvPr/>
         </p:nvSpPr>
@@ -19071,7 +19539,7 @@
       </p:sp>
       <p:sp>
         <p:nvSpPr>
-          <p:cNvPr id="16" name="事实标签文字"/>
+          <p:cNvPr id="17" name="事实标签文字"/>
           <p:cNvSpPr txBox="1"/>
           <p:nvPr/>
         </p:nvSpPr>
@@ -19107,7 +19575,7 @@
       </p:sp>
       <p:sp>
         <p:nvSpPr>
-          <p:cNvPr id="17" name="事实内容"/>
+          <p:cNvPr id="18" name="事实内容"/>
           <p:cNvSpPr txBox="1"/>
           <p:nvPr/>
         </p:nvSpPr>
@@ -19135,7 +19603,7 @@
                   <a:schemeClr val="tx1"/>
                 </a:solidFill>
               </a:rPr>
-              <a:t>“平均 14 分钟”“54% 可能退订”均来自六国调查；报告将 14 分钟置于描述美国收视情况的图表中。</a:t>
+              <a:t>“14 分钟”“54% 可能退订”均为六国数据，却置于美国收视图表中。</a:t>
             </a:r>
             <a:endParaRPr lang="en-US" sz="1400" dirty="0"/>
           </a:p>
@@ -19143,7 +19611,7 @@
       </p:sp>
       <p:sp>
         <p:nvSpPr>
-          <p:cNvPr id="18" name="下箭头"/>
+          <p:cNvPr id="19" name="下箭头"/>
           <p:cNvSpPr txBox="1"/>
           <p:nvPr/>
         </p:nvSpPr>
@@ -19179,7 +19647,7 @@
       </p:sp>
       <p:sp>
         <p:nvSpPr>
-          <p:cNvPr id="19" name="原因卡"/>
+          <p:cNvPr id="20" name="原因卡"/>
           <p:cNvSpPr/>
           <p:nvPr/>
         </p:nvSpPr>
@@ -19206,7 +19674,7 @@
       </p:sp>
       <p:sp>
         <p:nvSpPr>
-          <p:cNvPr id="20" name="原因标签"/>
+          <p:cNvPr id="21" name="原因标签"/>
           <p:cNvSpPr/>
           <p:nvPr/>
         </p:nvSpPr>
@@ -19233,7 +19701,7 @@
       </p:sp>
       <p:sp>
         <p:nvSpPr>
-          <p:cNvPr id="21" name="原因标签文字"/>
+          <p:cNvPr id="22" name="原因标签文字"/>
           <p:cNvSpPr txBox="1"/>
           <p:nvPr/>
         </p:nvSpPr>
@@ -19269,7 +19737,7 @@
       </p:sp>
       <p:sp>
         <p:nvSpPr>
-          <p:cNvPr id="22" name="原因内容"/>
+          <p:cNvPr id="23" name="原因内容"/>
           <p:cNvSpPr txBox="1"/>
           <p:nvPr/>
         </p:nvSpPr>
@@ -19297,7 +19765,7 @@
                   <a:schemeClr val="tx1"/>
                 </a:solidFill>
               </a:rPr>
-              <a:t>14 分钟为六国简单平均（每国 500 人、等权）；美国为 12 分钟，法国的 26 分钟拉高了均值。报告未标明国家口径。</a:t>
+              <a:t>14 分钟为六国等权简单平均；法国 26 分钟拉高均值，美国为 12 分钟。</a:t>
             </a:r>
             <a:endParaRPr lang="en-US" sz="1400" dirty="0"/>
           </a:p>
@@ -19305,7 +19773,7 @@
       </p:sp>
       <p:sp>
         <p:nvSpPr>
-          <p:cNvPr id="23" name="下箭头"/>
+          <p:cNvPr id="24" name="下箭头"/>
           <p:cNvSpPr txBox="1"/>
           <p:nvPr/>
         </p:nvSpPr>
@@ -19341,7 +19809,7 @@
       </p:sp>
       <p:sp>
         <p:nvSpPr>
-          <p:cNvPr id="24" name="影响卡"/>
+          <p:cNvPr id="25" name="影响卡"/>
           <p:cNvSpPr/>
           <p:nvPr/>
         </p:nvSpPr>
@@ -19368,7 +19836,7 @@
       </p:sp>
       <p:sp>
         <p:nvSpPr>
-          <p:cNvPr id="25" name="影响标签"/>
+          <p:cNvPr id="26" name="影响标签"/>
           <p:cNvSpPr/>
           <p:nvPr/>
         </p:nvSpPr>
@@ -19395,7 +19863,7 @@
       </p:sp>
       <p:sp>
         <p:nvSpPr>
-          <p:cNvPr id="26" name="影响标签文字"/>
+          <p:cNvPr id="27" name="影响标签文字"/>
           <p:cNvSpPr txBox="1"/>
           <p:nvPr/>
         </p:nvSpPr>
@@ -19431,7 +19899,7 @@
       </p:sp>
       <p:sp>
         <p:nvSpPr>
-          <p:cNvPr id="27" name="影响内容"/>
+          <p:cNvPr id="28" name="影响内容"/>
           <p:cNvSpPr txBox="1"/>
           <p:nvPr/>
         </p:nvSpPr>
@@ -19459,7 +19927,7 @@
                   <a:schemeClr val="tx1"/>
                 </a:solidFill>
               </a:rPr>
-              <a:t>读者会高估美国用户的检索困难；“50% 的美国观众考虑退订”在原始报告中仅见六国均值 49%。</a:t>
+              <a:t>高估美国用户的检索困难；“50% 美国观众考虑退订”原文仅见六国 49%。</a:t>
             </a:r>
             <a:endParaRPr lang="en-US" sz="1400" dirty="0"/>
           </a:p>
@@ -19467,7 +19935,7 @@
       </p:sp>
       <p:sp>
         <p:nvSpPr>
-          <p:cNvPr id="28" name="来源说明"/>
+          <p:cNvPr id="29" name="来源说明"/>
           <p:cNvSpPr txBox="1"/>
           <p:nvPr/>
         </p:nvSpPr>

</xml_diff>

<commit_message>
Fold course ideas into the analysis without naming them; plainer wording
Remove explicit references to in-class cases and restate their ideas in
the analysis itself (who was asked, where, when and how; an online
sample's make-up is not the population's). Rewrite titles, slide text,
speaker script and Q&A in a plainer, more natural voice, and balance
line breaks on the evaluation slides.

Co-Authored-By: Claude Opus 5.5 <noreply@anthropic.com>
Claude-Session: https://claude.ai/code/session_01GVqMkWurYUK1ig7fiBE8me
</commit_message>
<xml_diff>
--- a/Gracenote报告解读_课堂汇报.pptx
+++ b/Gracenote报告解读_课堂汇报.pptx
@@ -120,13 +120,13 @@
   <p:extLst>
     <p:ext uri="{521415D9-36F7-43E2-AB2F-B90AF26B5E84}">
       <p14:sectionLst xmlns:p14="http://schemas.microsoft.com/office/powerpoint/2010/main">
-        <p14:section name="开场" id="{4f627cb9-d809-8f6f-e1c3-1c9d89cf9fb2}">
+        <p14:section name="开场" id="{ae1897af-1cd9-c287-f9c3-001bdc18e597}">
           <p14:sldIdLst>
             <p14:sldId id="256"/>
             <p14:sldId id="257"/>
           </p14:sldIdLst>
         </p14:section>
-        <p14:section name="报告介绍" id="{99f81809-54be-4ea0-971a-0082ebf230f4}">
+        <p14:section name="报告介绍" id="{afa19afb-e8fc-dc17-ef62-8025774af16b}">
           <p14:sldIdLst>
             <p14:sldId id="258"/>
             <p14:sldId id="259"/>
@@ -134,7 +134,7 @@
             <p14:sldId id="261"/>
           </p14:sldIdLst>
         </p14:section>
-        <p14:section name="方法评价" id="{416134a8-8737-1f41-7fdb-f8afd7f563e6}">
+        <p14:section name="方法评价" id="{8fca11d5-64a1-f392-853a-581e5e94b38a}">
           <p14:sldIdLst>
             <p14:sldId id="262"/>
             <p14:sldId id="263"/>
@@ -143,12 +143,12 @@
             <p14:sldId id="266"/>
           </p14:sldIdLst>
         </p14:section>
-        <p14:section name="总结" id="{e8d22a79-b18f-928f-fbe6-e4747363fd09}">
+        <p14:section name="总结" id="{71a53c45-c2c8-630a-07d4-4192f3b8e689}">
           <p14:sldIdLst>
             <p14:sldId id="267"/>
           </p14:sldIdLst>
         </p14:section>
-        <p14:section name="附录（备问）" id="{9241cb5f-220d-0e2c-d48f-c6c176bc0de3}">
+        <p14:section name="附录（备问）" id="{eceb5e98-d75d-d3c8-9602-5ef0f73d470d}">
           <p14:sldIdLst>
             <p14:sldId id="268"/>
             <p14:sldId id="269"/>
@@ -917,7 +917,7 @@
           <a:p>
             <a:r>
               <a:rPr lang="en-US" dirty="0"/>
-              <a:t>【约 25 秒】各位同学好。我汇报的是尼尔森旗下 Gracenote 公司 2026 年的报告《AI 时代的电视搜索与内容发现》。报告称 54% 的 13 至 14 岁受访者每天使用 AI。这一数据代表哪类人群，是本次汇报的出发点。</a:t>
+              <a:t>【约 20 秒】大家好。我读的是尼尔森旗下 Gracenote 今年 4 月的一份报告。里面有个很醒目的数字：13 到 14 岁的受访者，54% 每天都用 AI。我想从这个数字出发，看看它到底代表了哪些人。</a:t>
             </a:r>
             <a:endParaRPr lang="en-US" dirty="0"/>
           </a:p>
@@ -1005,7 +1005,7 @@
           <a:p>
             <a:r>
               <a:rPr lang="en-US" dirty="0"/>
-              <a:t>【约 25 秒】维度三，调查时间：两项调查分母不同，“加速”的结论不成立。报告将皮尤 2025 年秋的 30% 与自身 2026 年初的 54% 对比；但皮尤是全体青少年，同为 13 至 14 岁仅 24%。统一为使用者口径后，差距约 10 个百分点。</a:t>
+              <a:t>【约 25 秒】第三，比较的时间和对象。报告拿皮尤去年秋天的 30%，比自己今年初的 54%，说使用在“加速”。可皮尤问的是全体青少年，同样 13 到 14 岁只有 24%；报告只问了 AI 用户。分母统一后，差距约 10 个百分点。</a:t>
             </a:r>
             <a:endParaRPr lang="en-US" dirty="0"/>
           </a:p>
@@ -1093,7 +1093,7 @@
           <a:p>
             <a:r>
               <a:rPr lang="en-US" dirty="0"/>
-              <a:t>【约 20 秒】维度四，研究方法：四类异质数据不足以证明“检索困难导致退订”。这四类是退订意向、行业退订率、市场预测和 AI 测试，对象和性质各不相同，又无追踪或实验设计，只能提示可能相关。</a:t>
+              <a:t>【约 20 秒】最后是方法。“找不到就退订”这一环，靠的是四种性质不同的数据：有的是想法，有的是实际行为，有的只是预测。报告也没有跟踪同一批人，所以这些数据能说明两件事相关，说明不了谁导致了谁。</a:t>
             </a:r>
             <a:endParaRPr lang="en-US" dirty="0"/>
           </a:p>
@@ -1181,7 +1181,7 @@
           <a:p>
             <a:r>
               <a:rPr lang="en-US" dirty="0"/>
-              <a:t>【约 30 秒】回到论证链：两环部分成立，两环证据不足。前两环只适用于 AI 用户；第三环口径混用、因果未证；第四环尚未检验。因此，报告可作为趋势参考，不宜作为精确估计或因果证据。最后提出一个问题：如何设计调查，才能检验“检索困难导致退订”？谢谢。</a:t>
+              <a:t>【约 30 秒】回到这条推理链：前两环大体成立，但只适用于 AI 用户；后两环证据还不够。报告把样本量和时间交代得很清楚，数字也经得起复算；只是一个醒目的数字，常常把它怎么测出来的省略了。最后留个问题：要验证“找不到就退订”，调查该怎么设计？谢谢。</a:t>
             </a:r>
             <a:endParaRPr lang="en-US" dirty="0"/>
           </a:p>
@@ -1445,7 +1445,7 @@
           <a:p>
             <a:r>
               <a:rPr lang="en-US" dirty="0"/>
-              <a:t>【约 10 秒】汇报分为五部分。核心观点是：报告的趋势判断有参考价值，但论证链的关键环节证据不足。</a:t>
+              <a:t>【约 15 秒】我的看法先放在前面：报告看到的趋势大体可信，但它把一群 AI 用户的回答，推成了更大人群的结论。下面按背景、设计、内容、评价、总结五部分展开。</a:t>
             </a:r>
             <a:endParaRPr lang="en-US" dirty="0"/>
           </a:p>
@@ -1533,7 +1533,7 @@
           <a:p>
             <a:r>
               <a:rPr lang="en-US" dirty="0"/>
-              <a:t>【约 30 秒】研究背景是：流媒体平台增多、内容分散，用户检索节目的难度上升，AI 也成为新的检索工具。报告由此提出三个问题：用户如何使用 AI、检索困难是否影响订阅、用户是否信任 AI。另需注意，Gracenote 的主营业务正是节目数据服务。</a:t>
+              <a:t>【约 20 秒】先说背景。平台越来越多，节目越来越难找，不少人干脆直接问 AI。报告想回答三件事：怎么用 AI 找信息，找不到节目会不会退订，信不信 AI。另外，Gracenote 本身就做节目数据。</a:t>
             </a:r>
             <a:endParaRPr lang="en-US" dirty="0"/>
           </a:p>
@@ -1621,7 +1621,7 @@
           <a:p>
             <a:r>
               <a:rPr lang="en-US" dirty="0"/>
-              <a:t>【约 25 秒】报告的结论主要来自两项线上问卷。调查一于 2026 年初进行，对象是 4003 名 13 至 79 岁的美国 AI 聊天机器人用户；调查二于 2025 年夏季进行，覆盖六国，每国 500 名流媒体用户。两项调查均未公开抽样方式。</a:t>
+              <a:t>【约 20 秒】报告的大部分结论来自两份线上问卷：一份今年年初问了 4003 名美国 AI 用户，13 到 79 岁；另一份去年夏天在六个国家各问了 500 名流媒体用户。样本怎么抽的，两份都没有交代。</a:t>
             </a:r>
             <a:endParaRPr lang="en-US" dirty="0"/>
           </a:p>
@@ -1709,7 +1709,7 @@
           <a:p>
             <a:r>
               <a:rPr lang="en-US" dirty="0"/>
-              <a:t>【约 30 秒】第一组发现是 AI 使用增加、信任不足：13 至 14 岁的 AI 用户中 54% 每天使用，但 75% 的受访者会核查 AI 的回答。报告的解释是：AI 能给出直接、完整的答案，因而受到偏好；但大模型可能生成看似合理的错误信息，因而难以被完全信任。</a:t>
+              <a:t>【约 25 秒】第一组发现：年轻人越来越依赖 AI，却不完全信任它。13 到 14 岁的 AI 用户里，54% 每天都用，但也有 75% 的人会回头核对。报告的解释是，AI 回答直接，所以受欢迎；可它也会给出看似合理的错误答案，所以还得再查一遍。</a:t>
             </a:r>
             <a:endParaRPr lang="en-US" dirty="0"/>
           </a:p>
@@ -1797,7 +1797,7 @@
           <a:p>
             <a:r>
               <a:rPr lang="en-US" dirty="0"/>
-              <a:t>【约 25 秒】第二组发现是内容分散导致检索困难：联网电视已占美国电视时长的 54%，用户平均花 14 分钟找节目，18 至 34 岁中 54% 表示可能因此退订，而 AI 只答对约三分之二的播出平台。报告据此主张 AI 须接入可信的行业数据。</a:t>
+              <a:t>【约 25 秒】第二组发现是一条推理链：内容分散，用户平均要花 14 分钟找节目；18 到 34 岁的人里，54% 说找不到可能会退订；而 AI 只能答对约三分之二的播出平台。所以报告主张，AI 需要接入可靠的行业数据。</a:t>
             </a:r>
             <a:endParaRPr lang="en-US" dirty="0"/>
           </a:p>
@@ -1885,7 +1885,7 @@
           <a:p>
             <a:r>
               <a:rPr lang="en-US" dirty="0"/>
-              <a:t>【约 15 秒】报告的论证可以整理为一条链：依赖 AI、不信任 AI、检索困难导致退订、AI 须接入可信数据。下面参照课上春晚案例的四个维度，逐环检验。</a:t>
+              <a:t>【约 15 秒】这条推理有四个环节。同一个问题，问的是谁、问哪里的人、什么时候问、怎么问，答案都可能不一样。我就从这四个角度，逐环看证据站不站得住。</a:t>
             </a:r>
             <a:endParaRPr lang="en-US" dirty="0"/>
           </a:p>
@@ -1973,7 +1973,7 @@
           <a:p>
             <a:r>
               <a:rPr lang="en-US" dirty="0"/>
-              <a:t>【约 25 秒】维度一，调查对象：样本仅为 AI 用户，结论却推及“美国人”。原因是样本以“使用 AI”为筛选条件。因此，54% 和 75% 只能理解为 AI 用户中的比例，这与课上 Durex 网络调查的问题相同。</a:t>
+              <a:t>【约 20 秒】先看问的是谁。4003 名受访者都是 AI 聊天机器人用户，样本本身就偏向会用 AI 的人，报告却常把结论说成“美国人”。网络样本的结构不等于总体，54% 和 75% 只能算 AI 用户内部的比例。</a:t>
             </a:r>
             <a:endParaRPr lang="en-US" dirty="0"/>
           </a:p>
@@ -2061,7 +2061,7 @@
           <a:p>
             <a:r>
               <a:rPr lang="en-US" dirty="0"/>
-              <a:t>【约 20 秒】维度二，研究总体：“14 分钟”是六国均值，美国实为 12 分钟。它是六国简单平均，法国的 26 分钟拉高了均值；报告却把它放进描述美国收视的图表，会使读者高估美国用户的检索困难。</a:t>
+              <a:t>【约 20 秒】再看是哪里的人。“平均 14 分钟”其实来自六国调查，是六个国家直接平均出来的；美国是 12 分钟，法国是 26 分钟。报告把它放进一张讲美国收视的图里，读者很容易以为美国人也要找 14 分钟。</a:t>
             </a:r>
             <a:endParaRPr lang="en-US" dirty="0"/>
           </a:p>
@@ -3160,7 +3160,7 @@
                   <a:schemeClr val="accent3"/>
                 </a:solidFill>
               </a:rPr>
-              <a:t>04  方法评价 · 维度三  调查时间</a:t>
+              <a:t>04  方法评价 · 调查时间</a:t>
             </a:r>
             <a:endParaRPr lang="en-US" sz="1400" dirty="0"/>
           </a:p>
@@ -3198,7 +3198,7 @@
                   <a:schemeClr val="tx2"/>
                 </a:solidFill>
               </a:rPr>
-              <a:t>两项调查分母不同，“加速”结论不成立</a:t>
+              <a:t>分母不一样，“加速”也就无从谈起</a:t>
             </a:r>
             <a:endParaRPr lang="en-US" sz="3000" dirty="0"/>
           </a:p>
@@ -3628,7 +3628,21 @@
                   <a:schemeClr val="tx1"/>
                 </a:solidFill>
               </a:rPr>
-              <a:t>以皮尤 30% 对比本报告 54%，称使用“加速”</a:t>
+              <a:t>拿皮尤去年秋的 30%，</a:t>
+            </a:r>
+            <a:endParaRPr lang="en-US" sz="1800" dirty="0"/>
+          </a:p>
+          <a:p>
+            <a:pPr indent="0" marL="0">
+              <a:buNone/>
+            </a:pPr>
+            <a:r>
+              <a:rPr lang="en-US" sz="1800" dirty="0">
+                <a:solidFill>
+                  <a:schemeClr val="tx1"/>
+                </a:solidFill>
+              </a:rPr>
+              <a:t>比本报告今年初的 54%</a:t>
             </a:r>
             <a:endParaRPr lang="en-US" sz="1800" dirty="0"/>
           </a:p>
@@ -3754,7 +3768,21 @@
                   <a:schemeClr val="tx1"/>
                 </a:solidFill>
               </a:rPr>
-              <a:t>分母不同：全体青少年 vs AI 用户</a:t>
+              <a:t>皮尤问全体青少年，</a:t>
+            </a:r>
+            <a:endParaRPr lang="en-US" sz="1800" dirty="0"/>
+          </a:p>
+          <a:p>
+            <a:pPr indent="0" marL="0">
+              <a:buNone/>
+            </a:pPr>
+            <a:r>
+              <a:rPr lang="en-US" sz="1800" dirty="0">
+                <a:solidFill>
+                  <a:schemeClr val="tx1"/>
+                </a:solidFill>
+              </a:rPr>
+              <a:t>本报告只问 AI 用户</a:t>
             </a:r>
             <a:endParaRPr lang="en-US" sz="1800" dirty="0"/>
           </a:p>
@@ -3880,7 +3908,21 @@
                   <a:schemeClr val="tx1"/>
                 </a:solidFill>
               </a:rPr>
-              <a:t>同一口径下差距仅约 10 个百分点</a:t>
+              <a:t>分母统一后，</a:t>
+            </a:r>
+            <a:endParaRPr lang="en-US" sz="1800" dirty="0"/>
+          </a:p>
+          <a:p>
+            <a:pPr indent="0" marL="0">
+              <a:buNone/>
+            </a:pPr>
+            <a:r>
+              <a:rPr lang="en-US" sz="1800" dirty="0">
+                <a:solidFill>
+                  <a:schemeClr val="tx1"/>
+                </a:solidFill>
+              </a:rPr>
+              <a:t>差距只剩约 10 个百分点</a:t>
             </a:r>
             <a:endParaRPr lang="en-US" sz="1800" dirty="0"/>
           </a:p>
@@ -4022,7 +4064,7 @@
                   <a:schemeClr val="accent3"/>
                 </a:solidFill>
               </a:rPr>
-              <a:t>04  方法评价 · 维度四  研究方法</a:t>
+              <a:t>04  方法评价 · 研究方法</a:t>
             </a:r>
             <a:endParaRPr lang="en-US" sz="1400" dirty="0"/>
           </a:p>
@@ -4060,7 +4102,7 @@
                   <a:schemeClr val="tx2"/>
                 </a:solidFill>
               </a:rPr>
-              <a:t>四类数据不足以证明“检索困难导致退订”</a:t>
+              <a:t>几类不同的数据，拼不出“找不到就退订”</a:t>
             </a:r>
             <a:endParaRPr lang="en-US" sz="3000" dirty="0"/>
           </a:p>
@@ -4594,7 +4636,21 @@
                   <a:schemeClr val="tx1"/>
                 </a:solidFill>
               </a:rPr>
-              <a:t>因果链由四类不同数据拼接而成</a:t>
+              <a:t>意愿、退订率、预测、测试</a:t>
+            </a:r>
+            <a:endParaRPr lang="en-US" sz="1800" dirty="0"/>
+          </a:p>
+          <a:p>
+            <a:pPr indent="0" marL="0">
+              <a:buNone/>
+            </a:pPr>
+            <a:r>
+              <a:rPr lang="en-US" sz="1800" dirty="0">
+                <a:solidFill>
+                  <a:schemeClr val="tx1"/>
+                </a:solidFill>
+              </a:rPr>
+              <a:t>被串成一条链</a:t>
             </a:r>
             <a:endParaRPr lang="en-US" sz="1800" dirty="0"/>
           </a:p>
@@ -4720,7 +4776,21 @@
                   <a:schemeClr val="tx1"/>
                 </a:solidFill>
               </a:rPr>
-              <a:t>数据性质不同，且无追踪或实验</a:t>
+              <a:t>有的是想法，有的是行为，</a:t>
+            </a:r>
+            <a:endParaRPr lang="en-US" sz="1800" dirty="0"/>
+          </a:p>
+          <a:p>
+            <a:pPr indent="0" marL="0">
+              <a:buNone/>
+            </a:pPr>
+            <a:r>
+              <a:rPr lang="en-US" sz="1800" dirty="0">
+                <a:solidFill>
+                  <a:schemeClr val="tx1"/>
+                </a:solidFill>
+              </a:rPr>
+              <a:t>有的只是预测</a:t>
             </a:r>
             <a:endParaRPr lang="en-US" sz="1800" dirty="0"/>
           </a:p>
@@ -4846,7 +4916,21 @@
                   <a:schemeClr val="tx1"/>
                 </a:solidFill>
               </a:rPr>
-              <a:t>只能提示相关，不能证明因果</a:t>
+              <a:t>能说明相关，</a:t>
+            </a:r>
+            <a:endParaRPr lang="en-US" sz="1800" dirty="0"/>
+          </a:p>
+          <a:p>
+            <a:pPr indent="0" marL="0">
+              <a:buNone/>
+            </a:pPr>
+            <a:r>
+              <a:rPr lang="en-US" sz="1800" dirty="0">
+                <a:solidFill>
+                  <a:schemeClr val="tx1"/>
+                </a:solidFill>
+              </a:rPr>
+              <a:t>说明不了谁导致了谁</a:t>
             </a:r>
             <a:endParaRPr lang="en-US" sz="1800" dirty="0"/>
           </a:p>
@@ -5026,7 +5110,7 @@
                   <a:schemeClr val="bg1"/>
                 </a:solidFill>
               </a:rPr>
-              <a:t>两环部分成立、两环证据不足：结论应限于 AI 用户</a:t>
+              <a:t>趋势可以参考，结论需要收窄</a:t>
             </a:r>
             <a:endParaRPr lang="en-US" sz="3000" dirty="0"/>
           </a:p>
@@ -5341,7 +5425,7 @@
                   <a:schemeClr val="bg1"/>
                 </a:solidFill>
               </a:rPr>
-              <a:t>③ 检索难致退订</a:t>
+              <a:t>③ 难找致退订</a:t>
             </a:r>
             <a:endParaRPr lang="en-US" sz="2000" dirty="0"/>
           </a:p>
@@ -5467,7 +5551,7 @@
                   <a:schemeClr val="bg1"/>
                 </a:solidFill>
               </a:rPr>
-              <a:t>④ 接入可信数据</a:t>
+              <a:t>④ 接入可靠数据</a:t>
             </a:r>
             <a:endParaRPr lang="en-US" sz="2000" dirty="0"/>
           </a:p>
@@ -5566,7 +5650,7 @@
                   <a:schemeClr val="accent4"/>
                 </a:solidFill>
               </a:rPr>
-              <a:t>优点：</a:t>
+              <a:t>可取之处：</a:t>
             </a:r>
             <a:pPr indent="0" marL="0">
               <a:buNone/>
@@ -5577,7 +5661,7 @@
                   <a:schemeClr val="accent6"/>
                 </a:solidFill>
               </a:rPr>
-              <a:t>公开了样本量、时间与年龄范围，图表数据经复核基本一致。</a:t>
+              <a:t>样本量、时间、年龄都交代清楚，图里的数字经得起复算。</a:t>
             </a:r>
             <a:endParaRPr lang="en-US" sz="1600" dirty="0"/>
           </a:p>
@@ -5643,7 +5727,7 @@
                   <a:schemeClr val="accent3"/>
                 </a:solidFill>
               </a:rPr>
-              <a:t>讨论问题</a:t>
+              <a:t>留给大家</a:t>
             </a:r>
             <a:endParaRPr lang="en-US" sz="1600" dirty="0"/>
           </a:p>
@@ -5660,7 +5744,7 @@
                   <a:schemeClr val="tx2"/>
                 </a:solidFill>
               </a:rPr>
-              <a:t>如何设计调查，才能检验“检索困难导致退订”？</a:t>
+              <a:t>要验证“找不到就退订”，调查该怎么设计？</a:t>
             </a:r>
             <a:endParaRPr lang="en-US" sz="1600" dirty="0"/>
           </a:p>
@@ -5804,7 +5888,7 @@
                   <a:schemeClr val="tx2"/>
                 </a:solidFill>
               </a:rPr>
-              <a:t>11 个数据来源中，核心两项问卷最不透明</a:t>
+              <a:t>11 个来源里，报告自己的两份问卷最不透明</a:t>
             </a:r>
             <a:endParaRPr lang="en-US" sz="3000" dirty="0"/>
           </a:p>
@@ -7293,7 +7377,7 @@
                   <a:schemeClr val="tx2"/>
                 </a:solidFill>
               </a:rPr>
-              <a:t>多处引用与原始来源的口径不一致</a:t>
+              <a:t>几处引用，和原始来源的说法并不一致</a:t>
             </a:r>
             <a:endParaRPr lang="en-US" sz="3000" dirty="0"/>
           </a:p>
@@ -8371,7 +8455,7 @@
                   <a:schemeClr val="tx2"/>
                 </a:solidFill>
               </a:rPr>
-              <a:t>趋势可参考，但论证链关键环节证据不足</a:t>
+              <a:t>趋势大体可信，但结论推得太远</a:t>
             </a:r>
             <a:endParaRPr lang="en-US" sz="3000" dirty="0"/>
           </a:p>
@@ -8947,7 +9031,7 @@
                   <a:schemeClr val="accent4"/>
                 </a:solidFill>
               </a:rPr>
-              <a:t>核心观点</a:t>
+              <a:t>我的判断</a:t>
             </a:r>
             <a:endParaRPr lang="en-US" sz="1600" dirty="0"/>
           </a:p>
@@ -8964,7 +9048,7 @@
                   <a:schemeClr val="bg1"/>
                 </a:solidFill>
               </a:rPr>
-              <a:t>报告的趋势判断有参考价值；但论证的关键环节证据不足，结论应限于调查对象。</a:t>
+              <a:t>报告看到的趋势大体可信；问题在于，它把一群 AI 用户的回答，推成了更大人群的结论。</a:t>
             </a:r>
             <a:endParaRPr lang="en-US" sz="1600" dirty="0"/>
           </a:p>
@@ -9108,7 +9192,7 @@
                   <a:schemeClr val="tx2"/>
                 </a:solidFill>
               </a:rPr>
-              <a:t>内容分散使检索变难，AI 能否成为新入口？</a:t>
+              <a:t>节目越来越难找，AI 会不会成为新的入口？</a:t>
             </a:r>
             <a:endParaRPr lang="en-US" sz="3000" dirty="0"/>
           </a:p>
@@ -9207,7 +9291,7 @@
                   <a:schemeClr val="tx2"/>
                 </a:solidFill>
               </a:rPr>
-              <a:t>使用行为</a:t>
+              <a:t>怎么用 AI</a:t>
             </a:r>
             <a:endParaRPr lang="en-US" sz="2600" dirty="0"/>
           </a:p>
@@ -9243,7 +9327,7 @@
                   <a:schemeClr val="tx1"/>
                 </a:solidFill>
               </a:rPr>
-              <a:t>各年龄群体如何用 AI 检索信息？</a:t>
+              <a:t>不同年龄的人，如何用 AI 找信息？</a:t>
             </a:r>
             <a:endParaRPr lang="en-US" sz="1800" dirty="0"/>
           </a:p>
@@ -9342,7 +9426,7 @@
                   <a:schemeClr val="tx2"/>
                 </a:solidFill>
               </a:rPr>
-              <a:t>检索困难</a:t>
+              <a:t>找不到会怎样</a:t>
             </a:r>
             <a:endParaRPr lang="en-US" sz="2600" dirty="0"/>
           </a:p>
@@ -9378,7 +9462,7 @@
                   <a:schemeClr val="tx1"/>
                 </a:solidFill>
               </a:rPr>
-              <a:t>内容分散是否影响订阅？</a:t>
+              <a:t>节目难找，会不会让人退订？</a:t>
             </a:r>
             <a:endParaRPr lang="en-US" sz="1800" dirty="0"/>
           </a:p>
@@ -9477,7 +9561,7 @@
                   <a:schemeClr val="tx2"/>
                 </a:solidFill>
               </a:rPr>
-              <a:t>信任程度</a:t>
+              <a:t>信不信 AI</a:t>
             </a:r>
             <a:endParaRPr lang="en-US" sz="2600" dirty="0"/>
           </a:p>
@@ -9513,7 +9597,7 @@
                   <a:schemeClr val="tx1"/>
                 </a:solidFill>
               </a:rPr>
-              <a:t>用户是否信任 AI 的回答？</a:t>
+              <a:t>人们是否相信 AI 给的答案？</a:t>
             </a:r>
             <a:endParaRPr lang="en-US" sz="1800" dirty="0"/>
           </a:p>
@@ -9587,7 +9671,7 @@
                   <a:schemeClr val="bg1"/>
                 </a:solidFill>
               </a:rPr>
-              <a:t>Gracenote，尼尔森旗下，主营节目数据服务——与报告主张直接相关。</a:t>
+              <a:t>Gracenote 隶属尼尔森，本身就做节目数据；报告最后的建议，恰好落在它自己的业务上。</a:t>
             </a:r>
             <a:endParaRPr lang="en-US" sz="1600" dirty="0"/>
           </a:p>
@@ -9731,7 +9815,7 @@
                   <a:schemeClr val="tx2"/>
                 </a:solidFill>
               </a:rPr>
-              <a:t>报告结论主要来自两项线上问卷</a:t>
+              <a:t>两份线上问卷，撑起了报告的大部分结论</a:t>
             </a:r>
             <a:endParaRPr lang="en-US" sz="3000" dirty="0"/>
           </a:p>
@@ -10541,7 +10625,7 @@
                   <a:schemeClr val="tx1"/>
                 </a:solidFill>
               </a:rPr>
-              <a:t>两项调查均未公开抽样方式。另引用尼尔森、皮尤等共 11 个来源（见附录）。</a:t>
+              <a:t>样本如何抽取，两份调查都没有交代。另引用尼尔森、皮尤等共 11 个来源（见附录）。</a:t>
             </a:r>
             <a:endParaRPr lang="en-US" sz="1800" dirty="0"/>
           </a:p>
@@ -10685,7 +10769,7 @@
                   <a:schemeClr val="tx2"/>
                 </a:solidFill>
               </a:rPr>
-              <a:t>报告发现：年轻用户依赖 AI，但信任不足</a:t>
+              <a:t>年轻人越来越依赖 AI，却并不完全信任它</a:t>
             </a:r>
             <a:endParaRPr lang="en-US" sz="3000" dirty="0"/>
           </a:p>
@@ -10801,7 +10885,7 @@
                   <a:schemeClr val="tx1"/>
                 </a:solidFill>
               </a:rPr>
-              <a:t>每天使用</a:t>
+              <a:t>每天都用</a:t>
             </a:r>
             <a:endParaRPr lang="en-US" sz="2000" dirty="0"/>
           </a:p>
@@ -10903,7 +10987,7 @@
                   <a:schemeClr val="tx1"/>
                 </a:solidFill>
               </a:rPr>
-              <a:t>受访者会核查</a:t>
+              <a:t>受访者会回头</a:t>
             </a:r>
             <a:endParaRPr lang="en-US" sz="2000" dirty="0"/>
           </a:p>
@@ -10917,7 +11001,7 @@
                   <a:schemeClr val="tx1"/>
                 </a:solidFill>
               </a:rPr>
-              <a:t>AI 的回答</a:t>
+              <a:t>核对 AI 的答案</a:t>
             </a:r>
             <a:endParaRPr lang="en-US" sz="2000" dirty="0"/>
           </a:p>
@@ -11016,7 +11100,7 @@
                   <a:schemeClr val="tx1"/>
                 </a:solidFill>
               </a:rPr>
-              <a:t>AI 回答直接、完整、可追问</a:t>
+              <a:t>AI 能直接给出答案，还能接着追问</a:t>
             </a:r>
             <a:endParaRPr lang="en-US" sz="1800" dirty="0"/>
           </a:p>
@@ -11060,7 +11144,7 @@
       </p:sp>
       <p:sp>
         <p:nvSpPr>
-          <p:cNvPr id="14" name="标签：用户偏好 AI"/>
+          <p:cNvPr id="14" name="标签：所以受欢迎"/>
           <p:cNvSpPr/>
           <p:nvPr/>
         </p:nvSpPr>
@@ -11087,7 +11171,7 @@
       </p:sp>
       <p:sp>
         <p:nvSpPr>
-          <p:cNvPr id="15" name="标签文字：用户偏好 AI"/>
+          <p:cNvPr id="15" name="标签文字：所以受欢迎"/>
           <p:cNvSpPr txBox="1"/>
           <p:nvPr/>
         </p:nvSpPr>
@@ -11115,7 +11199,7 @@
                   <a:schemeClr val="bg1"/>
                 </a:solidFill>
               </a:rPr>
-              <a:t>用户偏好 AI</a:t>
+              <a:t>所以受欢迎</a:t>
             </a:r>
             <a:endParaRPr lang="en-US" sz="1700" dirty="0"/>
           </a:p>
@@ -11178,7 +11262,7 @@
                   <a:schemeClr val="tx1"/>
                 </a:solidFill>
               </a:rPr>
-              <a:t>大模型可能生成看似合理的错误信息</a:t>
+              <a:t>但它也会给出看似合理的错误答案</a:t>
             </a:r>
             <a:endParaRPr lang="en-US" sz="1800" dirty="0"/>
           </a:p>
@@ -11222,7 +11306,7 @@
       </p:sp>
       <p:sp>
         <p:nvSpPr>
-          <p:cNvPr id="19" name="标签：用户难以完全信任"/>
+          <p:cNvPr id="19" name="标签：所以还要再核对"/>
           <p:cNvSpPr/>
           <p:nvPr/>
         </p:nvSpPr>
@@ -11249,7 +11333,7 @@
       </p:sp>
       <p:sp>
         <p:nvSpPr>
-          <p:cNvPr id="20" name="标签文字：用户难以完全信任"/>
+          <p:cNvPr id="20" name="标签文字：所以还要再核对"/>
           <p:cNvSpPr txBox="1"/>
           <p:nvPr/>
         </p:nvSpPr>
@@ -11277,7 +11361,7 @@
                   <a:schemeClr val="bg1"/>
                 </a:solidFill>
               </a:rPr>
-              <a:t>用户难以完全信任</a:t>
+              <a:t>所以还要再核对</a:t>
             </a:r>
             <a:endParaRPr lang="en-US" sz="1700" dirty="0"/>
           </a:p>
@@ -11421,7 +11505,7 @@
                   <a:schemeClr val="tx2"/>
                 </a:solidFill>
               </a:rPr>
-              <a:t>报告认为：内容分散导致退订，AI 须接入可信数据</a:t>
+              <a:t>从内容分散到用户流失，报告这样推理</a:t>
             </a:r>
             <a:endParaRPr lang="en-US" sz="3000" dirty="0"/>
           </a:p>
@@ -11595,7 +11679,21 @@
                   <a:schemeClr val="tx1"/>
                 </a:solidFill>
               </a:rPr>
-              <a:t>美国电视时长来自联网电视</a:t>
+              <a:t>联网电视占</a:t>
+            </a:r>
+            <a:endParaRPr lang="en-US" sz="1600" dirty="0"/>
+          </a:p>
+          <a:p>
+            <a:pPr indent="0" marL="0">
+              <a:buNone/>
+            </a:pPr>
+            <a:r>
+              <a:rPr lang="en-US" sz="1600" dirty="0">
+                <a:solidFill>
+                  <a:schemeClr val="tx1"/>
+                </a:solidFill>
+              </a:rPr>
+              <a:t>美国电视时长</a:t>
             </a:r>
             <a:endParaRPr lang="en-US" sz="1600" dirty="0"/>
           </a:p>
@@ -11730,7 +11828,7 @@
                   <a:schemeClr val="tx2"/>
                 </a:solidFill>
               </a:rPr>
-              <a:t>检索变难</a:t>
+              <a:t>找起来费时</a:t>
             </a:r>
             <a:endParaRPr lang="en-US" sz="2100" dirty="0"/>
           </a:p>
@@ -11805,7 +11903,7 @@
                   <a:schemeClr val="tx1"/>
                 </a:solidFill>
               </a:rPr>
-              <a:t>平均寻找节目时长</a:t>
+              <a:t>平均找一个节目</a:t>
             </a:r>
             <a:endParaRPr lang="en-US" sz="1600" dirty="0"/>
           </a:p>
@@ -11940,7 +12038,7 @@
                   <a:schemeClr val="tx2"/>
                 </a:solidFill>
               </a:rPr>
-              <a:t>退订风险</a:t>
+              <a:t>可能退订</a:t>
             </a:r>
             <a:endParaRPr lang="en-US" sz="2100" dirty="0"/>
           </a:p>
@@ -12015,7 +12113,7 @@
                   <a:schemeClr val="tx1"/>
                 </a:solidFill>
               </a:rPr>
-              <a:t>18–34 岁表示可能退订</a:t>
+              <a:t>18–34 岁说可能退订</a:t>
             </a:r>
             <a:endParaRPr lang="en-US" sz="1600" dirty="0"/>
           </a:p>
@@ -12150,7 +12248,7 @@
                   <a:schemeClr val="bg1"/>
                 </a:solidFill>
               </a:rPr>
-              <a:t>接入可信数据</a:t>
+              <a:t>接入可靠数据</a:t>
             </a:r>
             <a:endParaRPr lang="en-US" sz="2100" dirty="0"/>
           </a:p>
@@ -12225,7 +12323,7 @@
                   <a:schemeClr val="accent6"/>
                 </a:solidFill>
               </a:rPr>
-              <a:t>AI 答对播出平台</a:t>
+              <a:t>AI 能答对的播出平台</a:t>
             </a:r>
             <a:endParaRPr lang="en-US" sz="1600" dirty="0"/>
           </a:p>
@@ -12405,7 +12503,7 @@
                   <a:schemeClr val="tx2"/>
                 </a:solidFill>
               </a:rPr>
-              <a:t>用课上四个维度，逐环检验报告的论证</a:t>
+              <a:t>沿着这条推理，逐环看证据站不站得住</a:t>
             </a:r>
             <a:endParaRPr lang="en-US" sz="3000" dirty="0"/>
           </a:p>
@@ -12594,38 +12692,38 @@
           <a:bodyPr wrap="square" lIns="0" tIns="0" rIns="0" bIns="0" rtlCol="0" anchor="ctr"/>
           <a:lstStyle/>
           <a:p>
-            <a:pPr indent="0" marL="0">
+            <a:pPr algn="ctr" indent="0" marL="0">
               <a:spcAft>
                 <a:spcPts val="600"/>
               </a:spcAft>
               <a:buNone/>
             </a:pPr>
             <a:r>
-              <a:rPr lang="en-US" sz="1800" b="1" dirty="0">
+              <a:rPr lang="en-US" sz="2000" b="1" dirty="0">
                 <a:solidFill>
                   <a:schemeClr val="accent1"/>
                 </a:solidFill>
               </a:rPr>
-              <a:t>维度一  调查对象</a:t>
-            </a:r>
-            <a:endParaRPr lang="en-US" sz="1800" dirty="0"/>
-          </a:p>
-          <a:p>
-            <a:pPr indent="0" marL="0">
+              <a:t>调查对象</a:t>
+            </a:r>
+            <a:endParaRPr lang="en-US" sz="2000" dirty="0"/>
+          </a:p>
+          <a:p>
+            <a:pPr algn="ctr" indent="0" marL="0">
               <a:spcAft>
                 <a:spcPts val="600"/>
               </a:spcAft>
               <a:buNone/>
             </a:pPr>
             <a:r>
-              <a:rPr lang="en-US" sz="1800" b="1" dirty="0">
+              <a:rPr lang="en-US" sz="2000" b="1" dirty="0">
                 <a:solidFill>
                   <a:schemeClr val="accent1"/>
                 </a:solidFill>
               </a:rPr>
-              <a:t>维度三  调查时间</a:t>
-            </a:r>
-            <a:endParaRPr lang="en-US" sz="1800" dirty="0"/>
+              <a:t>调查时间</a:t>
+            </a:r>
+            <a:endParaRPr lang="en-US" sz="2000" dirty="0"/>
           </a:p>
         </p:txBody>
       </p:sp>
@@ -12812,21 +12910,21 @@
           <a:bodyPr wrap="square" lIns="0" tIns="0" rIns="0" bIns="0" rtlCol="0" anchor="ctr"/>
           <a:lstStyle/>
           <a:p>
-            <a:pPr indent="0" marL="0">
+            <a:pPr algn="ctr" indent="0" marL="0">
               <a:spcAft>
                 <a:spcPts val="600"/>
               </a:spcAft>
               <a:buNone/>
             </a:pPr>
             <a:r>
-              <a:rPr lang="en-US" sz="1800" b="1" dirty="0">
+              <a:rPr lang="en-US" sz="2000" b="1" dirty="0">
                 <a:solidFill>
                   <a:schemeClr val="accent1"/>
                 </a:solidFill>
               </a:rPr>
-              <a:t>维度一  调查对象</a:t>
-            </a:r>
-            <a:endParaRPr lang="en-US" sz="1800" dirty="0"/>
+              <a:t>调查对象</a:t>
+            </a:r>
+            <a:endParaRPr lang="en-US" sz="2000" dirty="0"/>
           </a:p>
         </p:txBody>
       </p:sp>
@@ -12887,7 +12985,7 @@
                   <a:schemeClr val="bg1"/>
                 </a:solidFill>
               </a:rPr>
-              <a:t>③ 检索难致退订</a:t>
+              <a:t>③ 难找致退订</a:t>
             </a:r>
             <a:endParaRPr lang="en-US" sz="2000" dirty="0"/>
           </a:p>
@@ -13013,38 +13111,38 @@
           <a:bodyPr wrap="square" lIns="0" tIns="0" rIns="0" bIns="0" rtlCol="0" anchor="ctr"/>
           <a:lstStyle/>
           <a:p>
-            <a:pPr indent="0" marL="0">
+            <a:pPr algn="ctr" indent="0" marL="0">
               <a:spcAft>
                 <a:spcPts val="600"/>
               </a:spcAft>
               <a:buNone/>
             </a:pPr>
             <a:r>
-              <a:rPr lang="en-US" sz="1800" b="1" dirty="0">
+              <a:rPr lang="en-US" sz="2000" b="1" dirty="0">
                 <a:solidFill>
                   <a:schemeClr val="accent1"/>
                 </a:solidFill>
               </a:rPr>
-              <a:t>维度二  研究总体</a:t>
-            </a:r>
-            <a:endParaRPr lang="en-US" sz="1800" dirty="0"/>
-          </a:p>
-          <a:p>
-            <a:pPr indent="0" marL="0">
+              <a:t>研究总体</a:t>
+            </a:r>
+            <a:endParaRPr lang="en-US" sz="2000" dirty="0"/>
+          </a:p>
+          <a:p>
+            <a:pPr algn="ctr" indent="0" marL="0">
               <a:spcAft>
                 <a:spcPts val="600"/>
               </a:spcAft>
               <a:buNone/>
             </a:pPr>
             <a:r>
-              <a:rPr lang="en-US" sz="1800" b="1" dirty="0">
+              <a:rPr lang="en-US" sz="2000" b="1" dirty="0">
                 <a:solidFill>
                   <a:schemeClr val="accent1"/>
                 </a:solidFill>
               </a:rPr>
-              <a:t>维度四  研究方法</a:t>
-            </a:r>
-            <a:endParaRPr lang="en-US" sz="1800" dirty="0"/>
+              <a:t>研究方法</a:t>
+            </a:r>
+            <a:endParaRPr lang="en-US" sz="2000" dirty="0"/>
           </a:p>
         </p:txBody>
       </p:sp>
@@ -13105,7 +13203,7 @@
                   <a:schemeClr val="bg1"/>
                 </a:solidFill>
               </a:rPr>
-              <a:t>④ 接入可信数据</a:t>
+              <a:t>④ 接入可靠数据</a:t>
             </a:r>
             <a:endParaRPr lang="en-US" sz="2000" dirty="0"/>
           </a:p>
@@ -13195,21 +13293,21 @@
           <a:bodyPr wrap="square" lIns="0" tIns="0" rIns="0" bIns="0" rtlCol="0" anchor="ctr"/>
           <a:lstStyle/>
           <a:p>
-            <a:pPr indent="0" marL="0">
+            <a:pPr algn="ctr" indent="0" marL="0">
               <a:spcAft>
                 <a:spcPts val="600"/>
               </a:spcAft>
               <a:buNone/>
             </a:pPr>
             <a:r>
-              <a:rPr lang="en-US" sz="1800" b="1" dirty="0">
+              <a:rPr lang="en-US" sz="2000" b="1" dirty="0">
                 <a:solidFill>
                   <a:schemeClr val="accent1"/>
                 </a:solidFill>
               </a:rPr>
-              <a:t>维度四  研究方法</a:t>
-            </a:r>
-            <a:endParaRPr lang="en-US" sz="1800" dirty="0"/>
+              <a:t>研究方法</a:t>
+            </a:r>
+            <a:endParaRPr lang="en-US" sz="2000" dirty="0"/>
           </a:p>
         </p:txBody>
       </p:sp>
@@ -13270,7 +13368,7 @@
                   <a:schemeClr val="accent3"/>
                 </a:solidFill>
               </a:rPr>
-              <a:t>依据：</a:t>
+              <a:t>为什么看这四处：</a:t>
             </a:r>
             <a:pPr indent="0" marL="0">
               <a:buNone/>
@@ -13281,7 +13379,7 @@
                   <a:schemeClr val="tx1"/>
                 </a:solidFill>
               </a:rPr>
-              <a:t>课上春晚满意度调查案例——对象、总体、时间、方法不同，结论不同。</a:t>
+              <a:t>同一个问题，问谁、问哪里的人、什么时候问、怎么问，得到的答案都可能不同。</a:t>
             </a:r>
             <a:endParaRPr lang="en-US" sz="1800" dirty="0"/>
           </a:p>
@@ -13387,7 +13485,7 @@
                   <a:schemeClr val="accent3"/>
                 </a:solidFill>
               </a:rPr>
-              <a:t>04  方法评价 · 维度一  调查对象</a:t>
+              <a:t>04  方法评价 · 调查对象</a:t>
             </a:r>
             <a:endParaRPr lang="en-US" sz="1400" dirty="0"/>
           </a:p>
@@ -13425,7 +13523,7 @@
                   <a:schemeClr val="tx2"/>
                 </a:solidFill>
               </a:rPr>
-              <a:t>样本仅为 AI 用户，结论却推及“美国人”</a:t>
+              <a:t>问的是 AI 用户，说的却是“美国人”</a:t>
             </a:r>
             <a:endParaRPr lang="en-US" sz="3000" dirty="0"/>
           </a:p>
@@ -13812,7 +13910,21 @@
                   <a:schemeClr val="tx1"/>
                 </a:solidFill>
               </a:rPr>
-              <a:t>样本是 4,003 名 AI 聊天机器人用户</a:t>
+              <a:t>4,003 名受访者</a:t>
+            </a:r>
+            <a:endParaRPr lang="en-US" sz="1800" dirty="0"/>
+          </a:p>
+          <a:p>
+            <a:pPr indent="0" marL="0">
+              <a:buNone/>
+            </a:pPr>
+            <a:r>
+              <a:rPr lang="en-US" sz="1800" dirty="0">
+                <a:solidFill>
+                  <a:schemeClr val="tx1"/>
+                </a:solidFill>
+              </a:rPr>
+              <a:t>全是 AI 聊天机器人用户</a:t>
             </a:r>
             <a:endParaRPr lang="en-US" sz="1800" dirty="0"/>
           </a:p>
@@ -13938,7 +14050,21 @@
                   <a:schemeClr val="tx1"/>
                 </a:solidFill>
               </a:rPr>
-              <a:t>以“使用 AI”为条件筛选的线上样本</a:t>
+              <a:t>按“用不用 AI”筛选，</a:t>
+            </a:r>
+            <a:endParaRPr lang="en-US" sz="1800" dirty="0"/>
+          </a:p>
+          <a:p>
+            <a:pPr indent="0" marL="0">
+              <a:buNone/>
+            </a:pPr>
+            <a:r>
+              <a:rPr lang="en-US" sz="1800" dirty="0">
+                <a:solidFill>
+                  <a:schemeClr val="tx1"/>
+                </a:solidFill>
+              </a:rPr>
+              <a:t>样本偏向会用的人</a:t>
             </a:r>
             <a:endParaRPr lang="en-US" sz="1800" dirty="0"/>
           </a:p>
@@ -14064,7 +14190,21 @@
                   <a:schemeClr val="tx1"/>
                 </a:solidFill>
               </a:rPr>
-              <a:t>结论只适用于 AI 用户，与课上 Durex 案例同类</a:t>
+              <a:t>网络样本不等于总体，</a:t>
+            </a:r>
+            <a:endParaRPr lang="en-US" sz="1800" dirty="0"/>
+          </a:p>
+          <a:p>
+            <a:pPr indent="0" marL="0">
+              <a:buNone/>
+            </a:pPr>
+            <a:r>
+              <a:rPr lang="en-US" sz="1800" dirty="0">
+                <a:solidFill>
+                  <a:schemeClr val="tx1"/>
+                </a:solidFill>
+              </a:rPr>
+              <a:t>结论只适用于 AI 用户</a:t>
             </a:r>
             <a:endParaRPr lang="en-US" sz="1800" dirty="0"/>
           </a:p>
@@ -14206,7 +14346,7 @@
                   <a:schemeClr val="accent3"/>
                 </a:solidFill>
               </a:rPr>
-              <a:t>04  方法评价 · 维度二  研究总体</a:t>
+              <a:t>04  方法评价 · 研究总体</a:t>
             </a:r>
             <a:endParaRPr lang="en-US" sz="1400" dirty="0"/>
           </a:p>
@@ -14244,7 +14384,7 @@
                   <a:schemeClr val="tx2"/>
                 </a:solidFill>
               </a:rPr>
-              <a:t>“14 分钟”是六国均值，美国实为 12 分钟</a:t>
+              <a:t>“14 分钟”其实是六国平均，美国是 12 分钟</a:t>
             </a:r>
             <a:endParaRPr lang="en-US" sz="3000" dirty="0"/>
           </a:p>
@@ -14386,7 +14526,21 @@
                   <a:schemeClr val="tx1"/>
                 </a:solidFill>
               </a:rPr>
-              <a:t>六国均值被放进美国收视图表</a:t>
+              <a:t>图里的“14 分钟”，</a:t>
+            </a:r>
+            <a:endParaRPr lang="en-US" sz="1800" dirty="0"/>
+          </a:p>
+          <a:p>
+            <a:pPr indent="0" marL="0">
+              <a:buNone/>
+            </a:pPr>
+            <a:r>
+              <a:rPr lang="en-US" sz="1800" dirty="0">
+                <a:solidFill>
+                  <a:schemeClr val="tx1"/>
+                </a:solidFill>
+              </a:rPr>
+              <a:t>是六个国家的平均</a:t>
             </a:r>
             <a:endParaRPr lang="en-US" sz="1800" dirty="0"/>
           </a:p>
@@ -14512,7 +14666,21 @@
                   <a:schemeClr val="tx1"/>
                 </a:solidFill>
               </a:rPr>
-              <a:t>法国 26 分钟拉高了等权均值</a:t>
+              <a:t>六国直接平均，</a:t>
+            </a:r>
+            <a:endParaRPr lang="en-US" sz="1800" dirty="0"/>
+          </a:p>
+          <a:p>
+            <a:pPr indent="0" marL="0">
+              <a:buNone/>
+            </a:pPr>
+            <a:r>
+              <a:rPr lang="en-US" sz="1800" dirty="0">
+                <a:solidFill>
+                  <a:schemeClr val="tx1"/>
+                </a:solidFill>
+              </a:rPr>
+              <a:t>法国的 26 分钟拉高了它</a:t>
             </a:r>
             <a:endParaRPr lang="en-US" sz="1800" dirty="0"/>
           </a:p>
@@ -14638,7 +14806,21 @@
                   <a:schemeClr val="tx1"/>
                 </a:solidFill>
               </a:rPr>
-              <a:t>高估美国用户的检索困难</a:t>
+              <a:t>放进美国收视图里，</a:t>
+            </a:r>
+            <a:endParaRPr lang="en-US" sz="1800" dirty="0"/>
+          </a:p>
+          <a:p>
+            <a:pPr indent="0" marL="0">
+              <a:buNone/>
+            </a:pPr>
+            <a:r>
+              <a:rPr lang="en-US" sz="1800" dirty="0">
+                <a:solidFill>
+                  <a:schemeClr val="tx1"/>
+                </a:solidFill>
+              </a:rPr>
+              <a:t>容易高估美国的困难</a:t>
             </a:r>
             <a:endParaRPr lang="en-US" sz="1800" dirty="0"/>
           </a:p>

</xml_diff>

<commit_message>
Rewrite slide and script wording in a plain, natural register
Drop slogan-style antitheses, rhetorical labels and parallel lists in
favour of plain declarative sentences; remove the '(重点)' tag and the
'我的判断 / 留给大家 / 可取之处' labels; titles now state concrete facts.

Co-Authored-By: Claude Opus 5.5 <noreply@anthropic.com>
Claude-Session: https://claude.ai/code/session_01GVqMkWurYUK1ig7fiBE8me
</commit_message>
<xml_diff>
--- a/Gracenote报告解读_课堂汇报.pptx
+++ b/Gracenote报告解读_课堂汇报.pptx
@@ -120,13 +120,13 @@
   <p:extLst>
     <p:ext uri="{521415D9-36F7-43E2-AB2F-B90AF26B5E84}">
       <p14:sectionLst xmlns:p14="http://schemas.microsoft.com/office/powerpoint/2010/main">
-        <p14:section name="开场" id="{ae1897af-1cd9-c287-f9c3-001bdc18e597}">
+        <p14:section name="开场" id="{7236708e-6632-68ed-795b-be9b9dc6b72f}">
           <p14:sldIdLst>
             <p14:sldId id="256"/>
             <p14:sldId id="257"/>
           </p14:sldIdLst>
         </p14:section>
-        <p14:section name="报告介绍" id="{afa19afb-e8fc-dc17-ef62-8025774af16b}">
+        <p14:section name="报告介绍" id="{b403a56f-1af2-5158-c7b4-106d3ceb85cd}">
           <p14:sldIdLst>
             <p14:sldId id="258"/>
             <p14:sldId id="259"/>
@@ -134,7 +134,7 @@
             <p14:sldId id="261"/>
           </p14:sldIdLst>
         </p14:section>
-        <p14:section name="方法评价" id="{8fca11d5-64a1-f392-853a-581e5e94b38a}">
+        <p14:section name="方法评价" id="{6ea40926-f546-cbdd-c379-2fea83c8c218}">
           <p14:sldIdLst>
             <p14:sldId id="262"/>
             <p14:sldId id="263"/>
@@ -143,12 +143,12 @@
             <p14:sldId id="266"/>
           </p14:sldIdLst>
         </p14:section>
-        <p14:section name="总结" id="{71a53c45-c2c8-630a-07d4-4192f3b8e689}">
+        <p14:section name="总结" id="{c95d22b6-39ab-a8e2-d737-0778e6a3556e}">
           <p14:sldIdLst>
             <p14:sldId id="267"/>
           </p14:sldIdLst>
         </p14:section>
-        <p14:section name="附录（备问）" id="{eceb5e98-d75d-d3c8-9602-5ef0f73d470d}">
+        <p14:section name="附录（备问）" id="{c70fcf27-1e1c-f053-6bb2-b798cc6c6e9f}">
           <p14:sldIdLst>
             <p14:sldId id="268"/>
             <p14:sldId id="269"/>
@@ -917,7 +917,7 @@
           <a:p>
             <a:r>
               <a:rPr lang="en-US" dirty="0"/>
-              <a:t>【约 20 秒】大家好。我读的是尼尔森旗下 Gracenote 今年 4 月的一份报告。里面有个很醒目的数字：13 到 14 岁的受访者，54% 每天都用 AI。我想从这个数字出发，看看它到底代表了哪些人。</a:t>
+              <a:t>【约 25 秒】大家好，我汇报的是尼尔森旗下 Gracenote 今年 4 月发布的一份报告，讲 AI 时代人们怎样找电视节目。报告提到，13 到 14 岁的受访者中有 54% 每天使用 AI。我想先弄清楚，这个比例是在哪些人中得出的。</a:t>
             </a:r>
             <a:endParaRPr lang="en-US" dirty="0"/>
           </a:p>
@@ -1005,7 +1005,7 @@
           <a:p>
             <a:r>
               <a:rPr lang="en-US" dirty="0"/>
-              <a:t>【约 25 秒】第三，比较的时间和对象。报告拿皮尤去年秋天的 30%，比自己今年初的 54%，说使用在“加速”。可皮尤问的是全体青少年，同样 13 到 14 岁只有 24%；报告只问了 AI 用户。分母统一后，差距约 10 个百分点。</a:t>
+              <a:t>【约 25 秒】第三是调查时间和比较对象。报告用皮尤去年秋天的 30% 对比自己今年初的 54%，认为使用在加速。但皮尤调查的是全体青少年，同样 13 到 14 岁只有 24%；本报告只调查 AI 用户。换成相同分母，两者只差约 10 个百分点。</a:t>
             </a:r>
             <a:endParaRPr lang="en-US" dirty="0"/>
           </a:p>
@@ -1093,7 +1093,7 @@
           <a:p>
             <a:r>
               <a:rPr lang="en-US" dirty="0"/>
-              <a:t>【约 20 秒】最后是方法。“找不到就退订”这一环，靠的是四种性质不同的数据：有的是想法，有的是实际行为，有的只是预测。报告也没有跟踪同一批人，所以这些数据能说明两件事相关，说明不了谁导致了谁。</a:t>
+              <a:t>【约 25 秒】第四是方法。报告用来说明“节目难找导致退订”的，是四种性质不同的数据：退订意愿、实际退订率、市场预测和 AI 测试。报告也没有追踪同一批用户，所以这些数据只能说明两者有关，不能说明前者导致后者。</a:t>
             </a:r>
             <a:endParaRPr lang="en-US" dirty="0"/>
           </a:p>
@@ -1181,7 +1181,7 @@
           <a:p>
             <a:r>
               <a:rPr lang="en-US" dirty="0"/>
-              <a:t>【约 30 秒】回到这条推理链：前两环大体成立，但只适用于 AI 用户；后两环证据还不够。报告把样本量和时间交代得很清楚，数字也经得起复算；只是一个醒目的数字，常常把它怎么测出来的省略了。最后留个问题：要验证“找不到就退订”，调查该怎么设计？谢谢。</a:t>
+              <a:t>【约 25 秒】总的来看，前两步在 AI 用户中基本成立，后两步证据不够。报告的样本量、调查时间和年龄范围写得很清楚，图里的数字也能复算。最后想请大家想一想：要验证节目难找会不会导致退订，调查应该怎么设计？谢谢。</a:t>
             </a:r>
             <a:endParaRPr lang="en-US" dirty="0"/>
           </a:p>
@@ -1445,7 +1445,7 @@
           <a:p>
             <a:r>
               <a:rPr lang="en-US" dirty="0"/>
-              <a:t>【约 15 秒】我的看法先放在前面：报告看到的趋势大体可信，但它把一群 AI 用户的回答，推成了更大人群的结论。下面按背景、设计、内容、评价、总结五部分展开。</a:t>
+              <a:t>【约 15 秒】我的看法是，这份报告说明了 AI 用户的一些变化，这部分可以参考；但它常把这群用户的回答，写成美国人整体的情况。汇报分五个部分。</a:t>
             </a:r>
             <a:endParaRPr lang="en-US" dirty="0"/>
           </a:p>
@@ -1533,7 +1533,7 @@
           <a:p>
             <a:r>
               <a:rPr lang="en-US" dirty="0"/>
-              <a:t>【约 20 秒】先说背景。平台越来越多，节目越来越难找，不少人干脆直接问 AI。报告想回答三件事：怎么用 AI 找信息，找不到节目会不会退订，信不信 AI。另外，Gracenote 本身就做节目数据。</a:t>
+              <a:t>【约 25 秒】先介绍背景。平台越来越多，找节目变得费时，不少人开始直接问 AI。报告关心三个问题：人们怎样用 AI 找信息，找节目难不难、会不会因此退订，以及是否相信 AI 的答案。另外，Gracenote 本身做节目数据。</a:t>
             </a:r>
             <a:endParaRPr lang="en-US" dirty="0"/>
           </a:p>
@@ -1621,7 +1621,7 @@
           <a:p>
             <a:r>
               <a:rPr lang="en-US" dirty="0"/>
-              <a:t>【约 20 秒】报告的大部分结论来自两份线上问卷：一份今年年初问了 4003 名美国 AI 用户，13 到 79 岁；另一份去年夏天在六个国家各问了 500 名流媒体用户。样本怎么抽的，两份都没有交代。</a:t>
+              <a:t>【约 25 秒】报告的数据主要来自两份线上问卷。第一份在今年一到二月，调查了 4003 名 13 到 79 岁的美国 AI 聊天机器人用户；第二份在去年夏天，调查了六个国家的流媒体用户，每国 500 人。两份调查都没有说明样本是怎么抽取的。</a:t>
             </a:r>
             <a:endParaRPr lang="en-US" dirty="0"/>
           </a:p>
@@ -1709,7 +1709,7 @@
           <a:p>
             <a:r>
               <a:rPr lang="en-US" dirty="0"/>
-              <a:t>【约 25 秒】第一组发现：年轻人越来越依赖 AI，却不完全信任它。13 到 14 岁的 AI 用户里，54% 每天都用，但也有 75% 的人会回头核对。报告的解释是，AI 回答直接，所以受欢迎；可它也会给出看似合理的错误答案，所以还得再查一遍。</a:t>
+              <a:t>【约 25 秒】报告的第一组发现是，13 到 14 岁的 AI 用户中有 54% 每天使用；同时 75% 的受访者会核对 AI 的答案。报告认为，AI 回答直接、可以追问，所以用得越来越多；但它有时会给出错误信息，所以多数人还会再核对。</a:t>
             </a:r>
             <a:endParaRPr lang="en-US" dirty="0"/>
           </a:p>
@@ -1797,7 +1797,7 @@
           <a:p>
             <a:r>
               <a:rPr lang="en-US" dirty="0"/>
-              <a:t>【约 25 秒】第二组发现是一条推理链：内容分散，用户平均要花 14 分钟找节目；18 到 34 岁的人里，54% 说找不到可能会退订；而 AI 只能答对约三分之二的播出平台。所以报告主张，AI 需要接入可靠的行业数据。</a:t>
+              <a:t>【约 25 秒】第二组发现与找节目有关。用户平均要花 14 分钟找节目，18 到 34 岁的受访者中有 54% 表示可能因此退订，而 AI 只能答对约三分之二节目的播出平台。报告据此建议，AI 应该接入可靠的行业数据。</a:t>
             </a:r>
             <a:endParaRPr lang="en-US" dirty="0"/>
           </a:p>
@@ -1885,7 +1885,7 @@
           <a:p>
             <a:r>
               <a:rPr lang="en-US" dirty="0"/>
-              <a:t>【约 15 秒】这条推理有四个环节。同一个问题，问的是谁、问哪里的人、什么时候问、怎么问，答案都可能不一样。我就从这四个角度，逐环看证据站不站得住。</a:t>
+              <a:t>【约 10 秒】这条推理可以分成四步。调查结果会随调查对象、范围、时间和方法而变化，所以我从这四个方面分别检查。</a:t>
             </a:r>
             <a:endParaRPr lang="en-US" dirty="0"/>
           </a:p>
@@ -1973,7 +1973,7 @@
           <a:p>
             <a:r>
               <a:rPr lang="en-US" dirty="0"/>
-              <a:t>【约 20 秒】先看问的是谁。4003 名受访者都是 AI 聊天机器人用户，样本本身就偏向会用 AI 的人，报告却常把结论说成“美国人”。网络样本的结构不等于总体，54% 和 75% 只能算 AI 用户内部的比例。</a:t>
+              <a:t>【约 20 秒】第一是调查对象。这 4003 名受访者都是 AI 聊天机器人用户，没有包括不用 AI 的人。线上样本的构成和总体不同，所以 54% 和 75% 只能说明 AI 用户的情况，不能直接推到全体美国人。</a:t>
             </a:r>
             <a:endParaRPr lang="en-US" dirty="0"/>
           </a:p>
@@ -2061,7 +2061,7 @@
           <a:p>
             <a:r>
               <a:rPr lang="en-US" dirty="0"/>
-              <a:t>【约 20 秒】再看是哪里的人。“平均 14 分钟”其实来自六国调查，是六个国家直接平均出来的；美国是 12 分钟，法国是 26 分钟。报告把它放进一张讲美国收视的图里，读者很容易以为美国人也要找 14 分钟。</a:t>
+              <a:t>【约 20 秒】第二是调查范围。“平均 14 分钟”来自六国调查，是六个国家的平均值；美国是 12 分钟，法国是 26 分钟。报告把这个数字放在一张讲美国收视的图里，读者容易以为美国人也要找 14 分钟。</a:t>
             </a:r>
             <a:endParaRPr lang="en-US" dirty="0"/>
           </a:p>
@@ -3099,7 +3099,7 @@
                   <a:schemeClr val="tx2"/>
                 </a:solidFill>
               </a:rPr>
-              <a:t>该数据代表哪类人群？</a:t>
+              <a:t>这个比例来自哪些人？</a:t>
             </a:r>
             <a:endParaRPr lang="en-US" sz="1800" dirty="0"/>
           </a:p>
@@ -3198,7 +3198,7 @@
                   <a:schemeClr val="tx2"/>
                 </a:solidFill>
               </a:rPr>
-              <a:t>分母不一样，“加速”也就无从谈起</a:t>
+              <a:t>两项调查的分母不同，不能说明使用在“加速”</a:t>
             </a:r>
             <a:endParaRPr lang="en-US" sz="3000" dirty="0"/>
           </a:p>
@@ -3628,7 +3628,7 @@
                   <a:schemeClr val="tx1"/>
                 </a:solidFill>
               </a:rPr>
-              <a:t>拿皮尤去年秋的 30%，</a:t>
+              <a:t>报告用皮尤去年秋的 30%</a:t>
             </a:r>
             <a:endParaRPr lang="en-US" sz="1800" dirty="0"/>
           </a:p>
@@ -3642,7 +3642,7 @@
                   <a:schemeClr val="tx1"/>
                 </a:solidFill>
               </a:rPr>
-              <a:t>比本报告今年初的 54%</a:t>
+              <a:t>对比自己今年初的 54%</a:t>
             </a:r>
             <a:endParaRPr lang="en-US" sz="1800" dirty="0"/>
           </a:p>
@@ -3768,7 +3768,7 @@
                   <a:schemeClr val="tx1"/>
                 </a:solidFill>
               </a:rPr>
-              <a:t>皮尤问全体青少年，</a:t>
+              <a:t>皮尤调查全体青少年，</a:t>
             </a:r>
             <a:endParaRPr lang="en-US" sz="1800" dirty="0"/>
           </a:p>
@@ -3782,7 +3782,7 @@
                   <a:schemeClr val="tx1"/>
                 </a:solidFill>
               </a:rPr>
-              <a:t>本报告只问 AI 用户</a:t>
+              <a:t>本报告只调查 AI 用户</a:t>
             </a:r>
             <a:endParaRPr lang="en-US" sz="1800" dirty="0"/>
           </a:p>
@@ -3908,7 +3908,7 @@
                   <a:schemeClr val="tx1"/>
                 </a:solidFill>
               </a:rPr>
-              <a:t>分母统一后，</a:t>
+              <a:t>换成相同分母后，</a:t>
             </a:r>
             <a:endParaRPr lang="en-US" sz="1800" dirty="0"/>
           </a:p>
@@ -3922,7 +3922,7 @@
                   <a:schemeClr val="tx1"/>
                 </a:solidFill>
               </a:rPr>
-              <a:t>差距只剩约 10 个百分点</a:t>
+              <a:t>两者只差约 10 个百分点</a:t>
             </a:r>
             <a:endParaRPr lang="en-US" sz="1800" dirty="0"/>
           </a:p>
@@ -4102,7 +4102,7 @@
                   <a:schemeClr val="tx2"/>
                 </a:solidFill>
               </a:rPr>
-              <a:t>几类不同的数据，拼不出“找不到就退订”</a:t>
+              <a:t>现有数据不足以证明节目难找会导致退订</a:t>
             </a:r>
             <a:endParaRPr lang="en-US" sz="3000" dirty="0"/>
           </a:p>
@@ -4636,7 +4636,7 @@
                   <a:schemeClr val="tx1"/>
                 </a:solidFill>
               </a:rPr>
-              <a:t>意愿、退订率、预测、测试</a:t>
+              <a:t>报告把退订意愿、退订率、</a:t>
             </a:r>
             <a:endParaRPr lang="en-US" sz="1800" dirty="0"/>
           </a:p>
@@ -4650,7 +4650,7 @@
                   <a:schemeClr val="tx1"/>
                 </a:solidFill>
               </a:rPr>
-              <a:t>被串成一条链</a:t>
+              <a:t>市场预测和 AI 测试放在一起</a:t>
             </a:r>
             <a:endParaRPr lang="en-US" sz="1800" dirty="0"/>
           </a:p>
@@ -4776,7 +4776,7 @@
                   <a:schemeClr val="tx1"/>
                 </a:solidFill>
               </a:rPr>
-              <a:t>有的是想法，有的是行为，</a:t>
+              <a:t>这些数据性质不同，</a:t>
             </a:r>
             <a:endParaRPr lang="en-US" sz="1800" dirty="0"/>
           </a:p>
@@ -4790,7 +4790,7 @@
                   <a:schemeClr val="tx1"/>
                 </a:solidFill>
               </a:rPr>
-              <a:t>有的只是预测</a:t>
+              <a:t>也没有追踪同一批人</a:t>
             </a:r>
             <a:endParaRPr lang="en-US" sz="1800" dirty="0"/>
           </a:p>
@@ -4916,7 +4916,7 @@
                   <a:schemeClr val="tx1"/>
                 </a:solidFill>
               </a:rPr>
-              <a:t>能说明相关，</a:t>
+              <a:t>只能说明两者有关，</a:t>
             </a:r>
             <a:endParaRPr lang="en-US" sz="1800" dirty="0"/>
           </a:p>
@@ -4930,7 +4930,7 @@
                   <a:schemeClr val="tx1"/>
                 </a:solidFill>
               </a:rPr>
-              <a:t>说明不了谁导致了谁</a:t>
+              <a:t>不能说明前者导致后者</a:t>
             </a:r>
             <a:endParaRPr lang="en-US" sz="1800" dirty="0"/>
           </a:p>
@@ -5110,7 +5110,7 @@
                   <a:schemeClr val="bg1"/>
                 </a:solidFill>
               </a:rPr>
-              <a:t>趋势可以参考，结论需要收窄</a:t>
+              <a:t>报告的结论，更适合用来描述 AI 用户群体</a:t>
             </a:r>
             <a:endParaRPr lang="en-US" sz="3000" dirty="0"/>
           </a:p>
@@ -5425,7 +5425,7 @@
                   <a:schemeClr val="bg1"/>
                 </a:solidFill>
               </a:rPr>
-              <a:t>③ 难找致退订</a:t>
+              <a:t>③ 难找导致退订</a:t>
             </a:r>
             <a:endParaRPr lang="en-US" sz="2000" dirty="0"/>
           </a:p>
@@ -5551,7 +5551,7 @@
                   <a:schemeClr val="bg1"/>
                 </a:solidFill>
               </a:rPr>
-              <a:t>④ 接入可靠数据</a:t>
+              <a:t>④ 接入行业数据</a:t>
             </a:r>
             <a:endParaRPr lang="en-US" sz="2000" dirty="0"/>
           </a:p>
@@ -5645,23 +5645,12 @@
               <a:buNone/>
             </a:pPr>
             <a:r>
-              <a:rPr lang="en-US" sz="1600" b="1" dirty="0">
-                <a:solidFill>
-                  <a:schemeClr val="accent4"/>
-                </a:solidFill>
-              </a:rPr>
-              <a:t>可取之处：</a:t>
-            </a:r>
-            <a:pPr indent="0" marL="0">
-              <a:buNone/>
-            </a:pPr>
-            <a:r>
               <a:rPr lang="en-US" sz="1600" dirty="0">
                 <a:solidFill>
                   <a:schemeClr val="accent6"/>
                 </a:solidFill>
               </a:rPr>
-              <a:t>样本量、时间、年龄都交代清楚，图里的数字经得起复算。</a:t>
+              <a:t>报告的样本量、调查时间和年龄范围写得很清楚，图里的数字也能复算。</a:t>
             </a:r>
             <a:endParaRPr lang="en-US" sz="1600" dirty="0"/>
           </a:p>
@@ -5727,7 +5716,7 @@
                   <a:schemeClr val="accent3"/>
                 </a:solidFill>
               </a:rPr>
-              <a:t>留给大家</a:t>
+              <a:t>讨论</a:t>
             </a:r>
             <a:endParaRPr lang="en-US" sz="1600" dirty="0"/>
           </a:p>
@@ -5744,7 +5733,41 @@
                   <a:schemeClr val="tx2"/>
                 </a:solidFill>
               </a:rPr>
-              <a:t>要验证“找不到就退订”，调查该怎么设计？</a:t>
+              <a:t>要验证节目难找</a:t>
+            </a:r>
+            <a:endParaRPr lang="en-US" sz="1600" dirty="0"/>
+          </a:p>
+          <a:p>
+            <a:pPr indent="0" marL="0">
+              <a:spcAft>
+                <a:spcPts val="1400"/>
+              </a:spcAft>
+              <a:buNone/>
+            </a:pPr>
+            <a:r>
+              <a:rPr lang="en-US" sz="2200" b="1" dirty="0">
+                <a:solidFill>
+                  <a:schemeClr val="tx2"/>
+                </a:solidFill>
+              </a:rPr>
+              <a:t>会不会导致退订，</a:t>
+            </a:r>
+            <a:endParaRPr lang="en-US" sz="1600" dirty="0"/>
+          </a:p>
+          <a:p>
+            <a:pPr indent="0" marL="0">
+              <a:spcAft>
+                <a:spcPts val="1400"/>
+              </a:spcAft>
+              <a:buNone/>
+            </a:pPr>
+            <a:r>
+              <a:rPr lang="en-US" sz="2200" b="1" dirty="0">
+                <a:solidFill>
+                  <a:schemeClr val="tx2"/>
+                </a:solidFill>
+              </a:rPr>
+              <a:t>调查应该怎么设计？</a:t>
             </a:r>
             <a:endParaRPr lang="en-US" sz="1600" dirty="0"/>
           </a:p>
@@ -5888,7 +5911,7 @@
                   <a:schemeClr val="tx2"/>
                 </a:solidFill>
               </a:rPr>
-              <a:t>11 个来源里，报告自己的两份问卷最不透明</a:t>
+              <a:t>各数据来源的方法说明情况</a:t>
             </a:r>
             <a:endParaRPr lang="en-US" sz="3000" dirty="0"/>
           </a:p>
@@ -7377,7 +7400,7 @@
                   <a:schemeClr val="tx2"/>
                 </a:solidFill>
               </a:rPr>
-              <a:t>几处引用，和原始来源的说法并不一致</a:t>
+              <a:t>部分引用与原始来源不一致</a:t>
             </a:r>
             <a:endParaRPr lang="en-US" sz="3000" dirty="0"/>
           </a:p>
@@ -8455,7 +8478,7 @@
                   <a:schemeClr val="tx2"/>
                 </a:solidFill>
               </a:rPr>
-              <a:t>趋势大体可信，但结论推得太远</a:t>
+              <a:t>报告反映的趋势有参考价值，但不少结论超出了样本范围</a:t>
             </a:r>
             <a:endParaRPr lang="en-US" sz="3000" dirty="0"/>
           </a:p>
@@ -8863,7 +8886,7 @@
                   <a:schemeClr val="tx2"/>
                 </a:solidFill>
               </a:rPr>
-              <a:t>方法评价（重点）</a:t>
+              <a:t>方法评价</a:t>
             </a:r>
             <a:endParaRPr lang="en-US" sz="2000" dirty="0"/>
           </a:p>
@@ -9031,7 +9054,7 @@
                   <a:schemeClr val="accent4"/>
                 </a:solidFill>
               </a:rPr>
-              <a:t>我的判断</a:t>
+              <a:t>我的看法</a:t>
             </a:r>
             <a:endParaRPr lang="en-US" sz="1600" dirty="0"/>
           </a:p>
@@ -9043,12 +9066,12 @@
               <a:buNone/>
             </a:pPr>
             <a:r>
-              <a:rPr lang="en-US" sz="2400" b="1" dirty="0">
+              <a:rPr lang="en-US" sz="2200" b="1" dirty="0">
                 <a:solidFill>
                   <a:schemeClr val="bg1"/>
                 </a:solidFill>
               </a:rPr>
-              <a:t>报告看到的趋势大体可信；问题在于，它把一群 AI 用户的回答，推成了更大人群的结论。</a:t>
+              <a:t>这份报告说明了 AI 用户的一些变化，这部分可以参考；但它常把这群用户的回答，写成美国人整体的情况。</a:t>
             </a:r>
             <a:endParaRPr lang="en-US" sz="1600" dirty="0"/>
           </a:p>
@@ -9192,7 +9215,7 @@
                   <a:schemeClr val="tx2"/>
                 </a:solidFill>
               </a:rPr>
-              <a:t>节目越来越难找，AI 会不会成为新的入口？</a:t>
+              <a:t>报告关心人们怎样用 AI 找电视节目</a:t>
             </a:r>
             <a:endParaRPr lang="en-US" sz="3000" dirty="0"/>
           </a:p>
@@ -9291,7 +9314,7 @@
                   <a:schemeClr val="tx2"/>
                 </a:solidFill>
               </a:rPr>
-              <a:t>怎么用 AI</a:t>
+              <a:t>使用情况</a:t>
             </a:r>
             <a:endParaRPr lang="en-US" sz="2600" dirty="0"/>
           </a:p>
@@ -9327,7 +9350,7 @@
                   <a:schemeClr val="tx1"/>
                 </a:solidFill>
               </a:rPr>
-              <a:t>不同年龄的人，如何用 AI 找信息？</a:t>
+              <a:t>不同年龄的人用 AI 找信息的频率</a:t>
             </a:r>
             <a:endParaRPr lang="en-US" sz="1800" dirty="0"/>
           </a:p>
@@ -9426,7 +9449,7 @@
                   <a:schemeClr val="tx2"/>
                 </a:solidFill>
               </a:rPr>
-              <a:t>找不到会怎样</a:t>
+              <a:t>找节目的难度</a:t>
             </a:r>
             <a:endParaRPr lang="en-US" sz="2600" dirty="0"/>
           </a:p>
@@ -9462,7 +9485,7 @@
                   <a:schemeClr val="tx1"/>
                 </a:solidFill>
               </a:rPr>
-              <a:t>节目难找，会不会让人退订？</a:t>
+              <a:t>找节目要花多久，会不会因此退订</a:t>
             </a:r>
             <a:endParaRPr lang="en-US" sz="1800" dirty="0"/>
           </a:p>
@@ -9561,7 +9584,7 @@
                   <a:schemeClr val="tx2"/>
                 </a:solidFill>
               </a:rPr>
-              <a:t>信不信 AI</a:t>
+              <a:t>对 AI 的信任</a:t>
             </a:r>
             <a:endParaRPr lang="en-US" sz="2600" dirty="0"/>
           </a:p>
@@ -9597,7 +9620,7 @@
                   <a:schemeClr val="tx1"/>
                 </a:solidFill>
               </a:rPr>
-              <a:t>人们是否相信 AI 给的答案？</a:t>
+              <a:t>人们是否会核对 AI 给出的答案</a:t>
             </a:r>
             <a:endParaRPr lang="en-US" sz="1800" dirty="0"/>
           </a:p>
@@ -9671,7 +9694,7 @@
                   <a:schemeClr val="bg1"/>
                 </a:solidFill>
               </a:rPr>
-              <a:t>Gracenote 隶属尼尔森，本身就做节目数据；报告最后的建议，恰好落在它自己的业务上。</a:t>
+              <a:t>Gracenote 是尼尔森旗下的节目数据公司；报告建议平台接入行业数据，这也是它的业务。</a:t>
             </a:r>
             <a:endParaRPr lang="en-US" sz="1600" dirty="0"/>
           </a:p>
@@ -9815,7 +9838,7 @@
                   <a:schemeClr val="tx2"/>
                 </a:solidFill>
               </a:rPr>
-              <a:t>两份线上问卷，撑起了报告的大部分结论</a:t>
+              <a:t>报告的数据主要来自两份线上问卷</a:t>
             </a:r>
             <a:endParaRPr lang="en-US" sz="3000" dirty="0"/>
           </a:p>
@@ -10625,7 +10648,7 @@
                   <a:schemeClr val="tx1"/>
                 </a:solidFill>
               </a:rPr>
-              <a:t>样本如何抽取，两份调查都没有交代。另引用尼尔森、皮尤等共 11 个来源（见附录）。</a:t>
+              <a:t>两份调查都没有说明样本是怎么抽取的。报告还引用了尼尔森、皮尤等共 11 个来源（见附录）。</a:t>
             </a:r>
             <a:endParaRPr lang="en-US" sz="1800" dirty="0"/>
           </a:p>
@@ -10769,7 +10792,7 @@
                   <a:schemeClr val="tx2"/>
                 </a:solidFill>
               </a:rPr>
-              <a:t>年轻人越来越依赖 AI，却并不完全信任它</a:t>
+              <a:t>年轻用户常用 AI，但多数受访者会核对它的答案</a:t>
             </a:r>
             <a:endParaRPr lang="en-US" sz="3000" dirty="0"/>
           </a:p>
@@ -10885,7 +10908,7 @@
                   <a:schemeClr val="tx1"/>
                 </a:solidFill>
               </a:rPr>
-              <a:t>每天都用</a:t>
+              <a:t>每天使用</a:t>
             </a:r>
             <a:endParaRPr lang="en-US" sz="2000" dirty="0"/>
           </a:p>
@@ -10987,7 +11010,7 @@
                   <a:schemeClr val="tx1"/>
                 </a:solidFill>
               </a:rPr>
-              <a:t>受访者会回头</a:t>
+              <a:t>受访者会核对</a:t>
             </a:r>
             <a:endParaRPr lang="en-US" sz="2000" dirty="0"/>
           </a:p>
@@ -11001,7 +11024,7 @@
                   <a:schemeClr val="tx1"/>
                 </a:solidFill>
               </a:rPr>
-              <a:t>核对 AI 的答案</a:t>
+              <a:t>AI 的答案</a:t>
             </a:r>
             <a:endParaRPr lang="en-US" sz="2000" dirty="0"/>
           </a:p>
@@ -11100,7 +11123,7 @@
                   <a:schemeClr val="tx1"/>
                 </a:solidFill>
               </a:rPr>
-              <a:t>AI 能直接给出答案，还能接着追问</a:t>
+              <a:t>回答直接，可以继续追问</a:t>
             </a:r>
             <a:endParaRPr lang="en-US" sz="1800" dirty="0"/>
           </a:p>
@@ -11144,7 +11167,7 @@
       </p:sp>
       <p:sp>
         <p:nvSpPr>
-          <p:cNvPr id="14" name="标签：所以受欢迎"/>
+          <p:cNvPr id="14" name="标签：使用增加"/>
           <p:cNvSpPr/>
           <p:nvPr/>
         </p:nvSpPr>
@@ -11171,7 +11194,7 @@
       </p:sp>
       <p:sp>
         <p:nvSpPr>
-          <p:cNvPr id="15" name="标签文字：所以受欢迎"/>
+          <p:cNvPr id="15" name="标签文字：使用增加"/>
           <p:cNvSpPr txBox="1"/>
           <p:nvPr/>
         </p:nvSpPr>
@@ -11199,7 +11222,7 @@
                   <a:schemeClr val="bg1"/>
                 </a:solidFill>
               </a:rPr>
-              <a:t>所以受欢迎</a:t>
+              <a:t>使用增加</a:t>
             </a:r>
             <a:endParaRPr lang="en-US" sz="1700" dirty="0"/>
           </a:p>
@@ -11262,7 +11285,7 @@
                   <a:schemeClr val="tx1"/>
                 </a:solidFill>
               </a:rPr>
-              <a:t>但它也会给出看似合理的错误答案</a:t>
+              <a:t>有时会给出看似合理的错误信息</a:t>
             </a:r>
             <a:endParaRPr lang="en-US" sz="1800" dirty="0"/>
           </a:p>
@@ -11306,7 +11329,7 @@
       </p:sp>
       <p:sp>
         <p:nvSpPr>
-          <p:cNvPr id="19" name="标签：所以还要再核对"/>
+          <p:cNvPr id="19" name="标签：需要核对"/>
           <p:cNvSpPr/>
           <p:nvPr/>
         </p:nvSpPr>
@@ -11333,7 +11356,7 @@
       </p:sp>
       <p:sp>
         <p:nvSpPr>
-          <p:cNvPr id="20" name="标签文字：所以还要再核对"/>
+          <p:cNvPr id="20" name="标签文字：需要核对"/>
           <p:cNvSpPr txBox="1"/>
           <p:nvPr/>
         </p:nvSpPr>
@@ -11361,7 +11384,7 @@
                   <a:schemeClr val="bg1"/>
                 </a:solidFill>
               </a:rPr>
-              <a:t>所以还要再核对</a:t>
+              <a:t>需要核对</a:t>
             </a:r>
             <a:endParaRPr lang="en-US" sz="1700" dirty="0"/>
           </a:p>
@@ -11505,7 +11528,7 @@
                   <a:schemeClr val="tx2"/>
                 </a:solidFill>
               </a:rPr>
-              <a:t>从内容分散到用户流失，报告这样推理</a:t>
+              <a:t>报告认为，节目难找会让用户退订</a:t>
             </a:r>
             <a:endParaRPr lang="en-US" sz="3000" dirty="0"/>
           </a:p>
@@ -11828,7 +11851,7 @@
                   <a:schemeClr val="tx2"/>
                 </a:solidFill>
               </a:rPr>
-              <a:t>找起来费时</a:t>
+              <a:t>找节目费时</a:t>
             </a:r>
             <a:endParaRPr lang="en-US" sz="2100" dirty="0"/>
           </a:p>
@@ -12113,7 +12136,21 @@
                   <a:schemeClr val="tx1"/>
                 </a:solidFill>
               </a:rPr>
-              <a:t>18–34 岁说可能退订</a:t>
+              <a:t>18–34 岁表示</a:t>
+            </a:r>
+            <a:endParaRPr lang="en-US" sz="1600" dirty="0"/>
+          </a:p>
+          <a:p>
+            <a:pPr indent="0" marL="0">
+              <a:buNone/>
+            </a:pPr>
+            <a:r>
+              <a:rPr lang="en-US" sz="1600" dirty="0">
+                <a:solidFill>
+                  <a:schemeClr val="tx1"/>
+                </a:solidFill>
+              </a:rPr>
+              <a:t>可能退订</a:t>
             </a:r>
             <a:endParaRPr lang="en-US" sz="1600" dirty="0"/>
           </a:p>
@@ -12248,7 +12285,7 @@
                   <a:schemeClr val="bg1"/>
                 </a:solidFill>
               </a:rPr>
-              <a:t>接入可靠数据</a:t>
+              <a:t>接入行业数据</a:t>
             </a:r>
             <a:endParaRPr lang="en-US" sz="2100" dirty="0"/>
           </a:p>
@@ -12323,7 +12360,21 @@
                   <a:schemeClr val="accent6"/>
                 </a:solidFill>
               </a:rPr>
-              <a:t>AI 能答对的播出平台</a:t>
+              <a:t>AI 能答对的</a:t>
+            </a:r>
+            <a:endParaRPr lang="en-US" sz="1600" dirty="0"/>
+          </a:p>
+          <a:p>
+            <a:pPr indent="0" marL="0">
+              <a:buNone/>
+            </a:pPr>
+            <a:r>
+              <a:rPr lang="en-US" sz="1600" dirty="0">
+                <a:solidFill>
+                  <a:schemeClr val="accent6"/>
+                </a:solidFill>
+              </a:rPr>
+              <a:t>播出平台</a:t>
             </a:r>
             <a:endParaRPr lang="en-US" sz="1600" dirty="0"/>
           </a:p>
@@ -12503,7 +12554,7 @@
                   <a:schemeClr val="tx2"/>
                 </a:solidFill>
               </a:rPr>
-              <a:t>沿着这条推理，逐环看证据站不站得住</a:t>
+              <a:t>从四个方面检查每一步的证据</a:t>
             </a:r>
             <a:endParaRPr lang="en-US" sz="3000" dirty="0"/>
           </a:p>
@@ -12985,7 +13036,7 @@
                   <a:schemeClr val="bg1"/>
                 </a:solidFill>
               </a:rPr>
-              <a:t>③ 难找致退订</a:t>
+              <a:t>③ 难找导致退订</a:t>
             </a:r>
             <a:endParaRPr lang="en-US" sz="2000" dirty="0"/>
           </a:p>
@@ -13123,7 +13174,7 @@
                   <a:schemeClr val="accent1"/>
                 </a:solidFill>
               </a:rPr>
-              <a:t>研究总体</a:t>
+              <a:t>调查范围</a:t>
             </a:r>
             <a:endParaRPr lang="en-US" sz="2000" dirty="0"/>
           </a:p>
@@ -13203,7 +13254,7 @@
                   <a:schemeClr val="bg1"/>
                 </a:solidFill>
               </a:rPr>
-              <a:t>④ 接入可靠数据</a:t>
+              <a:t>④ 接入行业数据</a:t>
             </a:r>
             <a:endParaRPr lang="en-US" sz="2000" dirty="0"/>
           </a:p>
@@ -13363,23 +13414,12 @@
               <a:buNone/>
             </a:pPr>
             <a:r>
-              <a:rPr lang="en-US" sz="1800" b="1" dirty="0">
-                <a:solidFill>
-                  <a:schemeClr val="accent3"/>
-                </a:solidFill>
-              </a:rPr>
-              <a:t>为什么看这四处：</a:t>
-            </a:r>
-            <a:pPr indent="0" marL="0">
-              <a:buNone/>
-            </a:pPr>
-            <a:r>
               <a:rPr lang="en-US" sz="1800" dirty="0">
                 <a:solidFill>
                   <a:schemeClr val="tx1"/>
                 </a:solidFill>
               </a:rPr>
-              <a:t>同一个问题，问谁、问哪里的人、什么时候问、怎么问，得到的答案都可能不同。</a:t>
+              <a:t>调查结果会随调查对象、范围、时间和方法而变化，所以分别从这四个方面检查。</a:t>
             </a:r>
             <a:endParaRPr lang="en-US" sz="1800" dirty="0"/>
           </a:p>
@@ -13523,7 +13563,7 @@
                   <a:schemeClr val="tx2"/>
                 </a:solidFill>
               </a:rPr>
-              <a:t>问的是 AI 用户，说的却是“美国人”</a:t>
+              <a:t>样本都是 AI 用户，不能直接代表美国人</a:t>
             </a:r>
             <a:endParaRPr lang="en-US" sz="3000" dirty="0"/>
           </a:p>
@@ -13924,7 +13964,7 @@
                   <a:schemeClr val="tx1"/>
                 </a:solidFill>
               </a:rPr>
-              <a:t>全是 AI 聊天机器人用户</a:t>
+              <a:t>都是 AI 聊天机器人用户</a:t>
             </a:r>
             <a:endParaRPr lang="en-US" sz="1800" dirty="0"/>
           </a:p>
@@ -14050,7 +14090,7 @@
                   <a:schemeClr val="tx1"/>
                 </a:solidFill>
               </a:rPr>
-              <a:t>按“用不用 AI”筛选，</a:t>
+              <a:t>调查只问了用 AI 的人，</a:t>
             </a:r>
             <a:endParaRPr lang="en-US" sz="1800" dirty="0"/>
           </a:p>
@@ -14064,7 +14104,7 @@
                   <a:schemeClr val="tx1"/>
                 </a:solidFill>
               </a:rPr>
-              <a:t>样本偏向会用的人</a:t>
+              <a:t>没有包括不用的人</a:t>
             </a:r>
             <a:endParaRPr lang="en-US" sz="1800" dirty="0"/>
           </a:p>
@@ -14190,7 +14230,7 @@
                   <a:schemeClr val="tx1"/>
                 </a:solidFill>
               </a:rPr>
-              <a:t>网络样本不等于总体，</a:t>
+              <a:t>线上样本和总体构成不同，</a:t>
             </a:r>
             <a:endParaRPr lang="en-US" sz="1800" dirty="0"/>
           </a:p>
@@ -14204,7 +14244,7 @@
                   <a:schemeClr val="tx1"/>
                 </a:solidFill>
               </a:rPr>
-              <a:t>结论只适用于 AI 用户</a:t>
+              <a:t>比例只能代表 AI 用户</a:t>
             </a:r>
             <a:endParaRPr lang="en-US" sz="1800" dirty="0"/>
           </a:p>
@@ -14346,7 +14386,7 @@
                   <a:schemeClr val="accent3"/>
                 </a:solidFill>
               </a:rPr>
-              <a:t>04  方法评价 · 研究总体</a:t>
+              <a:t>04  方法评价 · 调查范围</a:t>
             </a:r>
             <a:endParaRPr lang="en-US" sz="1400" dirty="0"/>
           </a:p>
@@ -14384,7 +14424,7 @@
                   <a:schemeClr val="tx2"/>
                 </a:solidFill>
               </a:rPr>
-              <a:t>“14 分钟”其实是六国平均，美国是 12 分钟</a:t>
+              <a:t>“14 分钟”是六国平均值，美国是 12 分钟</a:t>
             </a:r>
             <a:endParaRPr lang="en-US" sz="3000" dirty="0"/>
           </a:p>
@@ -14526,7 +14566,7 @@
                   <a:schemeClr val="tx1"/>
                 </a:solidFill>
               </a:rPr>
-              <a:t>图里的“14 分钟”，</a:t>
+              <a:t>报告把六国平均值</a:t>
             </a:r>
             <a:endParaRPr lang="en-US" sz="1800" dirty="0"/>
           </a:p>
@@ -14540,7 +14580,7 @@
                   <a:schemeClr val="tx1"/>
                 </a:solidFill>
               </a:rPr>
-              <a:t>是六个国家的平均</a:t>
+              <a:t>放在了美国收视的图里</a:t>
             </a:r>
             <a:endParaRPr lang="en-US" sz="1800" dirty="0"/>
           </a:p>
@@ -14666,7 +14706,7 @@
                   <a:schemeClr val="tx1"/>
                 </a:solidFill>
               </a:rPr>
-              <a:t>六国直接平均，</a:t>
+              <a:t>六国按同等权重平均，</a:t>
             </a:r>
             <a:endParaRPr lang="en-US" sz="1800" dirty="0"/>
           </a:p>
@@ -14680,7 +14720,7 @@
                   <a:schemeClr val="tx1"/>
                 </a:solidFill>
               </a:rPr>
-              <a:t>法国的 26 分钟拉高了它</a:t>
+              <a:t>法国的 26 分钟抬高了均值</a:t>
             </a:r>
             <a:endParaRPr lang="en-US" sz="1800" dirty="0"/>
           </a:p>
@@ -14806,7 +14846,7 @@
                   <a:schemeClr val="tx1"/>
                 </a:solidFill>
               </a:rPr>
-              <a:t>放进美国收视图里，</a:t>
+              <a:t>读者容易以为</a:t>
             </a:r>
             <a:endParaRPr lang="en-US" sz="1800" dirty="0"/>
           </a:p>
@@ -14820,7 +14860,7 @@
                   <a:schemeClr val="tx1"/>
                 </a:solidFill>
               </a:rPr>
-              <a:t>容易高估美国的困难</a:t>
+              <a:t>美国人也要找 14 分钟</a:t>
             </a:r>
             <a:endParaRPr lang="en-US" sz="1800" dirty="0"/>
           </a:p>

</xml_diff>